<commit_message>
docs(deck): the blocked card now names the real constraint — no server routes on Pages
</commit_message>
<xml_diff>
--- a/BROKE VEGAS/BROKE VEGAS.pptx
+++ b/BROKE VEGAS/BROKE VEGAS.pptx
@@ -717,7 +717,7 @@
             </c:numRef>
           </c:val>
         </c:ser>
-        <c:marker/>
+        <c:marker val="1"/>
         <c:axId val="89736801"/>
         <c:axId val="89736802"/>
       </c:lineChart>
@@ -858,7 +858,7 @@
   <p:cSld>
     <p:spTree>
       <p:nvGrpSpPr>
-        <p:cNvPr id="1" name="" descr="&lt;Slide style={{ width: 1280, height: 720, background: '#07060B', padding: '54px 72px', position: 'relative', overflow: 'hidden', display: 'flex', flexDirection: 'column' }}&gt;&#13;&#10;    &lt;Image src=&quot;assets/01-landing-hero.png&quot; style={{ position: 'absolute', top: 0, left: 0, width: 1280, height: 720, objectFit: 'cover', opacity: 0.9 }} /&gt;&#13;&#10;    &lt;Box style={{ position: 'absolute', top: 0, left: 0, width: 860, height: 720, background: 'linear-gradient(90deg, #07060B 42%, rgba(7,6,11,0.82) 68%, rgba(7,6,11,0) 100%)' }} /&gt;&#13;&#10;    &lt;Box style={{ position: 'absolute', top: 0, left: 0, width: 520, height: 720, background: 'radial-gradient(circle at 12% 62%, rgba(231,53,85,0.16) 0%, rgba(7,6,11,0) 62%)' }} /&gt;&#13;&#10;&#13;&#10;    &lt;Box style={{ position: 'relative', zIndex: 1, display: 'flex', flexDirection: 'column', justifyContent: 'space-between', height: '100%' }}&gt;&#13;&#10;        &lt;Box style={{ flexDirection: 'row', alignItems: 'center', gap: 14 }}&gt;&#13;&#10;            &lt;Box style={{ width: 9, height: 9, background: '#F2C96D', borderRadius: 9 }} /&gt;&#13;&#10;            &lt;Text style={{ fontSize: 13, fontWeight: 'bold', color: '#F2C96D', letterSpacing: 2.6 }}&gt;A MULTIPLAYER TRADING ARENA · VIRTUAL MONEY ONLY&lt;/Text&gt;&#13;&#10;        &lt;/Box&gt;&#13;&#10;&#13;&#10;        &lt;Box style={{ display: 'flex', flexDirection: 'column', gap: 18 }}&gt;&#13;&#10;            &lt;Text style={{ fontSize: 72, fontFamily: 'Impact', fontWeight: 'bold', color: '#F7F1E8', lineHeight: 0.98, letterSpacing: 1 }}&gt;THE MARKET IS&lt;br /&gt;A CASINO.&lt;/Text&gt;&#13;&#10;            &lt;Text style={{ fontSize: 34, fontWeight: 'bold', color: '#E73555', lineHeight: 1.15 }}&gt;At least here, you know it.&lt;/Text&gt;&#13;&#10;            &lt;Text style={{ fontSize: 19, color: 'rgba(247,241,232,0.78)', lineHeight: 1.55, width: 560 }}&gt;Six fictional tickers. Three seats. ₹1,00,000 of money that has never existed. Trade the chaos, outsmart your friends, and try not to go broke.&lt;/Text&gt;&#13;&#10;        &lt;/Box&gt;&#13;&#10;&#13;&#10;        &lt;Box style={{ display: 'flex', flexDirection: 'column', gap: 16 }}&gt;&#13;&#10;            &lt;Box style={{ width: 520, height: 1, background: 'rgba(247,241,232,0.22)' }} /&gt;&#13;&#10;            &lt;Box style={{ flexDirection: 'row', gap: 56 }}&gt;&#13;&#10;                &lt;Box style={{ display: 'flex', flexDirection: 'column', gap: 4 }}&gt;&#13;&#10;                    &lt;Text style={{ fontSize: 12, color: 'rgba(247,241,232,0.5)', letterSpacing: 2 }}&gt;LIVE INDEX&lt;/Text&gt;&#13;&#10;                    &lt;Text style={{ fontSize: 26, fontWeight: 'bold', color: '#F7F1E8' }}&gt;99.95&lt;/Text&gt;&#13;&#10;                &lt;/Box&gt;&#13;&#10;                &lt;Box style={{ display: 'flex', flexDirection: 'column', gap: 4 }}&gt;&#13;&#10;                    &lt;Text style={{ fontSize: 12, color: 'rgba(247,241,232,0.5)', letterSpacing: 2 }}&gt;ENGINE TICK&lt;/Text&gt;&#13;&#10;                    &lt;Text style={{ fontSize: 26, fontWeight: 'bold', color: '#F7F1E8' }}&gt;12&lt;/Text&gt;&#13;&#10;                &lt;/Box&gt;&#13;&#10;                &lt;Box style={{ display: 'flex', flexDirection: 'column', gap: 4 }}&gt;&#13;&#10;                    &lt;Text style={{ fontSize: 12, color: 'rgba(247,241,232,0.5)', letterSpacing: 2 }}&gt;STAKES&lt;/Text&gt;&#13;&#10;                    &lt;Text style={{ fontSize: 26, fontWeight: 'bold', color: '#F7F1E8' }}&gt;₹1,00,000&lt;/Text&gt;&#13;&#10;                &lt;/Box&gt;&#13;&#10;                &lt;Box style={{ display: 'flex', flexDirection: 'column', gap: 4 }}&gt;&#13;&#10;                    &lt;Text style={{ fontSize: 12, color: 'rgba(247,241,232,0.5)', letterSpacing: 2 }}&gt;STATUS&lt;/Text&gt;&#13;&#10;                    &lt;Text style={{ fontSize: 26, fontWeight: 'bold', color: '#E73555' }}&gt;LIVE&lt;/Text&gt;&#13;&#10;                &lt;/Box&gt;&#13;&#10;            &lt;/Box&gt;&#13;&#10;        &lt;/Box&gt;&#13;&#10;    &lt;/Box&gt;&#13;&#10;&lt;/Slide&gt;&#13;&#10;"/>
+        <p:cNvPr id="1" name=""/>
         <p:cNvGrpSpPr/>
         <p:nvPr/>
       </p:nvGrpSpPr>
@@ -891,7 +891,10 @@
         </p:spPr>
         <p:txBody>
           <a:bodyPr/>
-          <a:p/>
+          <a:p>
+            <a:pPr/>
+            <a:endParaRPr/>
+          </a:p>
         </p:txBody>
       </p:sp>
       <p:pic>
@@ -958,7 +961,10 @@
         </p:spPr>
         <p:txBody>
           <a:bodyPr/>
-          <a:p/>
+          <a:p>
+            <a:pPr/>
+            <a:endParaRPr/>
+          </a:p>
         </p:txBody>
       </p:sp>
       <p:sp>
@@ -996,7 +1002,10 @@
         </p:spPr>
         <p:txBody>
           <a:bodyPr/>
-          <a:p/>
+          <a:p>
+            <a:pPr/>
+            <a:endParaRPr/>
+          </a:p>
         </p:txBody>
       </p:sp>
       <p:sp>
@@ -1022,7 +1031,10 @@
         </p:spPr>
         <p:txBody>
           <a:bodyPr/>
-          <a:p/>
+          <a:p>
+            <a:pPr/>
+            <a:endParaRPr/>
+          </a:p>
         </p:txBody>
       </p:sp>
       <p:sp>
@@ -1212,7 +1224,10 @@
         </p:spPr>
         <p:txBody>
           <a:bodyPr/>
-          <a:p/>
+          <a:p>
+            <a:pPr/>
+            <a:endParaRPr/>
+          </a:p>
         </p:txBody>
       </p:sp>
       <p:sp>
@@ -1513,7 +1528,7 @@
   <p:cSld>
     <p:spTree>
       <p:nvGrpSpPr>
-        <p:cNvPr id="20" name="" descr="&lt;Slide style={{ width: 1280, height: 720, background: '#07060B', padding: '20px 72px', display: 'flex', flexDirection: 'column' }}&gt;&#13;&#10;    &lt;Box style={{ height: 100, flexDirection: 'row', justifyContent: 'space-between', alignItems: 'flex-start' }}&gt;&#13;&#10;        &lt;Box style={{ display: 'flex', flexDirection: 'column', gap: 8 }}&gt;&#13;&#10;            &lt;Text style={{ fontSize: 12, fontWeight: 'bold', color: '#F2C96D', letterSpacing: 2.4 }}&gt;ARCHITECTURE&lt;/Text&gt;&#13;&#10;            &lt;Text style={{ fontSize: 38, fontFamily: 'Impact', color: '#F7F1E8', lineHeight: 1.1 }}&gt;Four layers, one job each.&lt;/Text&gt;&#13;&#10;        &lt;/Box&gt;&#13;&#10;        &lt;Text style={{ fontSize: 13, color: 'rgba(247,241,232,0.5)', letterSpacing: 1.6, paddingTop: 6 }}&gt;THE SEAM IS THE POINT&lt;/Text&gt;&#13;&#10;    &lt;/Box&gt;&#13;&#10;&#13;&#10;    &lt;Box style={{ height: 480, marginTop: 20, display: 'flex', flexDirection: 'column', justifyContent: 'space-between' }}&gt;&#13;&#10;        &lt;Box style={{ width: 1040, height: 96, flexDirection: 'row', alignItems: 'center', justifyContent: 'space-between', padding: '0 26px', background: 'rgba(247,241,232,0.055)', border: '1px solid rgba(247,241,232,0.12)', borderRadius: 8 }}&gt;&#13;&#10;            &lt;Box style={{ display: 'flex', flexDirection: 'column', gap: 6 }}&gt;&#13;&#10;                &lt;Text style={{ fontSize: 11, fontWeight: 'bold', color: '#F2C96D', letterSpacing: 2.2 }}&gt;01 · INTERFACE&lt;/Text&gt;&#13;&#10;                &lt;Text style={{ fontSize: 22, fontWeight: 'bold', color: '#F7F1E8' }}&gt;Next.js App Router · terminal, lobby, results, replay&lt;/Text&gt;&#13;&#10;            &lt;/Box&gt;&#13;&#10;            &lt;Text style={{ fontSize: 14, color: 'rgba(247,241,232,0.55)', width: 240, textAlign: 'right' }}&gt;Server shell, client state. No data fetching in the terminal loop.&lt;/Text&gt;&#13;&#10;        &lt;/Box&gt;&#13;&#10;&#13;&#10;        &lt;Box style={{ width: 960, height: 96, marginLeft: 40, flexDirection: 'row', alignItems: 'center', justifyContent: 'space-between', padding: '0 26px', background: 'rgba(247,241,232,0.055)', border: '1px solid rgba(247,241,232,0.12)', borderRadius: 8 }}&gt;&#13;&#10;            &lt;Box style={{ display: 'flex', flexDirection: 'column', gap: 6 }}&gt;&#13;&#10;                &lt;Text style={{ fontSize: 11, fontWeight: 'bold', color: '#F2C96D', letterSpacing: 2.2 }}&gt;02 · GATEWAY&lt;/Text&gt;&#13;&#10;                &lt;Text style={{ fontSize: 22, fontWeight: 'bold', color: '#F7F1E8' }}&gt;Web Worker · one interface, two implementations&lt;/Text&gt;&#13;&#10;            &lt;/Box&gt;&#13;&#10;            &lt;Text style={{ fontSize: 14, color: 'rgba(247,241,232,0.55)', width: 230, textAlign: 'right' }}&gt;Demo Mode runs the engine in the browser, off the main thread.&lt;/Text&gt;&#13;&#10;        &lt;/Box&gt;&#13;&#10;&#13;&#10;        &lt;Box style={{ width: 880, height: 96, marginLeft: 80, flexDirection: 'row', alignItems: 'center', justifyContent: 'space-between', padding: '0 26px', background: 'rgba(231,53,85,0.10)', border: '1px solid rgba(231,53,85,0.32)', borderRadius: 8 }}&gt;&#13;&#10;            &lt;Box style={{ display: 'flex', flexDirection: 'column', gap: 6 }}&gt;&#13;&#10;                &lt;Text style={{ fontSize: 11, fontWeight: 'bold', color: '#E73555', letterSpacing: 2.2 }}&gt;03 · ENGINE&lt;/Text&gt;&#13;&#10;                &lt;Text style={{ fontSize: 22, fontWeight: 'bold', color: '#F7F1E8' }}&gt;Pure TypeScript · zero runtime dependencies&lt;/Text&gt;&#13;&#10;            &lt;/Box&gt;&#13;&#10;            &lt;Text style={{ fontSize: 14, color: 'rgba(247,241,232,0.6)', width: 210, textAlign: 'right' }}&gt;Prices, matching, accounting, replay. Synchronous and testable.&lt;/Text&gt;&#13;&#10;        &lt;/Box&gt;&#13;&#10;&#13;&#10;        &lt;Box style={{ width: 800, height: 96, marginLeft: 120, flexDirection: 'row', alignItems: 'center', justifyContent: 'space-between', padding: '0 26px', background: 'rgba(247,241,232,0.055)', border: '1px solid rgba(247,241,232,0.12)', borderRadius: 8 }}&gt;&#13;&#10;            &lt;Box style={{ display: 'flex', flexDirection: 'column', gap: 6 }}&gt;&#13;&#10;                &lt;Text style={{ fontSize: 11, fontWeight: 'bold', color: '#F2C96D', letterSpacing: 2.2 }}&gt;04 · DATA&lt;/Text&gt;&#13;&#10;                &lt;Text style={{ fontSize: 22, fontWeight: 'bold', color: '#F7F1E8' }}&gt;Supabase Postgres · 15 tables, RLS everywhere&lt;/Text&gt;&#13;&#10;            &lt;/Box&gt;&#13;&#10;            &lt;Text style={{ fontSize: 14, color: 'rgba(247,241,232,0.55)', width: 190, textAlign: 'right' }}&gt;Match secrets have no policy: service role only.&lt;/Text&gt;&#13;&#10;        &lt;/Box&gt;&#13;&#10;&#13;&#10;        &lt;Box style={{ flexDirection: 'row', justifyContent: 'space-between', alignItems: 'center', paddingTop: 10, borderTop: '1px solid rgba(247,241,232,0.10)' }}&gt;&#13;&#10;            &lt;Text style={{ fontSize: 11, fontWeight: 'bold', color: '#F2C96D', letterSpacing: 2.2 }}&gt;LOCKED VERSIONS&lt;/Text&gt;&#13;&#10;            &lt;Text style={{ fontSize: 12, fontFamily: 'Consolas', color: 'rgba(247,241,232,0.62)' }}&gt;next 16.4.3 · react 19.3 · typescript 5 · tailwind 4 · three 0.186 · zustand 5 · vitest 5 · playwright 1.64&lt;/Text&gt;&#13;&#10;        &lt;/Box&gt;&#13;&#10;    &lt;/Box&gt;&#13;&#10;&#13;&#10;    &lt;Box style={{ height: 60, marginTop: 20, flexDirection: 'row', justifyContent: 'space-between', alignItems: 'flex-end', borderTop: '1px solid rgba(247,241,232,0.10)', paddingTop: 12 }}&gt;&#13;&#10;        &lt;Text style={{ fontSize: 13, color: 'rgba(247,241,232,0.45)' }}&gt;BROKE VEGAS · fictional markets, virtual money&lt;/Text&gt;&#13;&#10;        &lt;Text style={{ fontSize: 13, color: 'rgba(247,241,232,0.45)' }}&gt;10 / 12&lt;/Text&gt;&#13;&#10;    &lt;/Box&gt;&#13;&#10;&lt;/Slide&gt;&#13;&#10;"/>
+        <p:cNvPr id="20" name=""/>
         <p:cNvGrpSpPr/>
         <p:nvPr/>
       </p:nvGrpSpPr>
@@ -1546,7 +1561,10 @@
         </p:spPr>
         <p:txBody>
           <a:bodyPr/>
-          <a:p/>
+          <a:p>
+            <a:pPr/>
+            <a:endParaRPr/>
+          </a:p>
         </p:txBody>
       </p:sp>
       <p:sp>
@@ -1688,7 +1706,10 @@
         </p:spPr>
         <p:txBody>
           <a:bodyPr/>
-          <a:p/>
+          <a:p>
+            <a:pPr/>
+            <a:endParaRPr/>
+          </a:p>
         </p:txBody>
       </p:sp>
       <p:sp>
@@ -1832,7 +1853,10 @@
         </p:spPr>
         <p:txBody>
           <a:bodyPr/>
-          <a:p/>
+          <a:p>
+            <a:pPr/>
+            <a:endParaRPr/>
+          </a:p>
         </p:txBody>
       </p:sp>
       <p:sp>
@@ -1976,7 +2000,10 @@
         </p:spPr>
         <p:txBody>
           <a:bodyPr/>
-          <a:p/>
+          <a:p>
+            <a:pPr/>
+            <a:endParaRPr/>
+          </a:p>
         </p:txBody>
       </p:sp>
       <p:sp>
@@ -2120,7 +2147,10 @@
         </p:spPr>
         <p:txBody>
           <a:bodyPr/>
-          <a:p/>
+          <a:p>
+            <a:pPr/>
+            <a:endParaRPr/>
+          </a:p>
         </p:txBody>
       </p:sp>
       <p:sp>
@@ -2271,7 +2301,10 @@
         </p:spPr>
         <p:txBody>
           <a:bodyPr/>
-          <a:p/>
+          <a:p>
+            <a:pPr/>
+            <a:endParaRPr/>
+          </a:p>
         </p:txBody>
       </p:sp>
       <p:sp>
@@ -2385,7 +2418,10 @@
         </p:spPr>
         <p:txBody>
           <a:bodyPr/>
-          <a:p/>
+          <a:p>
+            <a:pPr/>
+            <a:endParaRPr/>
+          </a:p>
         </p:txBody>
       </p:sp>
       <p:sp>
@@ -2472,7 +2508,7 @@
   <p:cSld>
     <p:spTree>
       <p:nvGrpSpPr>
-        <p:cNvPr id="47" name="" descr="&lt;Slide style={{ width: 1280, height: 720, background: '#07060B', padding: '20px 72px', display: 'flex', flexDirection: 'column' }}&gt;&#13;&#10;    &lt;Box style={{ height: 100, flexDirection: 'row', justifyContent: 'space-between', alignItems: 'flex-start' }}&gt;&#13;&#10;        &lt;Box style={{ display: 'flex', flexDirection: 'column', gap: 8 }}&gt;&#13;&#10;            &lt;Text style={{ fontSize: 12, fontWeight: 'bold', color: '#F2C96D', letterSpacing: 2.4 }}&gt;SHIPPING STATUS&lt;/Text&gt;&#13;&#10;            &lt;Text style={{ fontSize: 38, fontFamily: 'Impact', color: '#F7F1E8', lineHeight: 1.1 }}&gt;What is real, and what is not yet.&lt;/Text&gt;&#13;&#10;        &lt;/Box&gt;&#13;&#10;        &lt;Text style={{ fontSize: 13, color: 'rgba(247,241,232,0.5)', letterSpacing: 1.6, paddingTop: 6 }}&gt;NO INVENTED INTEGRATIONS&lt;/Text&gt;&#13;&#10;    &lt;/Box&gt;&#13;&#10;&#13;&#10;    &lt;Box style={{ height: 480, marginTop: 20, flexDirection: 'row', gap: 24 }}&gt;&#13;&#10;        &lt;Box style={{ width: 424, display: 'flex', flexDirection: 'column', gap: 14, padding: '20px 22px', background: 'rgba(247,241,232,0.06)', borderTop: '3px solid #F2C96D', border: '1px solid rgba(247,241,232,0.14)', borderRadius: 8 }}&gt;&#13;&#10;            &lt;Text style={{ fontSize: 12, fontWeight: 'bold', color: '#F2C96D', letterSpacing: 2.2 }}&gt;LIVE NOW&lt;/Text&gt;&#13;&#10;            &lt;Text style={{ fontSize: 20, fontWeight: 'bold', color: '#F7F1E8', lineHeight: 1.35 }}&gt;The whole game, playable in a browser&lt;/Text&gt;&#13;&#10;            &lt;Text style={{ fontSize: 15, color: 'rgba(247,241,232,0.72)', lineHeight: 1.55 }}&gt;Create a table, ready up, trade against two engine bots, fire the meltdown, end the match, then open the verified replay. Every screen in this deck was captured from that deployment.&lt;/Text&gt;&#13;&#10;            &lt;Box style={{ marginTop: 'auto', display: 'flex', flexDirection: 'column', gap: 6 }}&gt;&#13;&#10;                &lt;Text style={{ fontSize: 13, color: 'rgba(247,241,232,0.55)', letterSpacing: 1.2 }}&gt;vedinzen.github.io/broke-vegas&lt;/Text&gt;&#13;&#10;                &lt;Text style={{ fontSize: 13, color: 'rgba(247,241,232,0.55)', letterSpacing: 1.2 }}&gt;Typecheck clean · lint clean · 12 tests green&lt;/Text&gt;&#13;&#10;            &lt;/Box&gt;&#13;&#10;        &lt;/Box&gt;&#13;&#10;&#13;&#10;        &lt;Box style={{ width: 366, display: 'flex', flexDirection: 'column', gap: 14, padding: '20px 22px', background: 'rgba(247,241,232,0.035)', border: '1px solid rgba(247,241,232,0.12)', borderRadius: 8 }}&gt;&#13;&#10;            &lt;Text style={{ fontSize: 12, fontWeight: 'bold', color: 'rgba(247,241,232,0.62)', letterSpacing: 2.2 }}&gt;APPLIED, NOT WIRED&lt;/Text&gt;&#13;&#10;            &lt;Text style={{ fontSize: 20, fontWeight: 'bold', color: '#F7F1E8', lineHeight: 1.35 }}&gt;The multiplayer schema&lt;/Text&gt;&#13;&#10;            &lt;Text style={{ fontSize: 15, color: 'rgba(247,241,232,0.72)', lineHeight: 1.55 }}&gt;Two migrations are applied to a real Supabase project: 15 tables, row-level security on every public one, private membership helpers, and hardened RPCs for room creation and match start.&lt;/Text&gt;&#13;&#10;            &lt;Box style={{ marginTop: 'auto', display: 'flex', flexDirection: 'column', gap: 6 }}&gt;&#13;&#10;                &lt;Text style={{ fontSize: 13, color: 'rgba(247,241,232,0.55)', letterSpacing: 1.2 }}&gt;Live order writes need a service-role key&lt;/Text&gt;&#13;&#10;                &lt;Text style={{ fontSize: 13, color: 'rgba(247,241,232,0.55)', letterSpacing: 1.2 }}&gt;Anonymous auth is disabled on the project&lt;/Text&gt;&#13;&#10;            &lt;/Box&gt;&#13;&#10;        &lt;/Box&gt;&#13;&#10;&#13;&#10;        &lt;Box style={{ width: 298, display: 'flex', flexDirection: 'column', gap: 14, padding: '20px 22px', background: 'rgba(231,53,85,0.10)', border: '1px solid rgba(231,53,85,0.34)', borderRadius: 8 }}&gt;&#13;&#10;            &lt;Text style={{ fontSize: 12, fontWeight: 'bold', color: '#E73555', letterSpacing: 2.2 }}&gt;BLOCKED&lt;/Text&gt;&#13;&#10;            &lt;Text style={{ fontSize: 20, fontWeight: 'bold', color: '#F7F1E8', lineHeight: 1.35 }}&gt;Publishing the repository&lt;/Text&gt;&#13;&#10;            &lt;Text style={{ fontSize: 15, color: 'rgba(247,241,232,0.75)', lineHeight: 1.55 }}&gt;Creating a GitHub repo returns HTTP 403. The connector token has no repository-creation scope, so the work is committed locally and not pushed.&lt;/Text&gt;&#13;&#10;            &lt;Box style={{ marginTop: 'auto', display: 'flex', flexDirection: 'column', gap: 6 }}&gt;&#13;&#10;                &lt;Text style={{ fontSize: 12, color: '#E73555', letterSpacing: 0.4, lineHeight: 1.5 }}&gt;POST /user/repos → 403&lt;/Text&gt;&#13;&#10;                &lt;Text style={{ fontSize: 12, color: 'rgba(247,241,232,0.6)', letterSpacing: 0.4, lineHeight: 1.5 }}&gt;&quot;Resource not accessible by integration&quot;&lt;/Text&gt;&#13;&#10;            &lt;/Box&gt;&#13;&#10;        &lt;/Box&gt;&#13;&#10;    &lt;/Box&gt;&#13;&#10;&#13;&#10;    &lt;Box style={{ height: 60, marginTop: 20, flexDirection: 'row', justifyContent: 'space-between', alignItems: 'flex-end', borderTop: '1px solid rgba(247,241,232,0.10)', paddingTop: 12 }}&gt;&#13;&#10;        &lt;Text style={{ fontSize: 13, color: 'rgba(247,241,232,0.45)' }}&gt;BROKE VEGAS · fictional markets, virtual money&lt;/Text&gt;&#13;&#10;        &lt;Text style={{ fontSize: 13, color: 'rgba(247,241,232,0.45)' }}&gt;11 / 12&lt;/Text&gt;&#13;&#10;    &lt;/Box&gt;&#13;&#10;&lt;/Slide&gt;&#13;&#10;"/>
+        <p:cNvPr id="47" name="" descr="&lt;Slide style={{ width: 1280, height: 720, background: '#07060B', padding: '20px 72px', display: 'flex', flexDirection: 'column' }}&gt;&#10;    &lt;Box style={{ height: 100, flexDirection: 'row', justifyContent: 'space-between', alignItems: 'flex-start' }}&gt;&#10;        &lt;Box style={{ display: 'flex', flexDirection: 'column', gap: 8 }}&gt;&#10;            &lt;Text style={{ fontSize: 12, fontWeight: 'bold', color: '#F2C96D', letterSpacing: 2.4 }}&gt;SHIPPING STATUS&lt;/Text&gt;&#10;            &lt;Text style={{ fontSize: 38, fontFamily: 'Impact', color: '#F7F1E8', lineHeight: 1.1 }}&gt;What is real, and what is not yet.&lt;/Text&gt;&#10;        &lt;/Box&gt;&#10;        &lt;Text style={{ fontSize: 13, color: 'rgba(247,241,232,0.5)', letterSpacing: 1.6, paddingTop: 6 }}&gt;NO INVENTED INTEGRATIONS&lt;/Text&gt;&#10;    &lt;/Box&gt;&#10;&#10;    &lt;Box style={{ height: 480, marginTop: 20, flexDirection: 'row', gap: 24 }}&gt;&#10;        &lt;Box style={{ width: 424, display: 'flex', flexDirection: 'column', gap: 14, padding: '20px 22px', background: 'rgba(247,241,232,0.06)', borderTop: '3px solid #F2C96D', border: '1px solid rgba(247,241,232,0.14)', borderRadius: 8 }}&gt;&#10;            &lt;Text style={{ fontSize: 12, fontWeight: 'bold', color: '#F2C96D', letterSpacing: 2.2 }}&gt;LIVE NOW&lt;/Text&gt;&#10;            &lt;Text style={{ fontSize: 20, fontWeight: 'bold', color: '#F7F1E8', lineHeight: 1.35 }}&gt;The whole game, playable in a browser&lt;/Text&gt;&#10;            &lt;Text style={{ fontSize: 15, color: 'rgba(247,241,232,0.72)', lineHeight: 1.55 }}&gt;Create a table, ready up, trade against two engine bots, fire the meltdown, end the match, then open the verified replay. Every screen in this deck was captured from that deployment.&lt;/Text&gt;&#10;            &lt;Box style={{ marginTop: 'auto', display: 'flex', flexDirection: 'column', gap: 6 }}&gt;&#10;                &lt;Text style={{ fontSize: 13, color: 'rgba(247,241,232,0.55)', letterSpacing: 1.2 }}&gt;vedinzen.github.io/broke-vegas&lt;/Text&gt;&#10;                &lt;Text style={{ fontSize: 13, color: 'rgba(247,241,232,0.55)', letterSpacing: 1.2 }}&gt;Typecheck clean · lint clean · 12 tests green&lt;/Text&gt;&#10;            &lt;/Box&gt;&#10;        &lt;/Box&gt;&#10;&#10;        &lt;Box style={{ width: 366, display: 'flex', flexDirection: 'column', gap: 14, padding: '20px 22px', background: 'rgba(247,241,232,0.035)', border: '1px solid rgba(247,241,232,0.12)', borderRadius: 8 }}&gt;&#10;            &lt;Text style={{ fontSize: 12, fontWeight: 'bold', color: 'rgba(247,241,232,0.62)', letterSpacing: 2.2 }}&gt;APPLIED, NOT WIRED&lt;/Text&gt;&#10;            &lt;Text style={{ fontSize: 20, fontWeight: 'bold', color: '#F7F1E8', lineHeight: 1.35 }}&gt;The multiplayer schema&lt;/Text&gt;&#10;            &lt;Text style={{ fontSize: 15, color: 'rgba(247,241,232,0.72)', lineHeight: 1.55 }}&gt;Two migrations are applied to a real Supabase project: 15 tables, row-level security on every public one, private membership helpers, and hardened RPCs for room creation and match start.&lt;/Text&gt;&#10;            &lt;Box style={{ marginTop: 'auto', display: 'flex', flexDirection: 'column', gap: 6 }}&gt;&#10;                &lt;Text style={{ fontSize: 13, color: 'rgba(247,241,232,0.55)', letterSpacing: 1.2 }}&gt;Live order writes need a service-role key&lt;/Text&gt;&#10;                &lt;Text style={{ fontSize: 13, color: 'rgba(247,241,232,0.55)', letterSpacing: 1.2 }}&gt;Anonymous auth is disabled on the project&lt;/Text&gt;&#10;            &lt;/Box&gt;&#10;        &lt;/Box&gt;&#10;&#10;        &lt;Box style={{ width: 298, display: 'flex', flexDirection: 'column', gap: 14, padding: '20px 22px', background: 'rgba(231,53,85,0.10)', border: '1px solid rgba(231,53,85,0.34)', borderRadius: 8 }}&gt;&#10;            &lt;Text style={{ fontSize: 12, fontWeight: 'bold', color: '#E73555', letterSpacing: 2.2 }}&gt;BLOCKED&lt;/Text&gt;&#10;            &lt;Text style={{ fontSize: 20, fontWeight: 'bold', color: '#F7F1E8', lineHeight: 1.35 }}&gt;Server routes on a static host&lt;/Text&gt;&#10;            &lt;Text style={{ fontSize: 15, color: 'rgba(247,241,232,0.75)', lineHeight: 1.55 }}&gt;GitHub Pages serves files only. The analyst route returns 404 there, so the Pit Boss falls back to its deterministic review: same numbers, no narration. Response headers cannot be set either, so the CSP ships only with the Node build.&lt;/Text&gt;&#10;            &lt;Box style={{ marginTop: 'auto', display: 'flex', flexDirection: 'column', gap: 6 }}&gt;&#10;                &lt;Text style={{ fontSize: 12, color: '#E73555', letterSpacing: 0.4, lineHeight: 1.5 }}&gt;GET /api/analyst → 404 on Pages&lt;/Text&gt;&#10;                &lt;Text style={{ fontSize: 12, color: 'rgba(247,241,232,0.6)', letterSpacing: 0.4, lineHeight: 1.5 }}&gt;The Netlify target restores the headers&lt;/Text&gt;&#10;            &lt;/Box&gt;&#10;        &lt;/Box&gt;&#10;    &lt;/Box&gt;&#10;&#10;    &lt;Box style={{ height: 60, marginTop: 20, flexDirection: 'row', justifyContent: 'space-between', alignItems: 'flex-end', borderTop: '1px solid rgba(247,241,232,0.10)', paddingTop: 12 }}&gt;&#10;        &lt;Text style={{ fontSize: 13, color: 'rgba(247,241,232,0.45)' }}&gt;BROKE VEGAS · fictional markets, virtual money&lt;/Text&gt;&#10;        &lt;Text style={{ fontSize: 13, color: 'rgba(247,241,232,0.45)' }}&gt;11 / 12&lt;/Text&gt;&#10;    &lt;/Box&gt;&#10;&lt;/Slide&gt;&#10;"/>
         <p:cNvGrpSpPr/>
         <p:nvPr/>
       </p:nvGrpSpPr>
@@ -3206,7 +3242,7 @@
                 <a:latin typeface="Microsoft YaHei"/>
                 <a:ea typeface="Microsoft YaHei"/>
               </a:rPr>
-              <a:t>Publishing the repository</a:t>
+              <a:t>Server routes on a static host</a:t>
             </a:r>
             <a:endParaRPr/>
           </a:p>
@@ -3221,7 +3257,7 @@
         <p:spPr>
           <a:xfrm rot="0" flipH="0" flipV="0">
             <a:off x="8877300" y="2552700"/>
-            <a:ext cx="2419350" cy="1333500"/>
+            <a:ext cx="2419350" cy="2133600"/>
           </a:xfrm>
           <a:prstGeom prst="rect"/>
         </p:spPr>
@@ -3245,7 +3281,7 @@
                 <a:latin typeface="Microsoft YaHei"/>
                 <a:ea typeface="Microsoft YaHei"/>
               </a:rPr>
-              <a:t>Creating a GitHub repo returns HTTP 403. The connector token has no repository-creation scope, so the work is committed locally and not pushed.</a:t>
+              <a:t>GitHub Pages serves files only. The analyst route returns 404 there, so the Pit Boss falls back to its deterministic review: same numbers, no narration. Response headers cannot be set either, so the CSP ships only with the Node build.</a:t>
             </a:r>
             <a:endParaRPr/>
           </a:p>
@@ -3280,7 +3316,7 @@
                 <a:latin typeface="Microsoft YaHei"/>
                 <a:ea typeface="Microsoft YaHei"/>
               </a:rPr>
-              <a:t>POST /user/repos → 403</a:t>
+              <a:t>GET /api/analyst → 404 on Pages</a:t>
             </a:r>
             <a:endParaRPr/>
           </a:p>
@@ -3317,7 +3353,7 @@
                 <a:latin typeface="Microsoft YaHei"/>
                 <a:ea typeface="Microsoft YaHei"/>
               </a:rPr>
-              <a:t>"Resource not accessible by integration"</a:t>
+              <a:t>The Netlify target restores the headers</a:t>
             </a:r>
             <a:endParaRPr/>
           </a:p>
@@ -3449,7 +3485,7 @@
   <p:cSld>
     <p:spTree>
       <p:nvGrpSpPr>
-        <p:cNvPr id="74" name="" descr="&lt;Slide style={{ width: 1280, height: 720, background: '#07060B', padding: '54px 72px', position: 'relative', overflow: 'hidden', display: 'flex', flexDirection: 'column' }}&gt;&#13;&#10;    &lt;Box style={{ position: 'absolute', top: 0, right: 0, width: 620, height: 720, background: 'radial-gradient(circle at 78% 50%, rgba(231,53,85,0.22) 0%, rgba(7,6,11,0) 66%)' }} /&gt;&#13;&#10;    &lt;Box style={{ position: 'absolute', top: 0, right: 0, width: 8, height: 720, background: '#E73555' }} /&gt;&#13;&#10;&#13;&#10;    &lt;Box style={{ position: 'relative', zIndex: 1, display: 'flex', flexDirection: 'column', justifyContent: 'space-between', height: '100%' }}&gt;&#13;&#10;        &lt;Box style={{ flexDirection: 'row', alignItems: 'center', gap: 14 }}&gt;&#13;&#10;            &lt;Box style={{ width: 9, height: 9, background: '#F2C96D', borderRadius: 9 }} /&gt;&#13;&#10;            &lt;Text style={{ fontSize: 13, fontWeight: 'bold', color: '#F2C96D', letterSpacing: 2.6 }}&gt;BROKE VEGAS · LIVE AND PLAYABLE&lt;/Text&gt;&#13;&#10;        &lt;/Box&gt;&#13;&#10;&#13;&#10;        &lt;Box style={{ display: 'flex', flexDirection: 'column', gap: 22 }}&gt;&#13;&#10;            &lt;Text style={{ fontSize: 64, fontFamily: 'Impact', color: '#F7F1E8', lineHeight: 1.0 }}&gt;PLACE YOUR BETS.&lt;br /&gt;PLACE YOUR ORDERS.&lt;/Text&gt;&#13;&#10;            &lt;Text style={{ fontSize: 20, color: 'rgba(247,241,232,0.7)', lineHeight: 1.5, width: 620 }}&gt;Six fictional tickers. Three seats. One meltdown button that somebody will press too early. Bring people you enjoy losing to.&lt;/Text&gt;&#13;&#10;        &lt;/Box&gt;&#13;&#10;&#13;&#10;        &lt;Box style={{ display: 'flex', flexDirection: 'column', gap: 14 }}&gt;&#13;&#10;            &lt;Box style={{ width: 760, height: 1, background: 'rgba(247,241,232,0.22)' }} /&gt;&#13;&#10;            &lt;Box style={{ flexDirection: 'row', justifyContent: 'space-between', alignItems: 'flex-end', width: 760 }}&gt;&#13;&#10;                &lt;Box style={{ display: 'flex', flexDirection: 'column', gap: 6 }}&gt;&#13;&#10;                    &lt;Text style={{ fontSize: 12, color: 'rgba(247,241,232,0.5)', letterSpacing: 2.2 }}&gt;OPEN THE ARENA&lt;/Text&gt;&#13;&#10;                    &lt;Text style={{ fontSize: 24, fontWeight: 'bold', color: '#F2C96D', letterSpacing: 0.4 }}&gt;vedinzen.github.io/broke-vegas&lt;/Text&gt;&#13;&#10;                &lt;/Box&gt;&#13;&#10;                &lt;Box style={{ display: 'flex', flexDirection: 'column', gap: 6, alignItems: 'flex-end' }}&gt;&#13;&#10;                    &lt;Text style={{ fontSize: 12, color: 'rgba(247,241,232,0.5)', letterSpacing: 2.2 }}&gt;REMEMBER&lt;/Text&gt;&#13;&#10;                    &lt;Text style={{ fontSize: 18, fontWeight: 'bold', color: '#E73555' }}&gt;Virtual money only. No advice.&lt;/Text&gt;&#13;&#10;                &lt;/Box&gt;&#13;&#10;            &lt;/Box&gt;&#13;&#10;        &lt;/Box&gt;&#13;&#10;    &lt;/Box&gt;&#13;&#10;&lt;/Slide&gt;&#13;&#10;"/>
+        <p:cNvPr id="74" name=""/>
         <p:cNvGrpSpPr/>
         <p:nvPr/>
       </p:nvGrpSpPr>
@@ -3482,7 +3518,10 @@
         </p:spPr>
         <p:txBody>
           <a:bodyPr/>
-          <a:p/>
+          <a:p>
+            <a:pPr/>
+            <a:endParaRPr/>
+          </a:p>
         </p:txBody>
       </p:sp>
       <p:sp>
@@ -3520,7 +3559,10 @@
         </p:spPr>
         <p:txBody>
           <a:bodyPr/>
-          <a:p/>
+          <a:p>
+            <a:pPr/>
+            <a:endParaRPr/>
+          </a:p>
         </p:txBody>
       </p:sp>
       <p:sp>
@@ -3544,7 +3586,10 @@
         </p:spPr>
         <p:txBody>
           <a:bodyPr/>
-          <a:p/>
+          <a:p>
+            <a:pPr/>
+            <a:endParaRPr/>
+          </a:p>
         </p:txBody>
       </p:sp>
       <p:sp>
@@ -3570,7 +3615,10 @@
         </p:spPr>
         <p:txBody>
           <a:bodyPr/>
-          <a:p/>
+          <a:p>
+            <a:pPr/>
+            <a:endParaRPr/>
+          </a:p>
         </p:txBody>
       </p:sp>
       <p:sp>
@@ -3723,7 +3771,10 @@
         </p:spPr>
         <p:txBody>
           <a:bodyPr/>
-          <a:p/>
+          <a:p>
+            <a:pPr/>
+            <a:endParaRPr/>
+          </a:p>
         </p:txBody>
       </p:sp>
       <p:sp>
@@ -3880,7 +3931,7 @@
   <p:cSld>
     <p:spTree>
       <p:nvGrpSpPr>
-        <p:cNvPr id="87" name="" descr="&lt;Slide style={{ width: 1280, height: 720, background: '#07060B', padding: '20px 72px', display: 'flex', flexDirection: 'column' }}&gt;&#13;&#10;    &lt;Box style={{ height: 100, flexDirection: 'row', justifyContent: 'space-between', alignItems: 'flex-start' }}&gt;&#13;&#10;        &lt;Box style={{ display: 'flex', flexDirection: 'column', gap: 8 }}&gt;&#13;&#10;            &lt;Text style={{ fontSize: 12, fontWeight: 'bold', color: '#F2C96D', letterSpacing: 2.4 }}&gt;THE PREMISE&lt;/Text&gt;&#13;&#10;            &lt;Text style={{ fontSize: 38, fontFamily: 'Impact', color: '#F7F1E8', lineHeight: 1.1 }}&gt;Four rules. No exit.&lt;/Text&gt;&#13;&#10;        &lt;/Box&gt;&#13;&#10;        &lt;Text style={{ fontSize: 13, color: 'rgba(247,241,232,0.5)', letterSpacing: 1.6, paddingTop: 6 }}&gt;RULES OF THE FLOOR&lt;/Text&gt;&#13;&#10;    &lt;/Box&gt;&#13;&#10;&#13;&#10;    &lt;Box style={{ height: 480, marginTop: 20, flexDirection: 'row', gap: 56 }}&gt;&#13;&#10;        &lt;Box style={{ width: 420, display: 'flex', flexDirection: 'column', justifyContent: 'space-between', height: 480 }}&gt;&#13;&#10;            &lt;Box style={{ display: 'flex', flexDirection: 'column', gap: 16 }}&gt;&#13;&#10;                &lt;Text style={{ fontSize: 25, fontWeight: 'bold', color: '#F7F1E8', lineHeight: 1.3 }}&gt;Everyone has been told the market is a casino.&lt;/Text&gt;&#13;&#10;                &lt;Text style={{ fontSize: 18, color: 'rgba(247,241,232,0.72)', lineHeight: 1.55 }}&gt;BROKE VEGAS stops pretending otherwise. Three people, one order book, the same fictional cash, and a group chat that does what group chats do.&lt;/Text&gt;&#13;&#10;                &lt;Text style={{ fontSize: 18, color: 'rgba(247,241,232,0.72)', lineHeight: 1.55 }}&gt;No deposits, no leverage, no real tickers.&lt;/Text&gt;&#13;&#10;            &lt;/Box&gt;&#13;&#10;            &lt;Box style={{ padding: '14px 16px', background: 'rgba(231,53,85,0.10)', borderLeft: '3px solid #E73555' }}&gt;&#13;&#10;                &lt;Text style={{ fontSize: 16, color: '#F7F1E8', lineHeight: 1.45 }}&gt;The only thing you can lose is the argument about who was right.&lt;/Text&gt;&#13;&#10;            &lt;/Box&gt;&#13;&#10;        &lt;/Box&gt;&#13;&#10;&#13;&#10;        &lt;Box style={{ flex: 1, display: 'flex', flexDirection: 'column', justifyContent: 'space-between' }}&gt;&#13;&#10;            &lt;Box style={{ flexDirection: 'row', alignItems: 'flex-start', gap: 22, paddingBottom: 18, borderBottom: '1px solid rgba(247,241,232,0.12)' }}&gt;&#13;&#10;                &lt;Text style={{ fontSize: 30, fontWeight: 'bold', color: '#F2C96D', width: 74 }}&gt;01&lt;/Text&gt;&#13;&#10;                &lt;Box style={{ flex: 1, display: 'flex', flexDirection: 'column', gap: 6 }}&gt;&#13;&#10;                    &lt;Text style={{ fontSize: 21, fontWeight: 'bold', color: '#F7F1E8' }}&gt;₹1,00,000 of money that does not exist&lt;/Text&gt;&#13;&#10;                    &lt;Text style={{ fontSize: 16, color: 'rgba(247,241,232,0.66)', lineHeight: 1.5 }}&gt;Identical starting capital, integer paise, no top-ups. Everyone is marked to the same mid, every tick.&lt;/Text&gt;&#13;&#10;                &lt;/Box&gt;&#13;&#10;            &lt;/Box&gt;&#13;&#10;            &lt;Box style={{ flexDirection: 'row', alignItems: 'flex-start', gap: 22, paddingBottom: 18, borderBottom: '1px solid rgba(247,241,232,0.12)' }}&gt;&#13;&#10;                &lt;Text style={{ fontSize: 30, fontWeight: 'bold', color: '#F2C96D', width: 74 }}&gt;02&lt;/Text&gt;&#13;&#10;                &lt;Box style={{ flex: 1, display: 'flex', flexDirection: 'column', gap: 6 }}&gt;&#13;&#10;                    &lt;Text style={{ fontSize: 21, fontWeight: 'bold', color: '#F7F1E8' }}&gt;Three seats at one table&lt;/Text&gt;&#13;&#10;                    &lt;Text style={{ fontSize: 16, color: 'rgba(247,241,232,0.66)', lineHeight: 1.5 }}&gt;Two friends and you — or two bots running the exact same engine, order book and fee-free ledger.&lt;/Text&gt;&#13;&#10;                &lt;/Box&gt;&#13;&#10;            &lt;/Box&gt;&#13;&#10;            &lt;Box style={{ flexDirection: 'row', alignItems: 'flex-start', gap: 22, paddingBottom: 18, borderBottom: '1px solid rgba(247,241,232,0.12)' }}&gt;&#13;&#10;                &lt;Text style={{ fontSize: 30, fontWeight: 'bold', color: '#F2C96D', width: 74 }}&gt;03&lt;/Text&gt;&#13;&#10;                &lt;Box style={{ flex: 1, display: 'flex', flexDirection: 'column', gap: 6 }}&gt;&#13;&#10;                    &lt;Text style={{ fontSize: 21, fontWeight: 'bold', color: '#F7F1E8' }}&gt;Six fictional companies&lt;/Text&gt;&#13;&#10;                    &lt;Text style={{ fontSize: 16, color: 'rgba(247,241,232,0.66)', lineHeight: 1.5 }}&gt;NEON, CHIP, ACES, DICE, LUCK, JKPT. Invented tickers, invented volatility, zero resemblance to a real exchange.&lt;/Text&gt;&#13;&#10;                &lt;/Box&gt;&#13;&#10;            &lt;/Box&gt;&#13;&#10;            &lt;Box style={{ flexDirection: 'row', alignItems: 'flex-start', gap: 22 }}&gt;&#13;&#10;                &lt;Text style={{ fontSize: 30, fontWeight: 'bold', color: '#E73555', width: 74 }}&gt;04&lt;/Text&gt;&#13;&#10;                &lt;Box style={{ flex: 1, display: 'flex', flexDirection: 'column', gap: 6 }}&gt;&#13;&#10;                    &lt;Text style={{ fontSize: 21, fontWeight: 'bold', color: '#F7F1E8' }}&gt;Zero rupees convert, ever&lt;/Text&gt;&#13;&#10;                    &lt;Text style={{ fontSize: 16, color: 'rgba(247,241,232,0.66)', lineHeight: 1.5 }}&gt;Nothing cashes out. There is no withdrawal button, because there is nothing to withdraw.&lt;/Text&gt;&#13;&#10;                &lt;/Box&gt;&#13;&#10;            &lt;/Box&gt;&#13;&#10;        &lt;/Box&gt;&#13;&#10;    &lt;/Box&gt;&#13;&#10;&#13;&#10;    &lt;Box style={{ height: 60, marginTop: 20, flexDirection: 'row', justifyContent: 'space-between', alignItems: 'flex-end', borderTop: '1px solid rgba(247,241,232,0.10)', paddingTop: 12 }}&gt;&#13;&#10;        &lt;Text style={{ fontSize: 13, color: 'rgba(247,241,232,0.45)' }}&gt;BROKE VEGAS · fictional markets, virtual money&lt;/Text&gt;&#13;&#10;        &lt;Text style={{ fontSize: 13, color: 'rgba(247,241,232,0.45)' }}&gt;02 / 12&lt;/Text&gt;&#13;&#10;    &lt;/Box&gt;&#13;&#10;&lt;/Slide&gt;&#13;&#10;"/>
+        <p:cNvPr id="87" name=""/>
         <p:cNvGrpSpPr/>
         <p:nvPr/>
       </p:nvGrpSpPr>
@@ -3913,7 +3964,10 @@
         </p:spPr>
         <p:txBody>
           <a:bodyPr/>
-          <a:p/>
+          <a:p>
+            <a:pPr/>
+            <a:endParaRPr/>
+          </a:p>
         </p:txBody>
       </p:sp>
       <p:sp>
@@ -4159,7 +4213,10 @@
         </p:spPr>
         <p:txBody>
           <a:bodyPr/>
-          <a:p/>
+          <a:p>
+            <a:pPr/>
+            <a:endParaRPr/>
+          </a:p>
         </p:txBody>
       </p:sp>
       <p:sp>
@@ -4199,7 +4256,10 @@
         </p:spPr>
         <p:txBody>
           <a:bodyPr/>
-          <a:p/>
+          <a:p>
+            <a:pPr/>
+            <a:endParaRPr/>
+          </a:p>
         </p:txBody>
       </p:sp>
       <p:sp>
@@ -4278,7 +4338,10 @@
         </p:spPr>
         <p:txBody>
           <a:bodyPr/>
-          <a:p/>
+          <a:p>
+            <a:pPr/>
+            <a:endParaRPr/>
+          </a:p>
         </p:txBody>
       </p:sp>
       <p:sp>
@@ -4429,7 +4492,10 @@
         </p:spPr>
         <p:txBody>
           <a:bodyPr/>
-          <a:p/>
+          <a:p>
+            <a:pPr/>
+            <a:endParaRPr/>
+          </a:p>
         </p:txBody>
       </p:sp>
       <p:sp>
@@ -4580,7 +4646,10 @@
         </p:spPr>
         <p:txBody>
           <a:bodyPr/>
-          <a:p/>
+          <a:p>
+            <a:pPr/>
+            <a:endParaRPr/>
+          </a:p>
         </p:txBody>
       </p:sp>
       <p:sp>
@@ -4840,7 +4909,10 @@
         </p:spPr>
         <p:txBody>
           <a:bodyPr/>
-          <a:p/>
+          <a:p>
+            <a:pPr/>
+            <a:endParaRPr/>
+          </a:p>
         </p:txBody>
       </p:sp>
       <p:sp>
@@ -4927,7 +4999,7 @@
   <p:cSld>
     <p:spTree>
       <p:nvGrpSpPr>
-        <p:cNvPr id="116" name="" descr="&lt;Slide style={{ width: 1280, height: 720, background: '#07060B', padding: '20px 72px', display: 'flex', flexDirection: 'column' }}&gt;&#13;&#10;    &lt;Box style={{ height: 100, flexDirection: 'row', justifyContent: 'space-between', alignItems: 'flex-start' }}&gt;&#13;&#10;        &lt;Box style={{ display: 'flex', flexDirection: 'column', gap: 8 }}&gt;&#13;&#10;            &lt;Text style={{ fontSize: 12, fontWeight: 'bold', color: '#F2C96D', letterSpacing: 2.4 }}&gt;THE ENGINE&lt;/Text&gt;&#13;&#10;            &lt;Text style={{ fontSize: 38, fontFamily: 'Impact', color: '#F7F1E8', lineHeight: 1.1 }}&gt;Same seed. Same market. Every time.&lt;/Text&gt;&#13;&#10;        &lt;/Box&gt;&#13;&#10;        &lt;Text style={{ fontSize: 13, color: 'rgba(247,241,232,0.5)', letterSpacing: 1.6, paddingTop: 6 }}&gt;PURE TYPESCRIPT · ZERO DEPENDENCIES&lt;/Text&gt;&#13;&#10;    &lt;/Box&gt;&#13;&#10;&#13;&#10;    &lt;Box style={{ height: 480, marginTop: 20, flexDirection: 'row', gap: 44 }}&gt;&#13;&#10;        &lt;Box style={{ width: 400, display: 'flex', flexDirection: 'column', justifyContent: 'space-between', height: 480 }}&gt;&#13;&#10;            &lt;Box style={{ display: 'flex', flexDirection: 'column', gap: 2 }}&gt;&#13;&#10;                &lt;Text style={{ fontSize: 60, fontWeight: 'bold', color: '#E73555', lineHeight: 0.95 }}&gt;−12.8%&lt;/Text&gt;&#13;&#10;                &lt;Text style={{ fontSize: 15, color: 'rgba(247,241,232,0.6)', letterSpacing: 1.4, marginTop: 8 }}&gt;NEON HOLDINGS · 120 TICKS · SEED &quot;DECK&quot;&lt;/Text&gt;&#13;&#10;            &lt;/Box&gt;&#13;&#10;            &lt;Box style={{ display: 'flex', flexDirection: 'column', gap: 12 }}&gt;&#13;&#10;                &lt;Box style={{ flexDirection: 'row', gap: 14 }}&gt;&#13;&#10;                    &lt;Text style={{ fontSize: 15, fontWeight: 'bold', color: '#F2C96D', width: 22 }}&gt;01&lt;/Text&gt;&#13;&#10;                    &lt;Text style={{ fontSize: 15, color: 'rgba(247,241,232,0.78)', lineHeight: 1.5, flex: 1 }}&gt;Prices come from a seeded hash, not Math.random. Replay the seed and you get the identical path.&lt;/Text&gt;&#13;&#10;                &lt;/Box&gt;&#13;&#10;                &lt;Box style={{ flexDirection: 'row', gap: 14 }}&gt;&#13;&#10;                    &lt;Text style={{ fontSize: 15, fontWeight: 'bold', color: '#F2C96D', width: 22 }}&gt;02&lt;/Text&gt;&#13;&#10;                    &lt;Text style={{ fontSize: 15, color: 'rgba(247,241,232,0.78)', lineHeight: 1.5, flex: 1 }}&gt;A House market maker quotes three levels per side, so there is always someone to trade against.&lt;/Text&gt;&#13;&#10;                &lt;/Box&gt;&#13;&#10;                &lt;Box style={{ flexDirection: 'row', gap: 14 }}&gt;&#13;&#10;                    &lt;Text style={{ fontSize: 15, fontWeight: 'bold', color: '#F2C96D', width: 22 }}&gt;03&lt;/Text&gt;&#13;&#10;                    &lt;Text style={{ fontSize: 15, color: 'rgba(247,241,232,0.78)', lineHeight: 1.5, flex: 1 }}&gt;Price-time priority, partial fills, and a hard block on self-trading. Your own order cannot fill your own order.&lt;/Text&gt;&#13;&#10;                &lt;/Box&gt;&#13;&#10;                &lt;Box style={{ flexDirection: 'row', gap: 14 }}&gt;&#13;&#10;                    &lt;Text style={{ fontSize: 15, fontWeight: 'bold', color: '#F2C96D', width: 22 }}&gt;04&lt;/Text&gt;&#13;&#10;                    &lt;Text style={{ fontSize: 15, color: 'rgba(247,241,232,0.78)', lineHeight: 1.5, flex: 1 }}&gt;Integer paise, reserved cash, average-cost basis. 60 fills in this run, every one reconciled to zero.&lt;/Text&gt;&#13;&#10;                &lt;/Box&gt;&#13;&#10;            &lt;/Box&gt;&#13;&#10;        &lt;/Box&gt;&#13;&#10;&#13;&#10;        &lt;Box style={{ flex: 1, display: 'flex', flexDirection: 'column', gap: 12 }}&gt;&#13;&#10;            &lt;Chart&#13;&#10;                style={{ height: 392, width: '100%' }}&#13;&#10;                chartType='lineChart'&#13;&#10;                title='NEON · mid price, 120 ticks, one meltdown'&#13;&#10;                titleColor='#F7F1E8'&#13;&#10;                legendColor='rgba(247,241,232,0.6)'&#13;&#10;                axisColor='rgba(247,241,232,0.45)'&#13;&#10;                colors={['#E73555']}&#13;&#10;                background='linear-gradient(180deg, #0C0A12 0%, #07060B 100%)'&#13;&#10;                data={[&#13;&#10;                    ['Tick', 'NEON'],&#13;&#10;                    ['0', 420],&#13;&#10;                    ['10', 422],&#13;&#10;                    ['20', 421],&#13;&#10;                    ['30', 422],&#13;&#10;                    ['40', 413],&#13;&#10;                    ['50', 415],&#13;&#10;                    ['60', 417],&#13;&#10;                    ['70', 402],&#13;&#10;                    ['80', 355],&#13;&#10;                    ['90', 370],&#13;&#10;                    ['100', 366],&#13;&#10;                    ['110', 366],&#13;&#10;                    ['120', 366],&#13;&#10;                ]}&#13;&#10;            /&gt;&#13;&#10;            &lt;Box style={{ flexDirection: 'row', justifyContent: 'space-between' }}&gt;&#13;&#10;                &lt;Text style={{ fontSize: 14, color: 'rgba(247,241,232,0.55)' }}&gt;Open ₹420.00 · High ₹425.95 · Low ₹353.90&lt;/Text&gt;&#13;&#10;                &lt;Text style={{ fontSize: 14, color: '#F2C96D' }}&gt;Crash fires at tick 73 · severity 94/100&lt;/Text&gt;&#13;&#10;            &lt;/Box&gt;&#13;&#10;        &lt;/Box&gt;&#13;&#10;    &lt;/Box&gt;&#13;&#10;&#13;&#10;    &lt;Box style={{ height: 60, marginTop: 20, flexDirection: 'row', justifyContent: 'space-between', alignItems: 'flex-end', borderTop: '1px solid rgba(247,241,232,0.10)', paddingTop: 12 }}&gt;&#13;&#10;        &lt;Text style={{ fontSize: 13, color: 'rgba(247,241,232,0.45)' }}&gt;BROKE VEGAS · fictional markets, virtual money&lt;/Text&gt;&#13;&#10;        &lt;Text style={{ fontSize: 13, color: 'rgba(247,241,232,0.45)' }}&gt;03 / 12&lt;/Text&gt;&#13;&#10;    &lt;/Box&gt;&#13;&#10;&lt;/Slide&gt;&#13;&#10;"/>
+        <p:cNvPr id="116" name=""/>
         <p:cNvGrpSpPr/>
         <p:nvPr/>
       </p:nvGrpSpPr>
@@ -4960,7 +5032,10 @@
         </p:spPr>
         <p:txBody>
           <a:bodyPr/>
-          <a:p/>
+          <a:p>
+            <a:pPr/>
+            <a:endParaRPr/>
+          </a:p>
         </p:txBody>
       </p:sp>
       <p:sp>
@@ -5565,7 +5640,10 @@
         </p:spPr>
         <p:txBody>
           <a:bodyPr/>
-          <a:p/>
+          <a:p>
+            <a:pPr/>
+            <a:endParaRPr/>
+          </a:p>
         </p:txBody>
       </p:sp>
       <p:sp>
@@ -5652,7 +5730,7 @@
   <p:cSld>
     <p:spTree>
       <p:nvGrpSpPr>
-        <p:cNvPr id="137" name="" descr="&lt;Slide style={{ width: 1280, height: 720, background: '#07060B', padding: '20px 72px', display: 'flex', flexDirection: 'column' }}&gt;&#13;&#10;    &lt;Box style={{ height: 100, flexDirection: 'row', justifyContent: 'space-between', alignItems: 'flex-start' }}&gt;&#13;&#10;        &lt;Box style={{ display: 'flex', flexDirection: 'column', gap: 8 }}&gt;&#13;&#10;            &lt;Text style={{ fontSize: 12, fontWeight: 'bold', color: '#F2C96D', letterSpacing: 2.4 }}&gt;DETERMINISM&lt;/Text&gt;&#13;&#10;            &lt;Text style={{ fontSize: 38, fontFamily: 'Impact', color: '#F7F1E8', lineHeight: 1.1 }}&gt;No Math.random. A seed, a tick, a hash.&lt;/Text&gt;&#13;&#10;        &lt;/Box&gt;&#13;&#10;        &lt;Text style={{ fontSize: 13, color: 'rgba(247,241,232,0.5)', letterSpacing: 1.6, paddingTop: 6 }}&gt;PURE · NO CLOCK · NO I/O&lt;/Text&gt;&#13;&#10;    &lt;/Box&gt;&#13;&#10;&#13;&#10;    &lt;Box style={{ height: 480, marginTop: 20, flexDirection: 'row', gap: 36 }}&gt;&#13;&#10;        &lt;Box style={{ width: 640, height: 480, padding: '14px 18px', background: 'rgba(247,241,232,0.04)', border: '1px solid rgba(247,241,232,0.10)', borderRadius: 8, display: 'flex', flexDirection: 'column' }}&gt;&#13;&#10;            &lt;Box style={{ flexDirection: 'row', justifyContent: 'space-between', alignItems: 'center', paddingBottom: 10, borderBottom: '1px solid rgba(247,241,232,0.08)' }}&gt;&#13;&#10;                &lt;Text style={{ fontSize: 11, fontFamily: 'Consolas', color: '#F2C96D', letterSpacing: 0.8 }}&gt;packages/engine/engine.ts&lt;/Text&gt;&#13;&#10;                &lt;Text style={{ fontSize: 11, fontFamily: 'Consolas', color: 'rgba(247,241,232,0.4)' }}&gt;materializeOneTick · 414-439&lt;/Text&gt;&#13;&#10;            &lt;/Box&gt;&#13;&#10;            &lt;Box style={{ display: 'flex', flexDirection: 'column', gap: 0, marginTop: 12 }}&gt;&#13;&#10;                {[&#13;&#10;                { t: &quot;function materializeOneTick(state: EngineState) {&quot;, c: &quot;#F2C96D&quot; },&#13;&#10;                { t: &quot;  state.tick += 1;&quot;, c: &quot;#F7F1E8&quot; },&#13;&#10;                { t: &quot;  const marketFactor =&quot;, c: &quot;#F7F1E8&quot; },&#13;&#10;                { t: &quot;      normalFor(state.seed, state.tick, \&quot;shared-market\&quot;) * 0.0012;&quot;, c: &quot;#F7F1E8&quot; },&#13;&#10;                { t: &quot;  for (const symbol of SYMBOLS) {&quot;, c: &quot;#F2C96D&quot; },&#13;&#10;                { t: &quot;    const config = ASSETS[symbol];&quot;, c: &quot;#F7F1E8&quot; },&#13;&#10;                { t: &quot;    const asset = state.assets[symbol];&quot;, c: &quot;#F7F1E8&quot; },&#13;&#10;                { t: &quot;    const previous = asset.mid;&quot;, c: &quot;#F7F1E8&quot; },&#13;&#10;                { t: &quot;    const active = activeShock(state, symbol, state.tick);&quot;, c: &quot;#F7F1E8&quot; },&#13;&#10;                { t: &quot;    const epsilon = normalFor(state.seed, state.tick, symbol, \&quot;epsilon\&quot;);&quot;, c: &quot;#F7F1E8&quot; },&#13;&#10;                { t: &quot;    const logReturn =&quot;, c: &quot;#F7F1E8&quot; },&#13;&#10;                { t: &quot;        config.drift&quot;, c: &quot;#F7F1E8&quot; },&#13;&#10;                { t: &quot;      + config.vol * active.volatility * epsilon&quot;, c: &quot;#F7F1E8&quot; },&#13;&#10;                { t: &quot;      + config.beta * marketFactor&quot;, c: &quot;#F7F1E8&quot; },&#13;&#10;                { t: &quot;      + active.shock;&quot;, c: &quot;#E73555&quot; },&#13;&#10;                { t: &quot;    const mid = roundTick(previous * Math.exp(logReturn), config.tickSize);&quot;, c: &quot;#F7F1E8&quot; }&#13;&#10;                ].map((line, i) =&gt; (&#13;&#10;                    &lt;Text key={i} style={{ fontSize: 13.5, fontFamily: 'Consolas', color: line.c, lineHeight: 1.5, whiteSpace: 'pre' }}&gt;{line.t}&lt;/Text&gt;&#13;&#10;                ))}&#13;&#10;            &lt;/Box&gt;&#13;&#10;        &lt;/Box&gt;&#13;&#10;&#13;&#10;        &lt;Box style={{ width: 460, display: 'flex', flexDirection: 'column', justifyContent: 'space-between' }}&gt;&#13;&#10;            &lt;Box style={{ display: 'flex', flexDirection: 'column', gap: 16 }}&gt;&#13;&#10;                &lt;Box style={{ flexDirection: 'row', gap: 12 }}&gt;&#13;&#10;                    &lt;Text style={{ fontSize: 13, fontWeight: 'bold', color: '#F2C96D', width: 20 }}&gt;01&lt;/Text&gt;&#13;&#10;                    &lt;Text style={{ fontSize: 14, color: 'rgba(247,241,232,0.78)', lineHeight: 1.5, flex: 1 }}&gt;randomFor(seed, tick, symbol) is a pure function of its arguments. No shared PRNG cursor, so tick 900 can be computed without first computing ticks 1 to 899.&lt;/Text&gt;&#13;&#10;                &lt;/Box&gt;&#13;&#10;                &lt;Box style={{ flexDirection: 'row', gap: 12 }}&gt;&#13;&#10;                    &lt;Text style={{ fontSize: 13, fontWeight: 'bold', color: '#F2C96D', width: 20 }}&gt;02&lt;/Text&gt;&#13;&#10;                    &lt;Text style={{ fontSize: 14, color: 'rgba(247,241,232,0.78)', lineHeight: 1.5, flex: 1 }}&gt;The step is multiplicative. Math.exp of any real is positive, so a price can never reach zero or go negative, however bad the shock.&lt;/Text&gt;&#13;&#10;                &lt;/Box&gt;&#13;&#10;                &lt;Box style={{ flexDirection: 'row', gap: 12 }}&gt;&#13;&#10;                    &lt;Text style={{ fontSize: 13, fontWeight: 'bold', color: '#F2C96D', width: 20 }}&gt;03&lt;/Text&gt;&#13;&#10;                    &lt;Text style={{ fontSize: 14, color: 'rgba(247,241,232,0.78)', lineHeight: 1.5, flex: 1 }}&gt;Every mid is snapped to the asset tick grid before it is stored, so two prices are either equal or differ by at least one tick. The matcher never needs an epsilon.&lt;/Text&gt;&#13;&#10;                &lt;/Box&gt;&#13;&#10;            &lt;/Box&gt;&#13;&#10;            &lt;Box style={{ padding: '12px 14px', background: 'rgba(231,53,85,0.10)', borderLeft: '3px solid #E73555' }}&gt;&#13;&#10;                &lt;Text style={{ fontSize: 13.5, color: '#F7F1E8', lineHeight: 1.5 }}&gt;Seed plus order log is the entire match. Hash both and you get one string, which is exactly what the replay page compares.&lt;/Text&gt;&#13;&#10;            &lt;/Box&gt;&#13;&#10;        &lt;/Box&gt;&#13;&#10;    &lt;/Box&gt;&#13;&#10;&#13;&#10;    &lt;Box style={{ height: 60, marginTop: 20, flexDirection: 'row', justifyContent: 'space-between', alignItems: 'flex-end', borderTop: '1px solid rgba(247,241,232,0.10)', paddingTop: 12 }}&gt;&#13;&#10;        &lt;Text style={{ fontSize: 13, color: 'rgba(247,241,232,0.45)' }}&gt;BROKE VEGAS · fictional markets, virtual money&lt;/Text&gt;&#13;&#10;        &lt;Text style={{ fontSize: 13, color: 'rgba(247,241,232,0.45)' }}&gt;04 / 12&lt;/Text&gt;&#13;&#10;    &lt;/Box&gt;&#13;&#10;&lt;/Slide&gt;&#13;&#10;"/>
+        <p:cNvPr id="137" name=""/>
         <p:cNvGrpSpPr/>
         <p:nvPr/>
       </p:nvGrpSpPr>
@@ -5685,7 +5763,10 @@
         </p:spPr>
         <p:txBody>
           <a:bodyPr/>
-          <a:p/>
+          <a:p>
+            <a:pPr/>
+            <a:endParaRPr/>
+          </a:p>
         </p:txBody>
       </p:sp>
       <p:sp>
@@ -5827,7 +5908,10 @@
         </p:spPr>
         <p:txBody>
           <a:bodyPr/>
-          <a:p/>
+          <a:p>
+            <a:pPr/>
+            <a:endParaRPr/>
+          </a:p>
         </p:txBody>
       </p:sp>
       <p:sp>
@@ -5869,7 +5953,10 @@
         </p:spPr>
         <p:txBody>
           <a:bodyPr/>
-          <a:p/>
+          <a:p>
+            <a:pPr/>
+            <a:endParaRPr/>
+          </a:p>
         </p:txBody>
       </p:sp>
       <p:sp>
@@ -6749,7 +6836,10 @@
         </p:spPr>
         <p:txBody>
           <a:bodyPr/>
-          <a:p/>
+          <a:p>
+            <a:pPr/>
+            <a:endParaRPr/>
+          </a:p>
         </p:txBody>
       </p:sp>
       <p:sp>
@@ -6789,7 +6879,10 @@
         </p:spPr>
         <p:txBody>
           <a:bodyPr/>
-          <a:p/>
+          <a:p>
+            <a:pPr/>
+            <a:endParaRPr/>
+          </a:p>
         </p:txBody>
       </p:sp>
       <p:sp>
@@ -6868,7 +6961,10 @@
         </p:spPr>
         <p:txBody>
           <a:bodyPr/>
-          <a:p/>
+          <a:p>
+            <a:pPr/>
+            <a:endParaRPr/>
+          </a:p>
         </p:txBody>
       </p:sp>
       <p:sp>
@@ -6955,7 +7051,7 @@
   <p:cSld>
     <p:spTree>
       <p:nvGrpSpPr>
-        <p:cNvPr id="174" name="" descr="&lt;Slide style={{ width: 1280, height: 720, background: '#07060B', padding: '20px 72px', display: 'flex', flexDirection: 'column' }}&gt;&#13;&#10;    &lt;Box style={{ height: 100, flexDirection: 'row', justifyContent: 'space-between', alignItems: 'flex-start' }}&gt;&#13;&#10;        &lt;Box style={{ display: 'flex', flexDirection: 'column', gap: 8 }}&gt;&#13;&#10;            &lt;Text style={{ fontSize: 12, fontWeight: 'bold', color: '#F2C96D', letterSpacing: 2.4 }}&gt;MATCHING&lt;/Text&gt;&#13;&#10;            &lt;Text style={{ fontSize: 38, fontFamily: 'Impact', color: '#F7F1E8', lineHeight: 1.1 }}&gt;Price first. Then sequence. Nothing else.&lt;/Text&gt;&#13;&#10;        &lt;/Box&gt;&#13;&#10;        &lt;Text style={{ fontSize: 13, color: 'rgba(247,241,232,0.5)', letterSpacing: 1.6, paddingTop: 6 }}&gt;ONE BOOK · TWO SOURCES&lt;/Text&gt;&#13;&#10;    &lt;/Box&gt;&#13;&#10;&#13;&#10;    &lt;Box style={{ height: 480, marginTop: 20, flexDirection: 'row', gap: 36 }}&gt;&#13;&#10;        &lt;Box style={{ width: 640, height: 480, padding: '14px 18px', background: 'rgba(247,241,232,0.04)', border: '1px solid rgba(247,241,232,0.10)', borderRadius: 8, display: 'flex', flexDirection: 'column' }}&gt;&#13;&#10;            &lt;Box style={{ flexDirection: 'row', justifyContent: 'space-between', alignItems: 'center', paddingBottom: 10, borderBottom: '1px solid rgba(247,241,232,0.08)' }}&gt;&#13;&#10;                &lt;Text style={{ fontSize: 11, fontFamily: 'Consolas', color: '#F2C96D', letterSpacing: 0.8 }}&gt;packages/engine/engine.ts&lt;/Text&gt;&#13;&#10;                &lt;Text style={{ fontSize: 11, fontFamily: 'Consolas', color: 'rgba(247,241,232,0.4)' }}&gt;bestOpposite · 245-279 · limit filter elided&lt;/Text&gt;&#13;&#10;            &lt;/Box&gt;&#13;&#10;            &lt;Box style={{ display: 'flex', flexDirection: 'column', gap: 0, marginTop: 12 }}&gt;&#13;&#10;                {[&#13;&#10;                { t: &quot;function bestOpposite(state, incoming: Order) {&quot;, c: &quot;#F2C96D&quot; },&#13;&#10;                { t: &quot;  const candidates: Array&lt;Order | HouseQuote&gt; = [&quot;, c: &quot;#F7F1E8&quot; },&#13;&#10;                { t: &quot;    ...state.quotes.filter((q) =&gt; q.side !== incoming.side),&quot;, c: &quot;#F7F1E8&quot; },&#13;&#10;                { t: &quot;    ...state.orders.filter((o) =&gt;&quot;, c: &quot;#F7F1E8&quot; },&#13;&#10;                { t: &quot;      isOpen(o) &amp;&amp; o.side !== incoming.side &amp;&amp;&quot;, c: &quot;#F7F1E8&quot; },&#13;&#10;                { t: &quot;      o.playerId !== incoming.playerId),   // no self-trade&quot;, c: &quot;rgba(247,241,232,0.36)&quot; },&#13;&#10;                { t: &quot;  ];&quot;, c: &quot;#F7F1E8&quot; },&#13;&#10;                { t: &quot;  return candidates.sort((a, b) =&gt; {&quot;, c: &quot;#F7F1E8&quot; },&#13;&#10;                { t: &quot;    const priceOrder = incoming.side === \&quot;buy\&quot;&quot;, c: &quot;#F7F1E8&quot; },&#13;&#10;                { t: &quot;      ? priceOf(a) - priceOf(b)&quot;, c: &quot;#F7F1E8&quot; },&#13;&#10;                { t: &quot;      : priceOf(b) - priceOf(a);&quot;, c: &quot;#F7F1E8&quot; },&#13;&#10;                { t: &quot;    return priceOrder || a.seq - b.seq;    // price, then time&quot;, c: &quot;#E73555&quot; },&#13;&#10;                { t: &quot;  })[0] ?? null;&quot;, c: &quot;#F7F1E8&quot; },&#13;&#10;                { t: &quot;}&quot;, c: &quot;#F7F1E8&quot; },&#13;&#10;                { t: &quot;// aggressor pays the resting price, never its own limit&quot;, c: &quot;rgba(247,241,232,0.36)&quot; },&#13;&#10;                { t: &quot;executeFill(state, order, opposite, priceOf(opposite), qty);&quot;, c: &quot;#F7F1E8&quot; }&#13;&#10;                ].map((line, i) =&gt; (&#13;&#10;                    &lt;Text key={i} style={{ fontSize: 13.5, fontFamily: 'Consolas', color: line.c, lineHeight: 1.5, whiteSpace: 'pre' }}&gt;{line.t}&lt;/Text&gt;&#13;&#10;                ))}&#13;&#10;            &lt;/Box&gt;&#13;&#10;        &lt;/Box&gt;&#13;&#10;&#13;&#10;        &lt;Box style={{ width: 460, display: 'flex', flexDirection: 'column', justifyContent: 'space-between' }}&gt;&#13;&#10;            &lt;Box style={{ display: 'flex', flexDirection: 'column', gap: 16 }}&gt;&#13;&#10;                &lt;Box style={{ flexDirection: 'row', gap: 12 }}&gt;&#13;&#10;                    &lt;Text style={{ fontSize: 13, fontWeight: 'bold', color: '#F2C96D', width: 20 }}&gt;01&lt;/Text&gt;&#13;&#10;                    &lt;Text style={{ fontSize: 14, color: 'rgba(247,241,232,0.78)', lineHeight: 1.5, flex: 1 }}&gt;One book, two sources. House quotes and player orders are merged into a single candidate list, so there is no separate market-maker book to keep in sync.&lt;/Text&gt;&#13;&#10;                &lt;/Box&gt;&#13;&#10;                &lt;Box style={{ flexDirection: 'row', gap: 12 }}&gt;&#13;&#10;                    &lt;Text style={{ fontSize: 13, fontWeight: 'bold', color: '#F2C96D', width: 20 }}&gt;02&lt;/Text&gt;&#13;&#10;                    &lt;Text style={{ fontSize: 14, color: 'rgba(247,241,232,0.78)', lineHeight: 1.5, flex: 1 }}&gt;seq is stamped inside the engine at submit. Time priority is therefore a counter, not a wall clock, and client clock skew cannot reorder anything.&lt;/Text&gt;&#13;&#10;                &lt;/Box&gt;&#13;&#10;                &lt;Box style={{ flexDirection: 'row', gap: 12 }}&gt;&#13;&#10;                    &lt;Text style={{ fontSize: 13, fontWeight: 'bold', color: '#F2C96D', width: 20 }}&gt;03&lt;/Text&gt;&#13;&#10;                    &lt;Text style={{ fontSize: 14, color: 'rgba(247,241,232,0.78)', lineHeight: 1.5, flex: 1 }}&gt;Self-trade is excluded in the filter, before matching. It is never a post-hoc rejection that could leave half an order filled against yourself.&lt;/Text&gt;&#13;&#10;                &lt;/Box&gt;&#13;&#10;            &lt;/Box&gt;&#13;&#10;            &lt;Box style={{ padding: '12px 14px', background: 'rgba(231,53,85,0.10)', borderLeft: '3px solid #E73555' }}&gt;&#13;&#10;                &lt;Text style={{ fontSize: 13.5, color: '#F7F1E8', lineHeight: 1.5 }}&gt;The aggressor pays the resting price. A limit order can fill better than its limit, never worse, and a market order walks the book until it runs out of cash.&lt;/Text&gt;&#13;&#10;            &lt;/Box&gt;&#13;&#10;        &lt;/Box&gt;&#13;&#10;    &lt;/Box&gt;&#13;&#10;&#13;&#10;    &lt;Box style={{ height: 60, marginTop: 20, flexDirection: 'row', justifyContent: 'space-between', alignItems: 'flex-end', borderTop: '1px solid rgba(247,241,232,0.10)', paddingTop: 12 }}&gt;&#13;&#10;        &lt;Text style={{ fontSize: 13, color: 'rgba(247,241,232,0.45)' }}&gt;BROKE VEGAS · fictional markets, virtual money&lt;/Text&gt;&#13;&#10;        &lt;Text style={{ fontSize: 13, color: 'rgba(247,241,232,0.45)' }}&gt;05 / 12&lt;/Text&gt;&#13;&#10;    &lt;/Box&gt;&#13;&#10;&lt;/Slide&gt;&#13;&#10;"/>
+        <p:cNvPr id="174" name=""/>
         <p:cNvGrpSpPr/>
         <p:nvPr/>
       </p:nvGrpSpPr>
@@ -6988,7 +7084,10 @@
         </p:spPr>
         <p:txBody>
           <a:bodyPr/>
-          <a:p/>
+          <a:p>
+            <a:pPr/>
+            <a:endParaRPr/>
+          </a:p>
         </p:txBody>
       </p:sp>
       <p:sp>
@@ -7130,7 +7229,10 @@
         </p:spPr>
         <p:txBody>
           <a:bodyPr/>
-          <a:p/>
+          <a:p>
+            <a:pPr/>
+            <a:endParaRPr/>
+          </a:p>
         </p:txBody>
       </p:sp>
       <p:sp>
@@ -7172,7 +7274,10 @@
         </p:spPr>
         <p:txBody>
           <a:bodyPr/>
-          <a:p/>
+          <a:p>
+            <a:pPr/>
+            <a:endParaRPr/>
+          </a:p>
         </p:txBody>
       </p:sp>
       <p:sp>
@@ -8056,7 +8161,10 @@
         </p:spPr>
         <p:txBody>
           <a:bodyPr/>
-          <a:p/>
+          <a:p>
+            <a:pPr/>
+            <a:endParaRPr/>
+          </a:p>
         </p:txBody>
       </p:sp>
       <p:sp>
@@ -8096,7 +8204,10 @@
         </p:spPr>
         <p:txBody>
           <a:bodyPr/>
-          <a:p/>
+          <a:p>
+            <a:pPr/>
+            <a:endParaRPr/>
+          </a:p>
         </p:txBody>
       </p:sp>
       <p:sp>
@@ -8175,7 +8286,10 @@
         </p:spPr>
         <p:txBody>
           <a:bodyPr/>
-          <a:p/>
+          <a:p>
+            <a:pPr/>
+            <a:endParaRPr/>
+          </a:p>
         </p:txBody>
       </p:sp>
       <p:sp>
@@ -8262,7 +8376,7 @@
   <p:cSld>
     <p:spTree>
       <p:nvGrpSpPr>
-        <p:cNvPr id="211" name="" descr="&lt;Slide style={{ width: 1280, height: 720, background: '#07060B', padding: '20px 72px', display: 'flex', flexDirection: 'column' }}&gt;&#13;&#10;    &lt;Box style={{ height: 100, flexDirection: 'row', justifyContent: 'space-between', alignItems: 'flex-start' }}&gt;&#13;&#10;        &lt;Box style={{ display: 'flex', flexDirection: 'column', gap: 8 }}&gt;&#13;&#10;            &lt;Text style={{ fontSize: 12, fontWeight: 'bold', color: '#F2C96D', letterSpacing: 2.4 }}&gt;ACCOUNTING&lt;/Text&gt;&#13;&#10;            &lt;Text style={{ fontSize: 38, fontFamily: 'Impact', color: '#F7F1E8', lineHeight: 1.1 }}&gt;Money is integers. Reservations are explicit.&lt;/Text&gt;&#13;&#10;        &lt;/Box&gt;&#13;&#10;        &lt;Text style={{ fontSize: 13, color: 'rgba(247,241,232,0.5)', letterSpacing: 1.6, paddingTop: 6 }}&gt;PAISE · LONG ONLY · NO FLOATS&lt;/Text&gt;&#13;&#10;    &lt;/Box&gt;&#13;&#10;&#13;&#10;    &lt;Box style={{ height: 480, marginTop: 20, flexDirection: 'row', gap: 36 }}&gt;&#13;&#10;        &lt;Box style={{ width: 640, height: 480, padding: '14px 18px', background: 'rgba(247,241,232,0.04)', border: '1px solid rgba(247,241,232,0.10)', borderRadius: 8, display: 'flex', flexDirection: 'column' }}&gt;&#13;&#10;            &lt;Box style={{ flexDirection: 'row', justifyContent: 'space-between', alignItems: 'center', paddingBottom: 10, borderBottom: '1px solid rgba(247,241,232,0.08)' }}&gt;&#13;&#10;                &lt;Text style={{ fontSize: 11, fontFamily: 'Consolas', color: '#F2C96D', letterSpacing: 0.8 }}&gt;packages/engine/engine.ts&lt;/Text&gt;&#13;&#10;                &lt;Text style={{ fontSize: 11, fontFamily: 'Consolas', color: 'rgba(247,241,232,0.4)' }}&gt;submitOrder / verifyInvariants&lt;/Text&gt;&#13;&#10;            &lt;/Box&gt;&#13;&#10;            &lt;Box style={{ display: 'flex', flexDirection: 'column', gap: 0, marginTop: 12 }}&gt;&#13;&#10;                {[&#13;&#10;                { t: &quot;// buy limit: cash leaves the spendable balance at submit&quot;, c: &quot;rgba(247,241,232,0.36)&quot; },&#13;&#10;                { t: &quot;const reserve = order.qty * (order.limitPrice ?? 0);&quot;, c: &quot;#F7F1E8&quot; },&#13;&#10;                { t: &quot;player.cash -= reserve;&quot;, c: &quot;#F7F1E8&quot; },&#13;&#10;                { t: &quot;player.reserved += reserve;&quot;, c: &quot;#E73555&quot; },&#13;&#10;                { t: &quot; &quot;, c: &quot;#F7F1E8&quot; },&#13;&#10;                { t: &quot;// cancel: only the unfilled remainder comes back&quot;, c: &quot;rgba(247,241,232,0.36)&quot; },&#13;&#10;                { t: &quot;const release = remaining(order) * (order.limitPrice ?? 0);&quot;, c: &quot;#F7F1E8&quot; },&#13;&#10;                { t: &quot;player.reserved -= release;&quot;, c: &quot;#F7F1E8&quot; },&#13;&#10;                { t: &quot;player.cash += release;&quot;, c: &quot;#F7F1E8&quot; },&#13;&#10;                { t: &quot; &quot;, c: &quot;#F7F1E8&quot; },&#13;&#10;                { t: &quot;// every write is checked, not assumed&quot;, c: &quot;rgba(247,241,232,0.36)&quot; },&#13;&#10;                { t: &quot;if (!Number.isSafeInteger(player.cash) || player.cash &lt; 0)&quot;, c: &quot;#F7F1E8&quot; },&#13;&#10;                { t: &quot;  errors.push(player.id + \&quot;: invalid cash \&quot; + player.cash);&quot;, c: &quot;#F7F1E8&quot; },&#13;&#10;                { t: &quot;if (position.reservedQty &gt; position.qty)&quot;, c: &quot;#F7F1E8&quot; },&#13;&#10;                { t: &quot;  errors.push(player.id + \&quot;/\&quot; + symbol + \&quot;: bad position\&quot;);&quot;, c: &quot;#F7F1E8&quot; }&#13;&#10;                ].map((line, i) =&gt; (&#13;&#10;                    &lt;Text key={i} style={{ fontSize: 13.5, fontFamily: 'Consolas', color: line.c, lineHeight: 1.5, whiteSpace: 'pre' }}&gt;{line.t}&lt;/Text&gt;&#13;&#10;                ))}&#13;&#10;            &lt;/Box&gt;&#13;&#10;        &lt;/Box&gt;&#13;&#10;&#13;&#10;        &lt;Box style={{ width: 460, display: 'flex', flexDirection: 'column', justifyContent: 'space-between' }}&gt;&#13;&#10;            &lt;Box style={{ display: 'flex', flexDirection: 'column', gap: 16 }}&gt;&#13;&#10;                &lt;Box style={{ flexDirection: 'row', gap: 12 }}&gt;&#13;&#10;                    &lt;Text style={{ fontSize: 13, fontWeight: 'bold', color: '#F2C96D', width: 20 }}&gt;01&lt;/Text&gt;&#13;&#10;                    &lt;Text style={{ fontSize: 14, color: 'rgba(247,241,232,0.78)', lineHeight: 1.5, flex: 1 }}&gt;Money is an integer number of paise. The 1,00,000 rupee stack is 10,000,000, and every write passes Number.isSafeInteger, so there is no float drift and no rounding rule to argue about.&lt;/Text&gt;&#13;&#10;                &lt;/Box&gt;&#13;&#10;                &lt;Box style={{ flexDirection: 'row', gap: 12 }}&gt;&#13;&#10;                    &lt;Text style={{ fontSize: 13, fontWeight: 'bold', color: '#F2C96D', width: 20 }}&gt;02&lt;/Text&gt;&#13;&#10;                    &lt;Text style={{ fontSize: 14, color: 'rgba(247,241,232,0.78)', lineHeight: 1.5, flex: 1 }}&gt;cash and reserved are separate counters, so a resting order cannot spend the same rupee twice. Equity is cash + reserved + sum of qty times mid, which means placing an order never moves your equity.&lt;/Text&gt;&#13;&#10;                &lt;/Box&gt;&#13;&#10;                &lt;Box style={{ flexDirection: 'row', gap: 12 }}&gt;&#13;&#10;                    &lt;Text style={{ fontSize: 13, fontWeight: 'bold', color: '#F2C96D', width: 20 }}&gt;03&lt;/Text&gt;&#13;&#10;                    &lt;Text style={{ fontSize: 14, color: 'rgba(247,241,232,0.78)', lineHeight: 1.5, flex: 1 }}&gt;reservedQty is never allowed above qty. Positions are long-only whole shares, so a holding cannot go negative even if two orders race.&lt;/Text&gt;&#13;&#10;                &lt;/Box&gt;&#13;&#10;            &lt;/Box&gt;&#13;&#10;            &lt;Box style={{ padding: '12px 14px', background: 'rgba(231,53,85,0.10)', borderLeft: '3px solid #E73555' }}&gt;&#13;&#10;                &lt;Text style={{ fontSize: 13.5, color: '#F7F1E8', lineHeight: 1.5 }}&gt;The CLI simulation reconciles 60 fills to zero invariant errors, and the same check runs over randomised order flows in the test suite.&lt;/Text&gt;&#13;&#10;            &lt;/Box&gt;&#13;&#10;        &lt;/Box&gt;&#13;&#10;    &lt;/Box&gt;&#13;&#10;&#13;&#10;    &lt;Box style={{ height: 60, marginTop: 20, flexDirection: 'row', justifyContent: 'space-between', alignItems: 'flex-end', borderTop: '1px solid rgba(247,241,232,0.10)', paddingTop: 12 }}&gt;&#13;&#10;        &lt;Text style={{ fontSize: 13, color: 'rgba(247,241,232,0.45)' }}&gt;BROKE VEGAS · fictional markets, virtual money&lt;/Text&gt;&#13;&#10;        &lt;Text style={{ fontSize: 13, color: 'rgba(247,241,232,0.45)' }}&gt;06 / 12&lt;/Text&gt;&#13;&#10;    &lt;/Box&gt;&#13;&#10;&lt;/Slide&gt;&#13;&#10;"/>
+        <p:cNvPr id="211" name=""/>
         <p:cNvGrpSpPr/>
         <p:nvPr/>
       </p:nvGrpSpPr>
@@ -8295,7 +8409,10 @@
         </p:spPr>
         <p:txBody>
           <a:bodyPr/>
-          <a:p/>
+          <a:p>
+            <a:pPr/>
+            <a:endParaRPr/>
+          </a:p>
         </p:txBody>
       </p:sp>
       <p:sp>
@@ -8437,7 +8554,10 @@
         </p:spPr>
         <p:txBody>
           <a:bodyPr/>
-          <a:p/>
+          <a:p>
+            <a:pPr/>
+            <a:endParaRPr/>
+          </a:p>
         </p:txBody>
       </p:sp>
       <p:sp>
@@ -8479,7 +8599,10 @@
         </p:spPr>
         <p:txBody>
           <a:bodyPr/>
-          <a:p/>
+          <a:p>
+            <a:pPr/>
+            <a:endParaRPr/>
+          </a:p>
         </p:txBody>
       </p:sp>
       <p:sp>
@@ -9330,7 +9453,10 @@
         </p:spPr>
         <p:txBody>
           <a:bodyPr/>
-          <a:p/>
+          <a:p>
+            <a:pPr/>
+            <a:endParaRPr/>
+          </a:p>
         </p:txBody>
       </p:sp>
       <p:sp>
@@ -9370,7 +9496,10 @@
         </p:spPr>
         <p:txBody>
           <a:bodyPr/>
-          <a:p/>
+          <a:p>
+            <a:pPr/>
+            <a:endParaRPr/>
+          </a:p>
         </p:txBody>
       </p:sp>
       <p:sp>
@@ -9449,7 +9578,10 @@
         </p:spPr>
         <p:txBody>
           <a:bodyPr/>
-          <a:p/>
+          <a:p>
+            <a:pPr/>
+            <a:endParaRPr/>
+          </a:p>
         </p:txBody>
       </p:sp>
       <p:sp>
@@ -9536,7 +9668,7 @@
   <p:cSld>
     <p:spTree>
       <p:nvGrpSpPr>
-        <p:cNvPr id="247" name="" descr="&lt;Slide style={{ width: 1280, height: 720, background: '#07060B', padding: '20px 72px', display: 'flex', flexDirection: 'column' }}&gt;&#13;&#10;    &lt;Box style={{ height: 100, flexDirection: 'row', justifyContent: 'space-between', alignItems: 'flex-start' }}&gt;&#13;&#10;        &lt;Box style={{ display: 'flex', flexDirection: 'column', gap: 8 }}&gt;&#13;&#10;            &lt;Text style={{ fontSize: 12, fontWeight: 'bold', color: '#F2C96D', letterSpacing: 2.4 }}&gt;THE TERMINAL&lt;/Text&gt;&#13;&#10;            &lt;Text style={{ fontSize: 38, fontFamily: 'Impact', color: '#F7F1E8', lineHeight: 1.1 }}&gt;Dense on purpose.&lt;/Text&gt;&#13;&#10;        &lt;/Box&gt;&#13;&#10;        &lt;Text style={{ fontSize: 13, color: 'rgba(247,241,232,0.5)', letterSpacing: 1.6, paddingTop: 6 }}&gt;SCREENSHOT · LIVE DEPLOYMENT&lt;/Text&gt;&#13;&#10;    &lt;/Box&gt;&#13;&#10;&#13;&#10;    &lt;Box style={{ height: 480, marginTop: 20, flexDirection: 'row', gap: 32 }}&gt;&#13;&#10;        &lt;Box style={{ width: 748, display: 'flex', flexDirection: 'column', gap: 12 }}&gt;&#13;&#10;            &lt;Image src=&quot;assets/04-terminal.png&quot; style={{ width: 748, height: 442, objectFit: 'cover', border: '1px solid rgba(247,241,232,0.14)', borderRadius: 10, boxShadow: '0 24px 60px rgba(0,0,0,0.55)' }} /&gt;&#13;&#10;            &lt;Box style={{ flexDirection: 'row', justifyContent: 'space-between' }}&gt;&#13;&#10;                &lt;Text style={{ fontSize: 13, color: 'rgba(247,241,232,0.55)' }}&gt;The Obsidian Table · room ONXBW · tick 9 of 600&lt;/Text&gt;&#13;&#10;                &lt;Text style={{ fontSize: 13, color: 'rgba(247,241,232,0.55)' }}&gt;1440 × 900, production build&lt;/Text&gt;&#13;&#10;            &lt;/Box&gt;&#13;&#10;        &lt;/Box&gt;&#13;&#10;&#13;&#10;        &lt;Box style={{ flex: 1, display: 'flex', flexDirection: 'column', justifyContent: 'space-between' }}&gt;&#13;&#10;            &lt;Box style={{ display: 'flex', flexDirection: 'column', gap: 14 }}&gt;&#13;&#10;                &lt;Text style={{ fontSize: 20, fontWeight: 'bold', color: '#F7F1E8', lineHeight: 1.4 }}&gt;Everything a trader needs, and nothing that flatters them.&lt;/Text&gt;&#13;&#10;                &lt;Text style={{ fontSize: 16, color: 'rgba(247,241,232,0.7)', lineHeight: 1.55 }}&gt;Candles and volume, a live order book split into House and player liquidity, market and limit orders, open orders you can cancel, and a fill tape that never rounds in your favour.&lt;/Text&gt;&#13;&#10;            &lt;/Box&gt;&#13;&#10;            &lt;Box style={{ display: 'flex', flexDirection: 'column', gap: 16 }}&gt;&#13;&#10;                &lt;Box style={{ flexDirection: 'row', justifyContent: 'space-between', alignItems: 'baseline', paddingBottom: 10, borderBottom: '1px solid rgba(247,241,232,0.12)' }}&gt;&#13;&#10;                    &lt;Text style={{ fontSize: 14, color: 'rgba(247,241,232,0.6)', letterSpacing: 1.2 }}&gt;SPREAD ON NEON&lt;/Text&gt;&#13;&#10;                    &lt;Text style={{ fontSize: 22, fontWeight: 'bold', color: '#F7F1E8' }}&gt;₹0.30&lt;/Text&gt;&#13;&#10;                &lt;/Box&gt;&#13;&#10;                &lt;Box style={{ flexDirection: 'row', justifyContent: 'space-between', alignItems: 'baseline', paddingBottom: 10, borderBottom: '1px solid rgba(247,241,232,0.12)' }}&gt;&#13;&#10;                    &lt;Text style={{ fontSize: 14, color: 'rgba(247,241,232,0.6)', letterSpacing: 1.2 }}&gt;CASH RESERVED ON A LIMIT&lt;/Text&gt;&#13;&#10;                    &lt;Text style={{ fontSize: 22, fontWeight: 'bold', color: '#F7F1E8' }}&gt;Exact, to the paise&lt;/Text&gt;&#13;&#10;                &lt;/Box&gt;&#13;&#10;                &lt;Box style={{ flexDirection: 'row', justifyContent: 'space-between', alignItems: 'baseline', paddingBottom: 10, borderBottom: '1px solid rgba(247,241,232,0.12)' }}&gt;&#13;&#10;                    &lt;Text style={{ fontSize: 14, color: 'rgba(247,241,232,0.6)', letterSpacing: 1.2 }}&gt;ORDER BOOK LEVELS SHOWN&lt;/Text&gt;&#13;&#10;                    &lt;Text style={{ fontSize: 22, fontWeight: 'bold', color: '#F7F1E8' }}&gt;7 per side&lt;/Text&gt;&#13;&#10;                &lt;/Box&gt;&#13;&#10;                &lt;Box style={{ flexDirection: 'row', justifyContent: 'space-between', alignItems: 'baseline' }}&gt;&#13;&#10;                    &lt;Text style={{ fontSize: 14, color: 'rgba(247,241,232,0.6)', letterSpacing: 1.2 }}&gt;MOBILE&lt;/Text&gt;&#13;&#10;                    &lt;Text style={{ fontSize: 22, fontWeight: 'bold', color: '#F2C96D' }}&gt;Tabbed, no overflow&lt;/Text&gt;&#13;&#10;                &lt;/Box&gt;&#13;&#10;            &lt;/Box&gt;&#13;&#10;        &lt;/Box&gt;&#13;&#10;    &lt;/Box&gt;&#13;&#10;&#13;&#10;    &lt;Box style={{ height: 60, marginTop: 20, flexDirection: 'row', justifyContent: 'space-between', alignItems: 'flex-end', borderTop: '1px solid rgba(247,241,232,0.10)', paddingTop: 12 }}&gt;&#13;&#10;        &lt;Text style={{ fontSize: 13, color: 'rgba(247,241,232,0.45)' }}&gt;BROKE VEGAS · fictional markets, virtual money&lt;/Text&gt;&#13;&#10;        &lt;Text style={{ fontSize: 13, color: 'rgba(247,241,232,0.45)' }}&gt;07 / 12&lt;/Text&gt;&#13;&#10;    &lt;/Box&gt;&#13;&#10;&lt;/Slide&gt;&#13;&#10;"/>
+        <p:cNvPr id="247" name=""/>
         <p:cNvGrpSpPr/>
         <p:nvPr/>
       </p:nvGrpSpPr>
@@ -9569,7 +9701,10 @@
         </p:spPr>
         <p:txBody>
           <a:bodyPr/>
-          <a:p/>
+          <a:p>
+            <a:pPr/>
+            <a:endParaRPr/>
+          </a:p>
         </p:txBody>
       </p:sp>
       <p:sp>
@@ -9704,7 +9839,10 @@
         </p:spPr>
         <p:txBody>
           <a:bodyPr/>
-          <a:p/>
+          <a:p>
+            <a:pPr/>
+            <a:endParaRPr/>
+          </a:p>
         </p:txBody>
       </p:sp>
       <p:pic>
@@ -9931,7 +10069,10 @@
         </p:spPr>
         <p:txBody>
           <a:bodyPr/>
-          <a:p/>
+          <a:p>
+            <a:pPr/>
+            <a:endParaRPr/>
+          </a:p>
         </p:txBody>
       </p:sp>
       <p:sp>
@@ -10045,7 +10186,10 @@
         </p:spPr>
         <p:txBody>
           <a:bodyPr/>
-          <a:p/>
+          <a:p>
+            <a:pPr/>
+            <a:endParaRPr/>
+          </a:p>
         </p:txBody>
       </p:sp>
       <p:sp>
@@ -10159,7 +10303,10 @@
         </p:spPr>
         <p:txBody>
           <a:bodyPr/>
-          <a:p/>
+          <a:p>
+            <a:pPr/>
+            <a:endParaRPr/>
+          </a:p>
         </p:txBody>
       </p:sp>
       <p:sp>
@@ -10345,7 +10492,10 @@
         </p:spPr>
         <p:txBody>
           <a:bodyPr/>
-          <a:p/>
+          <a:p>
+            <a:pPr/>
+            <a:endParaRPr/>
+          </a:p>
         </p:txBody>
       </p:sp>
       <p:sp>
@@ -10432,7 +10582,7 @@
   <p:cSld>
     <p:spTree>
       <p:nvGrpSpPr>
-        <p:cNvPr id="272" name="" descr="&lt;Slide style={{ width: 1280, height: 720, background: '#07060B', padding: '20px 72px', display: 'flex', flexDirection: 'column' }}&gt;&#13;&#10;    &lt;Box style={{ height: 100, flexDirection: 'row', justifyContent: 'space-between', alignItems: 'flex-start' }}&gt;&#13;&#10;        &lt;Box style={{ display: 'flex', flexDirection: 'column', gap: 8 }}&gt;&#13;&#10;            &lt;Text style={{ fontSize: 12, fontWeight: 'bold', color: '#F2C96D', letterSpacing: 2.4 }}&gt;THE MELTDOWN&lt;/Text&gt;&#13;&#10;            &lt;Text style={{ fontSize: 38, fontFamily: 'Impact', color: '#F7F1E8', lineHeight: 1.1 }}&gt;One button ruins the group chat.&lt;/Text&gt;&#13;&#10;        &lt;/Box&gt;&#13;&#10;        &lt;Text style={{ fontSize: 13, color: 'rgba(247,241,232,0.5)', letterSpacing: 1.6, paddingTop: 6 }}&gt;HOST-ONLY · 20-TICK COOLDOWN&lt;/Text&gt;&#13;&#10;    &lt;/Box&gt;&#13;&#10;&#13;&#10;    &lt;Box style={{ height: 480, marginTop: 20, flexDirection: 'row', gap: 36 }}&gt;&#13;&#10;        &lt;Box style={{ width: 604, display: 'flex', flexDirection: 'column', gap: 14 }}&gt;&#13;&#10;            &lt;Image src=&quot;assets/06-meltdown.png&quot; style={{ width: 604, height: 378, objectFit: 'cover', border: '1px solid rgba(231,53,85,0.35)', borderRadius: 10, boxShadow: '0 24px 60px rgba(0,0,0,0.55)' }} /&gt;&#13;&#10;            &lt;Text style={{ fontSize: 15, color: 'rgba(247,241,232,0.62)', lineHeight: 1.5 }}&gt;The House re-quotes mid-crash. Resting player orders fill at the new quote — limit-or-better — while the tape keeps printing.&lt;/Text&gt;&#13;&#10;        &lt;/Box&gt;&#13;&#10;&#13;&#10;        &lt;Box style={{ flex: 1, display: 'flex', flexDirection: 'column', justifyContent: 'space-between' }}&gt;&#13;&#10;            &lt;Box style={{ display: 'flex', flexDirection: 'column', gap: 6 }}&gt;&#13;&#10;                &lt;Text style={{ fontSize: 13, fontWeight: 'bold', color: 'rgba(247,241,232,0.55)', letterSpacing: 2 }}&gt;NET EQUITY, ONE TICK AFTER THE SHOCK&lt;/Text&gt;&#13;&#10;                &lt;Box style={{ flexDirection: 'row', alignItems: 'baseline', gap: 16 }}&gt;&#13;&#10;                    &lt;Text style={{ fontSize: 62, fontWeight: 'bold', color: '#E73555', lineHeight: 1 }}&gt;₹98,775&lt;/Text&gt;&#13;&#10;                    &lt;Text style={{ fontSize: 24, fontWeight: 'bold', color: '#E73555' }}&gt;−1.23%&lt;/Text&gt;&#13;&#10;                &lt;/Box&gt;&#13;&#10;                &lt;Text style={{ fontSize: 16, color: 'rgba(247,241,232,0.65)' }}&gt;From ₹1,00,000 · severity 79/100 · a 25-share position held straight through it&lt;/Text&gt;&#13;&#10;            &lt;/Box&gt;&#13;&#10;&#13;&#10;            &lt;Box style={{ display: 'flex', flexDirection: 'column', gap: 6 }}&gt;&#13;&#10;                &lt;Text style={{ fontSize: 13, fontWeight: 'bold', color: 'rgba(247,241,232,0.55)', letterSpacing: 2 }}&gt;LEADERBOARD AT TICK 21 · MARKED TO THE SAME MID&lt;/Text&gt;&#13;&#10;                &lt;Box style={{ flexDirection: 'row', justifyContent: 'space-between', alignItems: 'baseline', padding: '9px 0', borderBottom: '1px solid rgba(247,241,232,0.12)' }}&gt;&#13;&#10;                    &lt;Text style={{ fontSize: 17, color: '#F7F1E8' }}&gt;1 · Reversion Rita&lt;/Text&gt;&#13;&#10;                    &lt;Text style={{ fontSize: 17, fontWeight: 'bold', color: 'rgba(247,241,232,0.8)' }}&gt;₹99,812 · −0.19%&lt;/Text&gt;&#13;&#10;                &lt;/Box&gt;&#13;&#10;                &lt;Box style={{ flexDirection: 'row', justifyContent: 'space-between', alignItems: 'baseline', padding: '9px 0', borderBottom: '1px solid rgba(247,241,232,0.12)' }}&gt;&#13;&#10;                    &lt;Text style={{ fontSize: 17, color: '#F7F1E8' }}&gt;2 · Momentum Mick&lt;/Text&gt;&#13;&#10;                    &lt;Text style={{ fontSize: 17, fontWeight: 'bold', color: 'rgba(247,241,232,0.8)' }}&gt;₹99,618 · −0.38%&lt;/Text&gt;&#13;&#10;                &lt;/Box&gt;&#13;&#10;                &lt;Box style={{ flexDirection: 'row', justifyContent: 'space-between', alignItems: 'baseline', padding: '9px 0' }}&gt;&#13;&#10;                    &lt;Text style={{ fontSize: 17, color: '#F7F1E8' }}&gt;3 · You&lt;/Text&gt;&#13;&#10;                    &lt;Text style={{ fontSize: 17, fontWeight: 'bold', color: '#E73555' }}&gt;₹98,984 · −1.00%&lt;/Text&gt;&#13;&#10;                &lt;/Box&gt;&#13;&#10;            &lt;/Box&gt;&#13;&#10;&#13;&#10;            &lt;Text style={{ fontSize: 15, color: 'rgba(247,241,232,0.6)', lineHeight: 1.5 }}&gt;All three equity curves cross inside the crash window. Nobody is repriced later, and nobody is repriced privately.&lt;/Text&gt;&#13;&#10;        &lt;/Box&gt;&#13;&#10;    &lt;/Box&gt;&#13;&#10;&#13;&#10;    &lt;Box style={{ height: 60, marginTop: 20, flexDirection: 'row', justifyContent: 'space-between', alignItems: 'flex-end', borderTop: '1px solid rgba(247,241,232,0.10)', paddingTop: 12 }}&gt;&#13;&#10;        &lt;Text style={{ fontSize: 13, color: 'rgba(247,241,232,0.45)' }}&gt;BROKE VEGAS · fictional markets, virtual money&lt;/Text&gt;&#13;&#10;        &lt;Text style={{ fontSize: 13, color: 'rgba(247,241,232,0.45)' }}&gt;08 / 12&lt;/Text&gt;&#13;&#10;    &lt;/Box&gt;&#13;&#10;&lt;/Slide&gt;&#13;&#10;"/>
+        <p:cNvPr id="272" name=""/>
         <p:cNvGrpSpPr/>
         <p:nvPr/>
       </p:nvGrpSpPr>
@@ -10465,7 +10615,10 @@
         </p:spPr>
         <p:txBody>
           <a:bodyPr/>
-          <a:p/>
+          <a:p>
+            <a:pPr/>
+            <a:endParaRPr/>
+          </a:p>
         </p:txBody>
       </p:sp>
       <p:sp>
@@ -10600,7 +10753,10 @@
         </p:spPr>
         <p:txBody>
           <a:bodyPr/>
-          <a:p/>
+          <a:p>
+            <a:pPr/>
+            <a:endParaRPr/>
+          </a:p>
         </p:txBody>
       </p:sp>
       <p:pic>
@@ -10899,7 +11055,10 @@
         </p:spPr>
         <p:txBody>
           <a:bodyPr/>
-          <a:p/>
+          <a:p>
+            <a:pPr/>
+            <a:endParaRPr/>
+          </a:p>
         </p:txBody>
       </p:sp>
       <p:sp>
@@ -11013,7 +11172,10 @@
         </p:spPr>
         <p:txBody>
           <a:bodyPr/>
-          <a:p/>
+          <a:p>
+            <a:pPr/>
+            <a:endParaRPr/>
+          </a:p>
         </p:txBody>
       </p:sp>
       <p:sp>
@@ -11236,7 +11398,10 @@
         </p:spPr>
         <p:txBody>
           <a:bodyPr/>
-          <a:p/>
+          <a:p>
+            <a:pPr/>
+            <a:endParaRPr/>
+          </a:p>
         </p:txBody>
       </p:sp>
       <p:sp>
@@ -11323,7 +11488,7 @@
   <p:cSld>
     <p:spTree>
       <p:nvGrpSpPr>
-        <p:cNvPr id="297" name="" descr="&lt;Slide style={{ width: 1280, height: 720, background: '#07060B', padding: '20px 72px', display: 'flex', flexDirection: 'column' }}&gt;&#13;&#10;    &lt;Box style={{ height: 100, flexDirection: 'row', justifyContent: 'space-between', alignItems: 'flex-start' }}&gt;&#13;&#10;        &lt;Box style={{ display: 'flex', flexDirection: 'column', gap: 8 }}&gt;&#13;&#10;            &lt;Text style={{ fontSize: 12, fontWeight: 'bold', color: '#F2C96D', letterSpacing: 2.4 }}&gt;VERIFICATION&lt;/Text&gt;&#13;&#10;            &lt;Text style={{ fontSize: 38, fontFamily: 'Impact', color: '#F7F1E8', lineHeight: 1.1 }}&gt;Don't trust the dealer. Replay him.&lt;/Text&gt;&#13;&#10;        &lt;/Box&gt;&#13;&#10;        &lt;Text style={{ fontSize: 13, color: 'rgba(247,241,232,0.5)', letterSpacing: 1.6, paddingTop: 6 }}&gt;EVENT-SOURCED · HASH COMPARED&lt;/Text&gt;&#13;&#10;    &lt;/Box&gt;&#13;&#10;&#13;&#10;    &lt;Box style={{ height: 480, marginTop: 20, flexDirection: 'row', gap: 40 }}&gt;&#13;&#10;        &lt;Box style={{ width: 600, display: 'flex', flexDirection: 'column', justifyContent: 'space-between' }}&gt;&#13;&#10;            &lt;Box style={{ display: 'flex', flexDirection: 'column', gap: 16 }}&gt;&#13;&#10;                &lt;Text style={{ fontSize: 19, color: 'rgba(247,241,232,0.76)', lineHeight: 1.6 }}&gt;Every match records its seed, its intents and its ticks. The replay rebuilds the final state from that log alone and compares SHA-256 hashes. If they differ, the badge says so.&lt;/Text&gt;&#13;&#10;                &lt;Box style={{ display: 'flex', flexDirection: 'column', gap: 10, padding: '16px 18px', background: 'rgba(247,241,232,0.045)', border: '1px solid rgba(247,241,232,0.10)' }}&gt;&#13;&#10;                    &lt;Text style={{ fontSize: 12, color: 'rgba(247,241,232,0.5)', letterSpacing: 2 }}&gt;SEED COMMITMENT · SHA-256&lt;/Text&gt;&#13;&#10;                    &lt;Text style={{ fontSize: 14, color: '#F2C96D', letterSpacing: 0.6 }}&gt;4524bc66845f0df34c56b14cdc9df636&lt;/Text&gt;&#13;&#10;                    &lt;Text style={{ fontSize: 12, color: 'rgba(247,241,232,0.5)', letterSpacing: 2, marginTop: 4 }}&gt;REVEALED AFTER CLOSE&lt;/Text&gt;&#13;&#10;                    &lt;Text style={{ fontSize: 14, color: '#F7F1E8', letterSpacing: 0.6 }}&gt;demo-ONXBW-42&lt;/Text&gt;&#13;&#10;                &lt;/Box&gt;&#13;&#10;            &lt;/Box&gt;&#13;&#10;&#13;&#10;            &lt;Box style={{ display: 'flex', flexDirection: 'row', gap: 30 }}&gt;&#13;&#10;                &lt;Box style={{ display: 'flex', flexDirection: 'column', gap: 2 }}&gt;&#13;&#10;                    &lt;Text style={{ fontSize: 40, fontWeight: 'bold', color: '#F7F1E8', lineHeight: 1 }}&gt;12&lt;/Text&gt;&#13;&#10;                    &lt;Text style={{ fontSize: 13, color: 'rgba(247,241,232,0.55)', letterSpacing: 1.2 }}&gt;ENGINE TESTS PASSING&lt;/Text&gt;&#13;&#10;                &lt;/Box&gt;&#13;&#10;                &lt;Box style={{ display: 'flex', flexDirection: 'column', gap: 2 }}&gt;&#13;&#10;                    &lt;Text style={{ fontSize: 40, fontWeight: 'bold', color: '#F7F1E8', lineHeight: 1 }}&gt;0&lt;/Text&gt;&#13;&#10;                    &lt;Text style={{ fontSize: 13, color: 'rgba(247,241,232,0.55)', letterSpacing: 1.2 }}&gt;INVARIANT VIOLATIONS&lt;/Text&gt;&#13;&#10;                &lt;/Box&gt;&#13;&#10;                &lt;Box style={{ display: 'flex', flexDirection: 'column', gap: 2 }}&gt;&#13;&#10;                    &lt;Text style={{ fontSize: 40, fontWeight: 'bold', color: '#F7F1E8', lineHeight: 1 }}&gt;34&lt;/Text&gt;&#13;&#10;                    &lt;Text style={{ fontSize: 13, color: 'rgba(247,241,232,0.55)', letterSpacing: 1.2 }}&gt;LOG ENTRIES REPLAYED&lt;/Text&gt;&#13;&#10;                &lt;/Box&gt;&#13;&#10;            &lt;/Box&gt;&#13;&#10;        &lt;/Box&gt;&#13;&#10;&#13;&#10;        &lt;Box style={{ flex: 1, display: 'flex', flexDirection: 'column', gap: 12 }}&gt;&#13;&#10;            &lt;Image src=&quot;assets/09-replay.png&quot; style={{ width: 424, height: 400, objectFit: 'cover', objectPosition: 'top', border: '1px solid rgba(247,241,232,0.14)', borderRadius: 10 }} /&gt;&#13;&#10;            &lt;Text style={{ fontSize: 14, color: 'rgba(247,241,232,0.55)', lineHeight: 1.5 }}&gt;The replay screen, live: scrub the tape, watch the equity curves, confirm the hash.&lt;/Text&gt;&#13;&#10;        &lt;/Box&gt;&#13;&#10;    &lt;/Box&gt;&#13;&#10;&#13;&#10;    &lt;Box style={{ height: 60, marginTop: 20, flexDirection: 'row', justifyContent: 'space-between', alignItems: 'flex-end', borderTop: '1px solid rgba(247,241,232,0.10)', paddingTop: 12 }}&gt;&#13;&#10;        &lt;Text style={{ fontSize: 13, color: 'rgba(247,241,232,0.45)' }}&gt;BROKE VEGAS · fictional markets, virtual money&lt;/Text&gt;&#13;&#10;        &lt;Text style={{ fontSize: 13, color: 'rgba(247,241,232,0.45)' }}&gt;09 / 12&lt;/Text&gt;&#13;&#10;    &lt;/Box&gt;&#13;&#10;&lt;/Slide&gt;&#13;&#10;"/>
+        <p:cNvPr id="297" name=""/>
         <p:cNvGrpSpPr/>
         <p:nvPr/>
       </p:nvGrpSpPr>
@@ -11356,7 +11521,10 @@
         </p:spPr>
         <p:txBody>
           <a:bodyPr/>
-          <a:p/>
+          <a:p>
+            <a:pPr/>
+            <a:endParaRPr/>
+          </a:p>
         </p:txBody>
       </p:sp>
       <p:sp>
@@ -11535,7 +11703,10 @@
         </p:spPr>
         <p:txBody>
           <a:bodyPr/>
-          <a:p/>
+          <a:p>
+            <a:pPr/>
+            <a:endParaRPr/>
+          </a:p>
         </p:txBody>
       </p:sp>
       <p:sp>
@@ -11923,7 +12094,10 @@
         </p:spPr>
         <p:txBody>
           <a:bodyPr/>
-          <a:p/>
+          <a:p>
+            <a:pPr/>
+            <a:endParaRPr/>
+          </a:p>
         </p:txBody>
       </p:sp>
       <p:pic>
@@ -12032,7 +12206,10 @@
         </p:spPr>
         <p:txBody>
           <a:bodyPr/>
-          <a:p/>
+          <a:p>
+            <a:pPr/>
+            <a:endParaRPr/>
+          </a:p>
         </p:txBody>
       </p:sp>
       <p:sp>

</xml_diff>

<commit_message>
docs(deck): title slide carries the author block
</commit_message>
<xml_diff>
--- a/BROKE VEGAS/BROKE VEGAS.pptx
+++ b/BROKE VEGAS/BROKE VEGAS.pptx
@@ -1518,6 +1518,45 @@
           </a:p>
         </p:txBody>
       </p:sp>
+      <p:sp>
+        <p:nvSpPr>
+          <p:cNvPr id="20" name=""/>
+          <p:cNvSpPr/>
+          <p:nvPr/>
+        </p:nvSpPr>
+        <p:spPr>
+          <a:xfrm>
+            <a:off x="685800" y="5029200"/>
+            <a:ext cx="7112000" cy="190500"/>
+          </a:xfrm>
+          <a:prstGeom prst="rect">
+            <a:avLst/>
+          </a:prstGeom>
+          <a:noFill/>
+          <a:ln>
+            <a:noFill/>
+          </a:ln>
+        </p:spPr>
+        <p:txBody>
+          <a:bodyPr wrap="none">
+            <a:spAutoFit/>
+          </a:bodyPr>
+          <a:p>
+            <a:pPr/>
+            <a:r>
+              <a:rPr lang="zh-CN" sz="1000">
+                <a:solidFill>
+                  <a:srgbClr val="8F8A82"/>
+                </a:solidFill>
+                <a:latin typeface="Microsoft YaHei"/>
+                <a:ea typeface="Microsoft YaHei"/>
+              </a:rPr>
+              <a:t>VEDANT ANAND GUPTA · 2427010515 · MANIPAL UNIVERSITY JAIPUR · SECTION E</a:t>
+            </a:r>
+            <a:endParaRPr/>
+          </a:p>
+        </p:txBody>
+      </p:sp>
     </p:spTree>
   </p:cSld>
 </p:sld>
@@ -1528,7 +1567,7 @@
   <p:cSld>
     <p:spTree>
       <p:nvGrpSpPr>
-        <p:cNvPr id="20" name=""/>
+        <p:cNvPr id="21" name=""/>
         <p:cNvGrpSpPr/>
         <p:nvPr/>
       </p:nvGrpSpPr>
@@ -1542,7 +1581,7 @@
       </p:grpSpPr>
       <p:sp>
         <p:nvSpPr>
-          <p:cNvPr id="21" name=""/>
+          <p:cNvPr id="22" name=""/>
           <p:cNvSpPr/>
           <p:nvPr/>
         </p:nvSpPr>
@@ -1569,7 +1608,7 @@
       </p:sp>
       <p:sp>
         <p:nvSpPr>
-          <p:cNvPr id="22" name="" descr="{&quot;isTemplate&quot;:true,&quot;type&quot;:&quot;text&quot;}"/>
+          <p:cNvPr id="23" name="" descr="{&quot;isTemplate&quot;:true,&quot;type&quot;:&quot;text&quot;}"/>
           <p:cNvSpPr txBox="1"/>
           <p:nvPr/>
         </p:nvSpPr>
@@ -1604,7 +1643,7 @@
       </p:sp>
       <p:sp>
         <p:nvSpPr>
-          <p:cNvPr id="23" name="" descr="{&quot;isTemplate&quot;:true,&quot;type&quot;:&quot;text&quot;}"/>
+          <p:cNvPr id="24" name="" descr="{&quot;isTemplate&quot;:true,&quot;type&quot;:&quot;text&quot;}"/>
           <p:cNvSpPr txBox="1"/>
           <p:nvPr/>
         </p:nvSpPr>
@@ -1639,7 +1678,7 @@
       </p:sp>
       <p:sp>
         <p:nvSpPr>
-          <p:cNvPr id="24" name="" descr="{&quot;isTemplate&quot;:true,&quot;type&quot;:&quot;text&quot;}"/>
+          <p:cNvPr id="25" name="" descr="{&quot;isTemplate&quot;:true,&quot;type&quot;:&quot;text&quot;}"/>
           <p:cNvSpPr txBox="1"/>
           <p:nvPr/>
         </p:nvSpPr>
@@ -1676,7 +1715,7 @@
       </p:sp>
       <p:sp>
         <p:nvSpPr>
-          <p:cNvPr id="25" name=""/>
+          <p:cNvPr id="26" name=""/>
           <p:cNvSpPr/>
           <p:nvPr/>
         </p:nvSpPr>
@@ -1714,7 +1753,7 @@
       </p:sp>
       <p:sp>
         <p:nvSpPr>
-          <p:cNvPr id="26" name="" descr="{&quot;isTemplate&quot;:true,&quot;type&quot;:&quot;text&quot;}"/>
+          <p:cNvPr id="27" name="" descr="{&quot;isTemplate&quot;:true,&quot;type&quot;:&quot;text&quot;}"/>
           <p:cNvSpPr txBox="1"/>
           <p:nvPr/>
         </p:nvSpPr>
@@ -1749,7 +1788,7 @@
       </p:sp>
       <p:sp>
         <p:nvSpPr>
-          <p:cNvPr id="27" name="" descr="{&quot;isTemplate&quot;:true,&quot;type&quot;:&quot;text&quot;}"/>
+          <p:cNvPr id="28" name="" descr="{&quot;isTemplate&quot;:true,&quot;type&quot;:&quot;text&quot;}"/>
           <p:cNvSpPr txBox="1"/>
           <p:nvPr/>
         </p:nvSpPr>
@@ -1784,7 +1823,7 @@
       </p:sp>
       <p:sp>
         <p:nvSpPr>
-          <p:cNvPr id="28" name="" descr="{&quot;isTemplate&quot;:true,&quot;type&quot;:&quot;text&quot;}"/>
+          <p:cNvPr id="29" name="" descr="{&quot;isTemplate&quot;:true,&quot;type&quot;:&quot;text&quot;}"/>
           <p:cNvSpPr txBox="1"/>
           <p:nvPr/>
         </p:nvSpPr>
@@ -1823,7 +1862,7 @@
       </p:sp>
       <p:sp>
         <p:nvSpPr>
-          <p:cNvPr id="29" name=""/>
+          <p:cNvPr id="30" name=""/>
           <p:cNvSpPr/>
           <p:nvPr/>
         </p:nvSpPr>
@@ -1861,7 +1900,7 @@
       </p:sp>
       <p:sp>
         <p:nvSpPr>
-          <p:cNvPr id="30" name="" descr="{&quot;isTemplate&quot;:true,&quot;type&quot;:&quot;text&quot;}"/>
+          <p:cNvPr id="31" name="" descr="{&quot;isTemplate&quot;:true,&quot;type&quot;:&quot;text&quot;}"/>
           <p:cNvSpPr txBox="1"/>
           <p:nvPr/>
         </p:nvSpPr>
@@ -1896,7 +1935,7 @@
       </p:sp>
       <p:sp>
         <p:nvSpPr>
-          <p:cNvPr id="31" name="" descr="{&quot;isTemplate&quot;:true,&quot;type&quot;:&quot;text&quot;}"/>
+          <p:cNvPr id="32" name="" descr="{&quot;isTemplate&quot;:true,&quot;type&quot;:&quot;text&quot;}"/>
           <p:cNvSpPr txBox="1"/>
           <p:nvPr/>
         </p:nvSpPr>
@@ -1931,7 +1970,7 @@
       </p:sp>
       <p:sp>
         <p:nvSpPr>
-          <p:cNvPr id="32" name="" descr="{&quot;isTemplate&quot;:true,&quot;type&quot;:&quot;text&quot;}"/>
+          <p:cNvPr id="33" name="" descr="{&quot;isTemplate&quot;:true,&quot;type&quot;:&quot;text&quot;}"/>
           <p:cNvSpPr txBox="1"/>
           <p:nvPr/>
         </p:nvSpPr>
@@ -1970,7 +2009,7 @@
       </p:sp>
       <p:sp>
         <p:nvSpPr>
-          <p:cNvPr id="33" name=""/>
+          <p:cNvPr id="34" name=""/>
           <p:cNvSpPr/>
           <p:nvPr/>
         </p:nvSpPr>
@@ -2008,7 +2047,7 @@
       </p:sp>
       <p:sp>
         <p:nvSpPr>
-          <p:cNvPr id="34" name="" descr="{&quot;isTemplate&quot;:true,&quot;type&quot;:&quot;text&quot;}"/>
+          <p:cNvPr id="35" name="" descr="{&quot;isTemplate&quot;:true,&quot;type&quot;:&quot;text&quot;}"/>
           <p:cNvSpPr txBox="1"/>
           <p:nvPr/>
         </p:nvSpPr>
@@ -2043,7 +2082,7 @@
       </p:sp>
       <p:sp>
         <p:nvSpPr>
-          <p:cNvPr id="35" name="" descr="{&quot;isTemplate&quot;:true,&quot;type&quot;:&quot;text&quot;}"/>
+          <p:cNvPr id="36" name="" descr="{&quot;isTemplate&quot;:true,&quot;type&quot;:&quot;text&quot;}"/>
           <p:cNvSpPr txBox="1"/>
           <p:nvPr/>
         </p:nvSpPr>
@@ -2078,7 +2117,7 @@
       </p:sp>
       <p:sp>
         <p:nvSpPr>
-          <p:cNvPr id="36" name="" descr="{&quot;isTemplate&quot;:true,&quot;type&quot;:&quot;text&quot;}"/>
+          <p:cNvPr id="37" name="" descr="{&quot;isTemplate&quot;:true,&quot;type&quot;:&quot;text&quot;}"/>
           <p:cNvSpPr txBox="1"/>
           <p:nvPr/>
         </p:nvSpPr>
@@ -2117,7 +2156,7 @@
       </p:sp>
       <p:sp>
         <p:nvSpPr>
-          <p:cNvPr id="37" name=""/>
+          <p:cNvPr id="38" name=""/>
           <p:cNvSpPr/>
           <p:nvPr/>
         </p:nvSpPr>
@@ -2155,7 +2194,7 @@
       </p:sp>
       <p:sp>
         <p:nvSpPr>
-          <p:cNvPr id="38" name="" descr="{&quot;isTemplate&quot;:true,&quot;type&quot;:&quot;text&quot;}"/>
+          <p:cNvPr id="39" name="" descr="{&quot;isTemplate&quot;:true,&quot;type&quot;:&quot;text&quot;}"/>
           <p:cNvSpPr txBox="1"/>
           <p:nvPr/>
         </p:nvSpPr>
@@ -2190,7 +2229,7 @@
       </p:sp>
       <p:sp>
         <p:nvSpPr>
-          <p:cNvPr id="39" name="" descr="{&quot;isTemplate&quot;:true,&quot;type&quot;:&quot;text&quot;}"/>
+          <p:cNvPr id="40" name="" descr="{&quot;isTemplate&quot;:true,&quot;type&quot;:&quot;text&quot;}"/>
           <p:cNvSpPr txBox="1"/>
           <p:nvPr/>
         </p:nvSpPr>
@@ -2225,7 +2264,7 @@
       </p:sp>
       <p:sp>
         <p:nvSpPr>
-          <p:cNvPr id="40" name="" descr="{&quot;isTemplate&quot;:true,&quot;type&quot;:&quot;text&quot;}"/>
+          <p:cNvPr id="41" name="" descr="{&quot;isTemplate&quot;:true,&quot;type&quot;:&quot;text&quot;}"/>
           <p:cNvSpPr txBox="1"/>
           <p:nvPr/>
         </p:nvSpPr>
@@ -2264,7 +2303,7 @@
       </p:sp>
       <p:sp>
         <p:nvSpPr>
-          <p:cNvPr id="41" name=""/>
+          <p:cNvPr id="42" name=""/>
           <p:cNvSpPr/>
           <p:nvPr/>
         </p:nvSpPr>
@@ -2309,7 +2348,7 @@
       </p:sp>
       <p:sp>
         <p:nvSpPr>
-          <p:cNvPr id="42" name="" descr="{&quot;isTemplate&quot;:true,&quot;type&quot;:&quot;text&quot;}"/>
+          <p:cNvPr id="43" name="" descr="{&quot;isTemplate&quot;:true,&quot;type&quot;:&quot;text&quot;}"/>
           <p:cNvSpPr txBox="1"/>
           <p:nvPr/>
         </p:nvSpPr>
@@ -2344,7 +2383,7 @@
       </p:sp>
       <p:sp>
         <p:nvSpPr>
-          <p:cNvPr id="43" name="" descr="{&quot;isTemplate&quot;:true,&quot;type&quot;:&quot;text&quot;}"/>
+          <p:cNvPr id="44" name="" descr="{&quot;isTemplate&quot;:true,&quot;type&quot;:&quot;text&quot;}"/>
           <p:cNvSpPr txBox="1"/>
           <p:nvPr/>
         </p:nvSpPr>
@@ -2381,7 +2420,7 @@
       </p:sp>
       <p:sp>
         <p:nvSpPr>
-          <p:cNvPr id="44" name=""/>
+          <p:cNvPr id="45" name=""/>
           <p:cNvSpPr/>
           <p:nvPr/>
         </p:nvSpPr>
@@ -2426,7 +2465,7 @@
       </p:sp>
       <p:sp>
         <p:nvSpPr>
-          <p:cNvPr id="45" name="" descr="{&quot;isTemplate&quot;:true,&quot;type&quot;:&quot;text&quot;}"/>
+          <p:cNvPr id="46" name="" descr="{&quot;isTemplate&quot;:true,&quot;type&quot;:&quot;text&quot;}"/>
           <p:cNvSpPr txBox="1"/>
           <p:nvPr/>
         </p:nvSpPr>
@@ -2463,7 +2502,7 @@
       </p:sp>
       <p:sp>
         <p:nvSpPr>
-          <p:cNvPr id="46" name="" descr="{&quot;isTemplate&quot;:true,&quot;type&quot;:&quot;text&quot;}"/>
+          <p:cNvPr id="47" name="" descr="{&quot;isTemplate&quot;:true,&quot;type&quot;:&quot;text&quot;}"/>
           <p:cNvSpPr txBox="1"/>
           <p:nvPr/>
         </p:nvSpPr>
@@ -2508,7 +2547,7 @@
   <p:cSld>
     <p:spTree>
       <p:nvGrpSpPr>
-        <p:cNvPr id="47" name="" descr="&lt;Slide style={{ width: 1280, height: 720, background: '#07060B', padding: '20px 72px', display: 'flex', flexDirection: 'column' }}&gt;&#10;    &lt;Box style={{ height: 100, flexDirection: 'row', justifyContent: 'space-between', alignItems: 'flex-start' }}&gt;&#10;        &lt;Box style={{ display: 'flex', flexDirection: 'column', gap: 8 }}&gt;&#10;            &lt;Text style={{ fontSize: 12, fontWeight: 'bold', color: '#F2C96D', letterSpacing: 2.4 }}&gt;SHIPPING STATUS&lt;/Text&gt;&#10;            &lt;Text style={{ fontSize: 38, fontFamily: 'Impact', color: '#F7F1E8', lineHeight: 1.1 }}&gt;What is real, and what is not yet.&lt;/Text&gt;&#10;        &lt;/Box&gt;&#10;        &lt;Text style={{ fontSize: 13, color: 'rgba(247,241,232,0.5)', letterSpacing: 1.6, paddingTop: 6 }}&gt;NO INVENTED INTEGRATIONS&lt;/Text&gt;&#10;    &lt;/Box&gt;&#10;&#10;    &lt;Box style={{ height: 480, marginTop: 20, flexDirection: 'row', gap: 24 }}&gt;&#10;        &lt;Box style={{ width: 424, display: 'flex', flexDirection: 'column', gap: 14, padding: '20px 22px', background: 'rgba(247,241,232,0.06)', borderTop: '3px solid #F2C96D', border: '1px solid rgba(247,241,232,0.14)', borderRadius: 8 }}&gt;&#10;            &lt;Text style={{ fontSize: 12, fontWeight: 'bold', color: '#F2C96D', letterSpacing: 2.2 }}&gt;LIVE NOW&lt;/Text&gt;&#10;            &lt;Text style={{ fontSize: 20, fontWeight: 'bold', color: '#F7F1E8', lineHeight: 1.35 }}&gt;The whole game, playable in a browser&lt;/Text&gt;&#10;            &lt;Text style={{ fontSize: 15, color: 'rgba(247,241,232,0.72)', lineHeight: 1.55 }}&gt;Create a table, ready up, trade against two engine bots, fire the meltdown, end the match, then open the verified replay. Every screen in this deck was captured from that deployment.&lt;/Text&gt;&#10;            &lt;Box style={{ marginTop: 'auto', display: 'flex', flexDirection: 'column', gap: 6 }}&gt;&#10;                &lt;Text style={{ fontSize: 13, color: 'rgba(247,241,232,0.55)', letterSpacing: 1.2 }}&gt;vedinzen.github.io/broke-vegas&lt;/Text&gt;&#10;                &lt;Text style={{ fontSize: 13, color: 'rgba(247,241,232,0.55)', letterSpacing: 1.2 }}&gt;Typecheck clean · lint clean · 12 tests green&lt;/Text&gt;&#10;            &lt;/Box&gt;&#10;        &lt;/Box&gt;&#10;&#10;        &lt;Box style={{ width: 366, display: 'flex', flexDirection: 'column', gap: 14, padding: '20px 22px', background: 'rgba(247,241,232,0.035)', border: '1px solid rgba(247,241,232,0.12)', borderRadius: 8 }}&gt;&#10;            &lt;Text style={{ fontSize: 12, fontWeight: 'bold', color: 'rgba(247,241,232,0.62)', letterSpacing: 2.2 }}&gt;APPLIED, NOT WIRED&lt;/Text&gt;&#10;            &lt;Text style={{ fontSize: 20, fontWeight: 'bold', color: '#F7F1E8', lineHeight: 1.35 }}&gt;The multiplayer schema&lt;/Text&gt;&#10;            &lt;Text style={{ fontSize: 15, color: 'rgba(247,241,232,0.72)', lineHeight: 1.55 }}&gt;Two migrations are applied to a real Supabase project: 15 tables, row-level security on every public one, private membership helpers, and hardened RPCs for room creation and match start.&lt;/Text&gt;&#10;            &lt;Box style={{ marginTop: 'auto', display: 'flex', flexDirection: 'column', gap: 6 }}&gt;&#10;                &lt;Text style={{ fontSize: 13, color: 'rgba(247,241,232,0.55)', letterSpacing: 1.2 }}&gt;Live order writes need a service-role key&lt;/Text&gt;&#10;                &lt;Text style={{ fontSize: 13, color: 'rgba(247,241,232,0.55)', letterSpacing: 1.2 }}&gt;Anonymous auth is disabled on the project&lt;/Text&gt;&#10;            &lt;/Box&gt;&#10;        &lt;/Box&gt;&#10;&#10;        &lt;Box style={{ width: 298, display: 'flex', flexDirection: 'column', gap: 14, padding: '20px 22px', background: 'rgba(231,53,85,0.10)', border: '1px solid rgba(231,53,85,0.34)', borderRadius: 8 }}&gt;&#10;            &lt;Text style={{ fontSize: 12, fontWeight: 'bold', color: '#E73555', letterSpacing: 2.2 }}&gt;BLOCKED&lt;/Text&gt;&#10;            &lt;Text style={{ fontSize: 20, fontWeight: 'bold', color: '#F7F1E8', lineHeight: 1.35 }}&gt;Server routes on a static host&lt;/Text&gt;&#10;            &lt;Text style={{ fontSize: 15, color: 'rgba(247,241,232,0.75)', lineHeight: 1.55 }}&gt;GitHub Pages serves files only. The analyst route returns 404 there, so the Pit Boss falls back to its deterministic review: same numbers, no narration. Response headers cannot be set either, so the CSP ships only with the Node build.&lt;/Text&gt;&#10;            &lt;Box style={{ marginTop: 'auto', display: 'flex', flexDirection: 'column', gap: 6 }}&gt;&#10;                &lt;Text style={{ fontSize: 12, color: '#E73555', letterSpacing: 0.4, lineHeight: 1.5 }}&gt;GET /api/analyst → 404 on Pages&lt;/Text&gt;&#10;                &lt;Text style={{ fontSize: 12, color: 'rgba(247,241,232,0.6)', letterSpacing: 0.4, lineHeight: 1.5 }}&gt;The Netlify target restores the headers&lt;/Text&gt;&#10;            &lt;/Box&gt;&#10;        &lt;/Box&gt;&#10;    &lt;/Box&gt;&#10;&#10;    &lt;Box style={{ height: 60, marginTop: 20, flexDirection: 'row', justifyContent: 'space-between', alignItems: 'flex-end', borderTop: '1px solid rgba(247,241,232,0.10)', paddingTop: 12 }}&gt;&#10;        &lt;Text style={{ fontSize: 13, color: 'rgba(247,241,232,0.45)' }}&gt;BROKE VEGAS · fictional markets, virtual money&lt;/Text&gt;&#10;        &lt;Text style={{ fontSize: 13, color: 'rgba(247,241,232,0.45)' }}&gt;11 / 12&lt;/Text&gt;&#10;    &lt;/Box&gt;&#10;&lt;/Slide&gt;&#10;"/>
+        <p:cNvPr id="48" name="" descr="&lt;Slide style={{ width: 1280, height: 720, background: '#07060B', padding: '20px 72px', display: 'flex', flexDirection: 'column' }}&gt;&#10;    &lt;Box style={{ height: 100, flexDirection: 'row', justifyContent: 'space-between', alignItems: 'flex-start' }}&gt;&#10;        &lt;Box style={{ display: 'flex', flexDirection: 'column', gap: 8 }}&gt;&#10;            &lt;Text style={{ fontSize: 12, fontWeight: 'bold', color: '#F2C96D', letterSpacing: 2.4 }}&gt;SHIPPING STATUS&lt;/Text&gt;&#10;            &lt;Text style={{ fontSize: 38, fontFamily: 'Impact', color: '#F7F1E8', lineHeight: 1.1 }}&gt;What is real, and what is not yet.&lt;/Text&gt;&#10;        &lt;/Box&gt;&#10;        &lt;Text style={{ fontSize: 13, color: 'rgba(247,241,232,0.5)', letterSpacing: 1.6, paddingTop: 6 }}&gt;NO INVENTED INTEGRATIONS&lt;/Text&gt;&#10;    &lt;/Box&gt;&#10;&#10;    &lt;Box style={{ height: 480, marginTop: 20, flexDirection: 'row', gap: 24 }}&gt;&#10;        &lt;Box style={{ width: 424, display: 'flex', flexDirection: 'column', gap: 14, padding: '20px 22px', background: 'rgba(247,241,232,0.06)', borderTop: '3px solid #F2C96D', border: '1px solid rgba(247,241,232,0.14)', borderRadius: 8 }}&gt;&#10;            &lt;Text style={{ fontSize: 12, fontWeight: 'bold', color: '#F2C96D', letterSpacing: 2.2 }}&gt;LIVE NOW&lt;/Text&gt;&#10;            &lt;Text style={{ fontSize: 20, fontWeight: 'bold', color: '#F7F1E8', lineHeight: 1.35 }}&gt;The whole game, playable in a browser&lt;/Text&gt;&#10;            &lt;Text style={{ fontSize: 15, color: 'rgba(247,241,232,0.72)', lineHeight: 1.55 }}&gt;Create a table, ready up, trade against two engine bots, fire the meltdown, end the match, then open the verified replay. Every screen in this deck was captured from that deployment.&lt;/Text&gt;&#10;            &lt;Box style={{ marginTop: 'auto', display: 'flex', flexDirection: 'column', gap: 6 }}&gt;&#10;                &lt;Text style={{ fontSize: 13, color: 'rgba(247,241,232,0.55)', letterSpacing: 1.2 }}&gt;vedinzen.github.io/broke-vegas&lt;/Text&gt;&#10;                &lt;Text style={{ fontSize: 13, color: 'rgba(247,241,232,0.55)', letterSpacing: 1.2 }}&gt;Typecheck clean · lint clean · 12 tests green&lt;/Text&gt;&#10;            &lt;/Box&gt;&#10;        &lt;/Box&gt;&#10;&#10;        &lt;Box style={{ width: 366, display: 'flex', flexDirection: 'column', gap: 14, padding: '20px 22px', background: 'rgba(247,241,232,0.035)', border: '1px solid rgba(247,241,232,0.12)', borderRadius: 8 }}&gt;&#10;            &lt;Text style={{ fontSize: 12, fontWeight: 'bold', color: 'rgba(247,241,232,0.62)', letterSpacing: 2.2 }}&gt;APPLIED, NOT WIRED&lt;/Text&gt;&#10;            &lt;Text style={{ fontSize: 20, fontWeight: 'bold', color: '#F7F1E8', lineHeight: 1.35 }}&gt;The multiplayer schema&lt;/Text&gt;&#10;            &lt;Text style={{ fontSize: 15, color: 'rgba(247,241,232,0.72)', lineHeight: 1.55 }}&gt;Two migrations are applied to a real Supabase project: 15 tables, row-level security on every public one, private membership helpers, and hardened RPCs for room creation and match start.&lt;/Text&gt;&#10;            &lt;Box style={{ marginTop: 'auto', display: 'flex', flexDirection: 'column', gap: 6 }}&gt;&#10;                &lt;Text style={{ fontSize: 13, color: 'rgba(247,241,232,0.55)', letterSpacing: 1.2 }}&gt;Live order writes need a service-role key&lt;/Text&gt;&#10;                &lt;Text style={{ fontSize: 13, color: 'rgba(247,241,232,0.55)', letterSpacing: 1.2 }}&gt;Anonymous auth is disabled on the project&lt;/Text&gt;&#10;            &lt;/Box&gt;&#10;        &lt;/Box&gt;&#10;&#10;        &lt;Box style={{ width: 298, display: 'flex', flexDirection: 'column', gap: 14, padding: '20px 22px', background: 'rgba(231,53,85,0.10)', border: '1px solid rgba(231,53,85,0.34)', borderRadius: 8 }}&gt;&#10;            &lt;Text style={{ fontSize: 12, fontWeight: 'bold', color: '#E73555', letterSpacing: 2.2 }}&gt;BLOCKED&lt;/Text&gt;&#10;            &lt;Text style={{ fontSize: 20, fontWeight: 'bold', color: '#F7F1E8', lineHeight: 1.35 }}&gt;Server routes on a static host&lt;/Text&gt;&#10;            &lt;Text style={{ fontSize: 15, color: 'rgba(247,241,232,0.75)', lineHeight: 1.55 }}&gt;GitHub Pages serves files only. The analyst route returns 404 there, so the Pit Boss falls back to its deterministic review: same numbers, no narration. Response headers cannot be set either, so the CSP ships only with the Node build.&lt;/Text&gt;&#10;            &lt;Box style={{ marginTop: 'auto', display: 'flex', flexDirection: 'column', gap: 6 }}&gt;&#10;                &lt;Text style={{ fontSize: 12, color: '#E73555', letterSpacing: 0.4, lineHeight: 1.5 }}&gt;GET /api/analyst → 404 on Pages&lt;/Text&gt;&#10;                &lt;Text style={{ fontSize: 12, color: 'rgba(247,241,232,0.6)', letterSpacing: 0.4, lineHeight: 1.5 }}&gt;The Netlify target restores the headers&lt;/Text&gt;&#10;            &lt;/Box&gt;&#10;        &lt;/Box&gt;&#10;    &lt;/Box&gt;&#10;&#10;    &lt;Box style={{ height: 60, marginTop: 20, flexDirection: 'row', justifyContent: 'space-between', alignItems: 'flex-end', borderTop: '1px solid rgba(247,241,232,0.10)', paddingTop: 12 }}&gt;&#10;        &lt;Text style={{ fontSize: 13, color: 'rgba(247,241,232,0.45)' }}&gt;BROKE VEGAS · fictional markets, virtual money&lt;/Text&gt;&#10;        &lt;Text style={{ fontSize: 13, color: 'rgba(247,241,232,0.45)' }}&gt;11 / 12&lt;/Text&gt;&#10;    &lt;/Box&gt;&#10;&lt;/Slide&gt;&#10;"/>
         <p:cNvGrpSpPr/>
         <p:nvPr/>
       </p:nvGrpSpPr>
@@ -2522,7 +2561,7 @@
       </p:grpSpPr>
       <p:sp>
         <p:nvSpPr>
-          <p:cNvPr id="48" name=""/>
+          <p:cNvPr id="49" name=""/>
           <p:cNvSpPr/>
           <p:nvPr/>
         </p:nvSpPr>
@@ -2546,7 +2585,7 @@
       </p:sp>
       <p:sp>
         <p:nvSpPr>
-          <p:cNvPr id="49" name="" descr="{&quot;isTemplate&quot;:true,&quot;type&quot;:&quot;text&quot;}"/>
+          <p:cNvPr id="50" name="" descr="{&quot;isTemplate&quot;:true,&quot;type&quot;:&quot;text&quot;}"/>
           <p:cNvSpPr txBox="1"/>
           <p:nvPr/>
         </p:nvSpPr>
@@ -2581,7 +2620,7 @@
       </p:sp>
       <p:sp>
         <p:nvSpPr>
-          <p:cNvPr id="50" name="" descr="{&quot;isTemplate&quot;:true,&quot;type&quot;:&quot;text&quot;}"/>
+          <p:cNvPr id="51" name="" descr="{&quot;isTemplate&quot;:true,&quot;type&quot;:&quot;text&quot;}"/>
           <p:cNvSpPr txBox="1"/>
           <p:nvPr/>
         </p:nvSpPr>
@@ -2616,7 +2655,7 @@
       </p:sp>
       <p:sp>
         <p:nvSpPr>
-          <p:cNvPr id="51" name="" descr="{&quot;isTemplate&quot;:true,&quot;type&quot;:&quot;text&quot;}"/>
+          <p:cNvPr id="52" name="" descr="{&quot;isTemplate&quot;:true,&quot;type&quot;:&quot;text&quot;}"/>
           <p:cNvSpPr txBox="1"/>
           <p:nvPr/>
         </p:nvSpPr>
@@ -2653,7 +2692,7 @@
       </p:sp>
       <p:sp>
         <p:nvSpPr>
-          <p:cNvPr id="52" name=""/>
+          <p:cNvPr id="53" name=""/>
           <p:cNvSpPr/>
           <p:nvPr/>
         </p:nvSpPr>
@@ -2681,7 +2720,7 @@
       </p:sp>
       <p:sp>
         <p:nvSpPr>
-          <p:cNvPr id="53" name=""/>
+          <p:cNvPr id="54" name=""/>
           <p:cNvSpPr/>
           <p:nvPr/>
         </p:nvSpPr>
@@ -2738,7 +2777,7 @@
       </p:sp>
       <p:sp>
         <p:nvSpPr>
-          <p:cNvPr id="54" name="" descr="{&quot;isTemplate&quot;:true,&quot;type&quot;:&quot;text&quot;}"/>
+          <p:cNvPr id="55" name="" descr="{&quot;isTemplate&quot;:true,&quot;type&quot;:&quot;text&quot;}"/>
           <p:cNvSpPr txBox="1"/>
           <p:nvPr/>
         </p:nvSpPr>
@@ -2773,7 +2812,7 @@
       </p:sp>
       <p:sp>
         <p:nvSpPr>
-          <p:cNvPr id="55" name="" descr="{&quot;isTemplate&quot;:true,&quot;type&quot;:&quot;text&quot;}"/>
+          <p:cNvPr id="56" name="" descr="{&quot;isTemplate&quot;:true,&quot;type&quot;:&quot;text&quot;}"/>
           <p:cNvSpPr txBox="1"/>
           <p:nvPr/>
         </p:nvSpPr>
@@ -2810,7 +2849,7 @@
       </p:sp>
       <p:sp>
         <p:nvSpPr>
-          <p:cNvPr id="56" name="" descr="{&quot;isTemplate&quot;:true,&quot;type&quot;:&quot;text&quot;}"/>
+          <p:cNvPr id="57" name="" descr="{&quot;isTemplate&quot;:true,&quot;type&quot;:&quot;text&quot;}"/>
           <p:cNvSpPr txBox="1"/>
           <p:nvPr/>
         </p:nvSpPr>
@@ -2849,7 +2888,7 @@
       </p:sp>
       <p:sp>
         <p:nvSpPr>
-          <p:cNvPr id="57" name="" descr="{&quot;isTemplate&quot;:true,&quot;type&quot;:&quot;text&quot;}"/>
+          <p:cNvPr id="58" name="" descr="{&quot;isTemplate&quot;:true,&quot;type&quot;:&quot;text&quot;}"/>
           <p:cNvSpPr txBox="1"/>
           <p:nvPr/>
         </p:nvSpPr>
@@ -2886,7 +2925,7 @@
       </p:sp>
       <p:sp>
         <p:nvSpPr>
-          <p:cNvPr id="58" name="" descr="{&quot;isTemplate&quot;:true,&quot;type&quot;:&quot;text&quot;}"/>
+          <p:cNvPr id="59" name="" descr="{&quot;isTemplate&quot;:true,&quot;type&quot;:&quot;text&quot;}"/>
           <p:cNvSpPr txBox="1"/>
           <p:nvPr/>
         </p:nvSpPr>
@@ -2923,7 +2962,7 @@
       </p:sp>
       <p:sp>
         <p:nvSpPr>
-          <p:cNvPr id="59" name=""/>
+          <p:cNvPr id="60" name=""/>
           <p:cNvSpPr/>
           <p:nvPr/>
         </p:nvSpPr>
@@ -2958,7 +2997,7 @@
       </p:sp>
       <p:sp>
         <p:nvSpPr>
-          <p:cNvPr id="60" name="" descr="{&quot;isTemplate&quot;:true,&quot;type&quot;:&quot;text&quot;}"/>
+          <p:cNvPr id="61" name="" descr="{&quot;isTemplate&quot;:true,&quot;type&quot;:&quot;text&quot;}"/>
           <p:cNvSpPr txBox="1"/>
           <p:nvPr/>
         </p:nvSpPr>
@@ -2995,7 +3034,7 @@
       </p:sp>
       <p:sp>
         <p:nvSpPr>
-          <p:cNvPr id="61" name="" descr="{&quot;isTemplate&quot;:true,&quot;type&quot;:&quot;text&quot;}"/>
+          <p:cNvPr id="62" name="" descr="{&quot;isTemplate&quot;:true,&quot;type&quot;:&quot;text&quot;}"/>
           <p:cNvSpPr txBox="1"/>
           <p:nvPr/>
         </p:nvSpPr>
@@ -3030,7 +3069,7 @@
       </p:sp>
       <p:sp>
         <p:nvSpPr>
-          <p:cNvPr id="62" name="" descr="{&quot;isTemplate&quot;:true,&quot;type&quot;:&quot;text&quot;}"/>
+          <p:cNvPr id="63" name="" descr="{&quot;isTemplate&quot;:true,&quot;type&quot;:&quot;text&quot;}"/>
           <p:cNvSpPr txBox="1"/>
           <p:nvPr/>
         </p:nvSpPr>
@@ -3069,7 +3108,7 @@
       </p:sp>
       <p:sp>
         <p:nvSpPr>
-          <p:cNvPr id="63" name="" descr="{&quot;isTemplate&quot;:true,&quot;type&quot;:&quot;text&quot;}"/>
+          <p:cNvPr id="64" name="" descr="{&quot;isTemplate&quot;:true,&quot;type&quot;:&quot;text&quot;}"/>
           <p:cNvSpPr txBox="1"/>
           <p:nvPr/>
         </p:nvSpPr>
@@ -3106,7 +3145,7 @@
       </p:sp>
       <p:sp>
         <p:nvSpPr>
-          <p:cNvPr id="64" name="" descr="{&quot;isTemplate&quot;:true,&quot;type&quot;:&quot;text&quot;}"/>
+          <p:cNvPr id="65" name="" descr="{&quot;isTemplate&quot;:true,&quot;type&quot;:&quot;text&quot;}"/>
           <p:cNvSpPr txBox="1"/>
           <p:nvPr/>
         </p:nvSpPr>
@@ -3143,7 +3182,7 @@
       </p:sp>
       <p:sp>
         <p:nvSpPr>
-          <p:cNvPr id="65" name=""/>
+          <p:cNvPr id="66" name=""/>
           <p:cNvSpPr/>
           <p:nvPr/>
         </p:nvSpPr>
@@ -3178,7 +3217,7 @@
       </p:sp>
       <p:sp>
         <p:nvSpPr>
-          <p:cNvPr id="66" name="" descr="{&quot;isTemplate&quot;:true,&quot;type&quot;:&quot;text&quot;}"/>
+          <p:cNvPr id="67" name="" descr="{&quot;isTemplate&quot;:true,&quot;type&quot;:&quot;text&quot;}"/>
           <p:cNvSpPr txBox="1"/>
           <p:nvPr/>
         </p:nvSpPr>
@@ -3213,7 +3252,7 @@
       </p:sp>
       <p:sp>
         <p:nvSpPr>
-          <p:cNvPr id="67" name="" descr="{&quot;isTemplate&quot;:true,&quot;type&quot;:&quot;text&quot;}"/>
+          <p:cNvPr id="68" name="" descr="{&quot;isTemplate&quot;:true,&quot;type&quot;:&quot;text&quot;}"/>
           <p:cNvSpPr txBox="1"/>
           <p:nvPr/>
         </p:nvSpPr>
@@ -3250,7 +3289,7 @@
       </p:sp>
       <p:sp>
         <p:nvSpPr>
-          <p:cNvPr id="68" name="" descr="{&quot;isTemplate&quot;:true,&quot;type&quot;:&quot;text&quot;}"/>
+          <p:cNvPr id="69" name="" descr="{&quot;isTemplate&quot;:true,&quot;type&quot;:&quot;text&quot;}"/>
           <p:cNvSpPr txBox="1"/>
           <p:nvPr/>
         </p:nvSpPr>
@@ -3289,7 +3328,7 @@
       </p:sp>
       <p:sp>
         <p:nvSpPr>
-          <p:cNvPr id="69" name="" descr="{&quot;isTemplate&quot;:true,&quot;type&quot;:&quot;text&quot;}"/>
+          <p:cNvPr id="70" name="" descr="{&quot;isTemplate&quot;:true,&quot;type&quot;:&quot;text&quot;}"/>
           <p:cNvSpPr txBox="1"/>
           <p:nvPr/>
         </p:nvSpPr>
@@ -3324,7 +3363,7 @@
       </p:sp>
       <p:sp>
         <p:nvSpPr>
-          <p:cNvPr id="70" name="" descr="{&quot;isTemplate&quot;:true,&quot;type&quot;:&quot;text&quot;}"/>
+          <p:cNvPr id="71" name="" descr="{&quot;isTemplate&quot;:true,&quot;type&quot;:&quot;text&quot;}"/>
           <p:cNvSpPr txBox="1"/>
           <p:nvPr/>
         </p:nvSpPr>
@@ -3361,7 +3400,7 @@
       </p:sp>
       <p:sp>
         <p:nvSpPr>
-          <p:cNvPr id="71" name=""/>
+          <p:cNvPr id="72" name=""/>
           <p:cNvSpPr/>
           <p:nvPr/>
         </p:nvSpPr>
@@ -3403,7 +3442,7 @@
       </p:sp>
       <p:sp>
         <p:nvSpPr>
-          <p:cNvPr id="72" name="" descr="{&quot;isTemplate&quot;:true,&quot;type&quot;:&quot;text&quot;}"/>
+          <p:cNvPr id="73" name="" descr="{&quot;isTemplate&quot;:true,&quot;type&quot;:&quot;text&quot;}"/>
           <p:cNvSpPr txBox="1"/>
           <p:nvPr/>
         </p:nvSpPr>
@@ -3440,7 +3479,7 @@
       </p:sp>
       <p:sp>
         <p:nvSpPr>
-          <p:cNvPr id="73" name="" descr="{&quot;isTemplate&quot;:true,&quot;type&quot;:&quot;text&quot;}"/>
+          <p:cNvPr id="74" name="" descr="{&quot;isTemplate&quot;:true,&quot;type&quot;:&quot;text&quot;}"/>
           <p:cNvSpPr txBox="1"/>
           <p:nvPr/>
         </p:nvSpPr>
@@ -3485,7 +3524,7 @@
   <p:cSld>
     <p:spTree>
       <p:nvGrpSpPr>
-        <p:cNvPr id="74" name=""/>
+        <p:cNvPr id="75" name=""/>
         <p:cNvGrpSpPr/>
         <p:nvPr/>
       </p:nvGrpSpPr>
@@ -3499,7 +3538,7 @@
       </p:grpSpPr>
       <p:sp>
         <p:nvSpPr>
-          <p:cNvPr id="75" name=""/>
+          <p:cNvPr id="76" name=""/>
           <p:cNvSpPr/>
           <p:nvPr/>
         </p:nvSpPr>
@@ -3526,7 +3565,7 @@
       </p:sp>
       <p:sp>
         <p:nvSpPr>
-          <p:cNvPr id="76" name=""/>
+          <p:cNvPr id="77" name=""/>
           <p:cNvSpPr/>
           <p:nvPr/>
         </p:nvSpPr>
@@ -3567,7 +3606,7 @@
       </p:sp>
       <p:sp>
         <p:nvSpPr>
-          <p:cNvPr id="77" name=""/>
+          <p:cNvPr id="78" name=""/>
           <p:cNvSpPr/>
           <p:nvPr/>
         </p:nvSpPr>
@@ -3594,7 +3633,7 @@
       </p:sp>
       <p:sp>
         <p:nvSpPr>
-          <p:cNvPr id="78" name=""/>
+          <p:cNvPr id="79" name=""/>
           <p:cNvSpPr/>
           <p:nvPr/>
         </p:nvSpPr>
@@ -3623,7 +3662,7 @@
       </p:sp>
       <p:sp>
         <p:nvSpPr>
-          <p:cNvPr id="79" name="" descr="{&quot;isTemplate&quot;:true,&quot;type&quot;:&quot;text&quot;}"/>
+          <p:cNvPr id="80" name="" descr="{&quot;isTemplate&quot;:true,&quot;type&quot;:&quot;text&quot;}"/>
           <p:cNvSpPr txBox="1"/>
           <p:nvPr/>
         </p:nvSpPr>
@@ -3658,7 +3697,7 @@
       </p:sp>
       <p:sp>
         <p:nvSpPr>
-          <p:cNvPr id="80" name="" descr="{&quot;isTemplate&quot;:true,&quot;type&quot;:&quot;text&quot;}"/>
+          <p:cNvPr id="81" name="" descr="{&quot;isTemplate&quot;:true,&quot;type&quot;:&quot;text&quot;}"/>
           <p:cNvSpPr txBox="1"/>
           <p:nvPr/>
         </p:nvSpPr>
@@ -3711,7 +3750,7 @@
       </p:sp>
       <p:sp>
         <p:nvSpPr>
-          <p:cNvPr id="81" name="" descr="{&quot;isTemplate&quot;:true,&quot;type&quot;:&quot;text&quot;}"/>
+          <p:cNvPr id="82" name="" descr="{&quot;isTemplate&quot;:true,&quot;type&quot;:&quot;text&quot;}"/>
           <p:cNvSpPr txBox="1"/>
           <p:nvPr/>
         </p:nvSpPr>
@@ -3750,7 +3789,7 @@
       </p:sp>
       <p:sp>
         <p:nvSpPr>
-          <p:cNvPr id="82" name=""/>
+          <p:cNvPr id="83" name=""/>
           <p:cNvSpPr/>
           <p:nvPr/>
         </p:nvSpPr>
@@ -3779,7 +3818,7 @@
       </p:sp>
       <p:sp>
         <p:nvSpPr>
-          <p:cNvPr id="83" name="" descr="{&quot;isTemplate&quot;:true,&quot;type&quot;:&quot;text&quot;}"/>
+          <p:cNvPr id="84" name="" descr="{&quot;isTemplate&quot;:true,&quot;type&quot;:&quot;text&quot;}"/>
           <p:cNvSpPr txBox="1"/>
           <p:nvPr/>
         </p:nvSpPr>
@@ -3816,7 +3855,7 @@
       </p:sp>
       <p:sp>
         <p:nvSpPr>
-          <p:cNvPr id="84" name="" descr="{&quot;isTemplate&quot;:true,&quot;type&quot;:&quot;text&quot;}"/>
+          <p:cNvPr id="85" name="" descr="{&quot;isTemplate&quot;:true,&quot;type&quot;:&quot;text&quot;}"/>
           <p:cNvSpPr txBox="1"/>
           <p:nvPr/>
         </p:nvSpPr>
@@ -3851,7 +3890,7 @@
       </p:sp>
       <p:sp>
         <p:nvSpPr>
-          <p:cNvPr id="85" name="" descr="{&quot;isTemplate&quot;:true,&quot;type&quot;:&quot;text&quot;}"/>
+          <p:cNvPr id="86" name="" descr="{&quot;isTemplate&quot;:true,&quot;type&quot;:&quot;text&quot;}"/>
           <p:cNvSpPr txBox="1"/>
           <p:nvPr/>
         </p:nvSpPr>
@@ -3888,7 +3927,7 @@
       </p:sp>
       <p:sp>
         <p:nvSpPr>
-          <p:cNvPr id="86" name="" descr="{&quot;isTemplate&quot;:true,&quot;type&quot;:&quot;text&quot;}"/>
+          <p:cNvPr id="87" name="" descr="{&quot;isTemplate&quot;:true,&quot;type&quot;:&quot;text&quot;}"/>
           <p:cNvSpPr txBox="1"/>
           <p:nvPr/>
         </p:nvSpPr>
@@ -3931,7 +3970,7 @@
   <p:cSld>
     <p:spTree>
       <p:nvGrpSpPr>
-        <p:cNvPr id="87" name=""/>
+        <p:cNvPr id="88" name=""/>
         <p:cNvGrpSpPr/>
         <p:nvPr/>
       </p:nvGrpSpPr>
@@ -3945,7 +3984,7 @@
       </p:grpSpPr>
       <p:sp>
         <p:nvSpPr>
-          <p:cNvPr id="88" name=""/>
+          <p:cNvPr id="89" name=""/>
           <p:cNvSpPr/>
           <p:nvPr/>
         </p:nvSpPr>
@@ -3972,7 +4011,7 @@
       </p:sp>
       <p:sp>
         <p:nvSpPr>
-          <p:cNvPr id="89" name="" descr="{&quot;isTemplate&quot;:true,&quot;type&quot;:&quot;text&quot;}"/>
+          <p:cNvPr id="90" name="" descr="{&quot;isTemplate&quot;:true,&quot;type&quot;:&quot;text&quot;}"/>
           <p:cNvSpPr txBox="1"/>
           <p:nvPr/>
         </p:nvSpPr>
@@ -4007,7 +4046,7 @@
       </p:sp>
       <p:sp>
         <p:nvSpPr>
-          <p:cNvPr id="90" name="" descr="{&quot;isTemplate&quot;:true,&quot;type&quot;:&quot;text&quot;}"/>
+          <p:cNvPr id="91" name="" descr="{&quot;isTemplate&quot;:true,&quot;type&quot;:&quot;text&quot;}"/>
           <p:cNvSpPr txBox="1"/>
           <p:nvPr/>
         </p:nvSpPr>
@@ -4042,7 +4081,7 @@
       </p:sp>
       <p:sp>
         <p:nvSpPr>
-          <p:cNvPr id="91" name="" descr="{&quot;isTemplate&quot;:true,&quot;type&quot;:&quot;text&quot;}"/>
+          <p:cNvPr id="92" name="" descr="{&quot;isTemplate&quot;:true,&quot;type&quot;:&quot;text&quot;}"/>
           <p:cNvSpPr txBox="1"/>
           <p:nvPr/>
         </p:nvSpPr>
@@ -4079,7 +4118,7 @@
       </p:sp>
       <p:sp>
         <p:nvSpPr>
-          <p:cNvPr id="92" name="" descr="{&quot;isTemplate&quot;:true,&quot;type&quot;:&quot;text&quot;}"/>
+          <p:cNvPr id="93" name="" descr="{&quot;isTemplate&quot;:true,&quot;type&quot;:&quot;text&quot;}"/>
           <p:cNvSpPr txBox="1"/>
           <p:nvPr/>
         </p:nvSpPr>
@@ -4116,7 +4155,7 @@
       </p:sp>
       <p:sp>
         <p:nvSpPr>
-          <p:cNvPr id="93" name="" descr="{&quot;isTemplate&quot;:true,&quot;type&quot;:&quot;text&quot;}"/>
+          <p:cNvPr id="94" name="" descr="{&quot;isTemplate&quot;:true,&quot;type&quot;:&quot;text&quot;}"/>
           <p:cNvSpPr txBox="1"/>
           <p:nvPr/>
         </p:nvSpPr>
@@ -4155,7 +4194,7 @@
       </p:sp>
       <p:sp>
         <p:nvSpPr>
-          <p:cNvPr id="94" name="" descr="{&quot;isTemplate&quot;:true,&quot;type&quot;:&quot;text&quot;}"/>
+          <p:cNvPr id="95" name="" descr="{&quot;isTemplate&quot;:true,&quot;type&quot;:&quot;text&quot;}"/>
           <p:cNvSpPr txBox="1"/>
           <p:nvPr/>
         </p:nvSpPr>
@@ -4192,7 +4231,7 @@
       </p:sp>
       <p:sp>
         <p:nvSpPr>
-          <p:cNvPr id="95" name=""/>
+          <p:cNvPr id="96" name=""/>
           <p:cNvSpPr/>
           <p:nvPr/>
         </p:nvSpPr>
@@ -4221,7 +4260,7 @@
       </p:sp>
       <p:sp>
         <p:nvSpPr>
-          <p:cNvPr id="96" name=""/>
+          <p:cNvPr id="97" name=""/>
           <p:cNvSpPr/>
           <p:nvPr/>
         </p:nvSpPr>
@@ -4264,7 +4303,7 @@
       </p:sp>
       <p:sp>
         <p:nvSpPr>
-          <p:cNvPr id="97" name="" descr="{&quot;isTemplate&quot;:true,&quot;type&quot;:&quot;text&quot;}"/>
+          <p:cNvPr id="98" name="" descr="{&quot;isTemplate&quot;:true,&quot;type&quot;:&quot;text&quot;}"/>
           <p:cNvSpPr txBox="1"/>
           <p:nvPr/>
         </p:nvSpPr>
@@ -4301,7 +4340,7 @@
       </p:sp>
       <p:sp>
         <p:nvSpPr>
-          <p:cNvPr id="98" name=""/>
+          <p:cNvPr id="99" name=""/>
           <p:cNvSpPr/>
           <p:nvPr/>
         </p:nvSpPr>
@@ -4346,7 +4385,7 @@
       </p:sp>
       <p:sp>
         <p:nvSpPr>
-          <p:cNvPr id="99" name="" descr="{&quot;isTemplate&quot;:true,&quot;type&quot;:&quot;text&quot;}"/>
+          <p:cNvPr id="100" name="" descr="{&quot;isTemplate&quot;:true,&quot;type&quot;:&quot;text&quot;}"/>
           <p:cNvSpPr txBox="1"/>
           <p:nvPr/>
         </p:nvSpPr>
@@ -4381,7 +4420,7 @@
       </p:sp>
       <p:sp>
         <p:nvSpPr>
-          <p:cNvPr id="100" name="" descr="{&quot;isTemplate&quot;:true,&quot;type&quot;:&quot;text&quot;}"/>
+          <p:cNvPr id="101" name="" descr="{&quot;isTemplate&quot;:true,&quot;type&quot;:&quot;text&quot;}"/>
           <p:cNvSpPr txBox="1"/>
           <p:nvPr/>
         </p:nvSpPr>
@@ -4416,7 +4455,7 @@
       </p:sp>
       <p:sp>
         <p:nvSpPr>
-          <p:cNvPr id="101" name="" descr="{&quot;isTemplate&quot;:true,&quot;type&quot;:&quot;text&quot;}"/>
+          <p:cNvPr id="102" name="" descr="{&quot;isTemplate&quot;:true,&quot;type&quot;:&quot;text&quot;}"/>
           <p:cNvSpPr txBox="1"/>
           <p:nvPr/>
         </p:nvSpPr>
@@ -4455,7 +4494,7 @@
       </p:sp>
       <p:sp>
         <p:nvSpPr>
-          <p:cNvPr id="102" name=""/>
+          <p:cNvPr id="103" name=""/>
           <p:cNvSpPr/>
           <p:nvPr/>
         </p:nvSpPr>
@@ -4500,7 +4539,7 @@
       </p:sp>
       <p:sp>
         <p:nvSpPr>
-          <p:cNvPr id="103" name="" descr="{&quot;isTemplate&quot;:true,&quot;type&quot;:&quot;text&quot;}"/>
+          <p:cNvPr id="104" name="" descr="{&quot;isTemplate&quot;:true,&quot;type&quot;:&quot;text&quot;}"/>
           <p:cNvSpPr txBox="1"/>
           <p:nvPr/>
         </p:nvSpPr>
@@ -4535,7 +4574,7 @@
       </p:sp>
       <p:sp>
         <p:nvSpPr>
-          <p:cNvPr id="104" name="" descr="{&quot;isTemplate&quot;:true,&quot;type&quot;:&quot;text&quot;}"/>
+          <p:cNvPr id="105" name="" descr="{&quot;isTemplate&quot;:true,&quot;type&quot;:&quot;text&quot;}"/>
           <p:cNvSpPr txBox="1"/>
           <p:nvPr/>
         </p:nvSpPr>
@@ -4570,7 +4609,7 @@
       </p:sp>
       <p:sp>
         <p:nvSpPr>
-          <p:cNvPr id="105" name="" descr="{&quot;isTemplate&quot;:true,&quot;type&quot;:&quot;text&quot;}"/>
+          <p:cNvPr id="106" name="" descr="{&quot;isTemplate&quot;:true,&quot;type&quot;:&quot;text&quot;}"/>
           <p:cNvSpPr txBox="1"/>
           <p:nvPr/>
         </p:nvSpPr>
@@ -4609,7 +4648,7 @@
       </p:sp>
       <p:sp>
         <p:nvSpPr>
-          <p:cNvPr id="106" name=""/>
+          <p:cNvPr id="107" name=""/>
           <p:cNvSpPr/>
           <p:nvPr/>
         </p:nvSpPr>
@@ -4654,7 +4693,7 @@
       </p:sp>
       <p:sp>
         <p:nvSpPr>
-          <p:cNvPr id="107" name="" descr="{&quot;isTemplate&quot;:true,&quot;type&quot;:&quot;text&quot;}"/>
+          <p:cNvPr id="108" name="" descr="{&quot;isTemplate&quot;:true,&quot;type&quot;:&quot;text&quot;}"/>
           <p:cNvSpPr txBox="1"/>
           <p:nvPr/>
         </p:nvSpPr>
@@ -4689,7 +4728,7 @@
       </p:sp>
       <p:sp>
         <p:nvSpPr>
-          <p:cNvPr id="108" name="" descr="{&quot;isTemplate&quot;:true,&quot;type&quot;:&quot;text&quot;}"/>
+          <p:cNvPr id="109" name="" descr="{&quot;isTemplate&quot;:true,&quot;type&quot;:&quot;text&quot;}"/>
           <p:cNvSpPr txBox="1"/>
           <p:nvPr/>
         </p:nvSpPr>
@@ -4724,7 +4763,7 @@
       </p:sp>
       <p:sp>
         <p:nvSpPr>
-          <p:cNvPr id="109" name="" descr="{&quot;isTemplate&quot;:true,&quot;type&quot;:&quot;text&quot;}"/>
+          <p:cNvPr id="110" name="" descr="{&quot;isTemplate&quot;:true,&quot;type&quot;:&quot;text&quot;}"/>
           <p:cNvSpPr txBox="1"/>
           <p:nvPr/>
         </p:nvSpPr>
@@ -4763,7 +4802,7 @@
       </p:sp>
       <p:sp>
         <p:nvSpPr>
-          <p:cNvPr id="110" name="" descr="{&quot;isTemplate&quot;:true,&quot;type&quot;:&quot;text&quot;}"/>
+          <p:cNvPr id="111" name="" descr="{&quot;isTemplate&quot;:true,&quot;type&quot;:&quot;text&quot;}"/>
           <p:cNvSpPr txBox="1"/>
           <p:nvPr/>
         </p:nvSpPr>
@@ -4798,7 +4837,7 @@
       </p:sp>
       <p:sp>
         <p:nvSpPr>
-          <p:cNvPr id="111" name="" descr="{&quot;isTemplate&quot;:true,&quot;type&quot;:&quot;text&quot;}"/>
+          <p:cNvPr id="112" name="" descr="{&quot;isTemplate&quot;:true,&quot;type&quot;:&quot;text&quot;}"/>
           <p:cNvSpPr txBox="1"/>
           <p:nvPr/>
         </p:nvSpPr>
@@ -4833,7 +4872,7 @@
       </p:sp>
       <p:sp>
         <p:nvSpPr>
-          <p:cNvPr id="112" name="" descr="{&quot;isTemplate&quot;:true,&quot;type&quot;:&quot;text&quot;}"/>
+          <p:cNvPr id="113" name="" descr="{&quot;isTemplate&quot;:true,&quot;type&quot;:&quot;text&quot;}"/>
           <p:cNvSpPr txBox="1"/>
           <p:nvPr/>
         </p:nvSpPr>
@@ -4872,7 +4911,7 @@
       </p:sp>
       <p:sp>
         <p:nvSpPr>
-          <p:cNvPr id="113" name=""/>
+          <p:cNvPr id="114" name=""/>
           <p:cNvSpPr/>
           <p:nvPr/>
         </p:nvSpPr>
@@ -4917,7 +4956,7 @@
       </p:sp>
       <p:sp>
         <p:nvSpPr>
-          <p:cNvPr id="114" name="" descr="{&quot;isTemplate&quot;:true,&quot;type&quot;:&quot;text&quot;}"/>
+          <p:cNvPr id="115" name="" descr="{&quot;isTemplate&quot;:true,&quot;type&quot;:&quot;text&quot;}"/>
           <p:cNvSpPr txBox="1"/>
           <p:nvPr/>
         </p:nvSpPr>
@@ -4954,7 +4993,7 @@
       </p:sp>
       <p:sp>
         <p:nvSpPr>
-          <p:cNvPr id="115" name="" descr="{&quot;isTemplate&quot;:true,&quot;type&quot;:&quot;text&quot;}"/>
+          <p:cNvPr id="116" name="" descr="{&quot;isTemplate&quot;:true,&quot;type&quot;:&quot;text&quot;}"/>
           <p:cNvSpPr txBox="1"/>
           <p:nvPr/>
         </p:nvSpPr>
@@ -4999,7 +5038,7 @@
   <p:cSld>
     <p:spTree>
       <p:nvGrpSpPr>
-        <p:cNvPr id="116" name=""/>
+        <p:cNvPr id="117" name=""/>
         <p:cNvGrpSpPr/>
         <p:nvPr/>
       </p:nvGrpSpPr>
@@ -5013,7 +5052,7 @@
       </p:grpSpPr>
       <p:sp>
         <p:nvSpPr>
-          <p:cNvPr id="117" name=""/>
+          <p:cNvPr id="118" name=""/>
           <p:cNvSpPr/>
           <p:nvPr/>
         </p:nvSpPr>
@@ -5040,7 +5079,7 @@
       </p:sp>
       <p:sp>
         <p:nvSpPr>
-          <p:cNvPr id="118" name="" descr="{&quot;isTemplate&quot;:true,&quot;type&quot;:&quot;text&quot;}"/>
+          <p:cNvPr id="119" name="" descr="{&quot;isTemplate&quot;:true,&quot;type&quot;:&quot;text&quot;}"/>
           <p:cNvSpPr txBox="1"/>
           <p:nvPr/>
         </p:nvSpPr>
@@ -5075,7 +5114,7 @@
       </p:sp>
       <p:sp>
         <p:nvSpPr>
-          <p:cNvPr id="119" name="" descr="{&quot;isTemplate&quot;:true,&quot;type&quot;:&quot;text&quot;}"/>
+          <p:cNvPr id="120" name="" descr="{&quot;isTemplate&quot;:true,&quot;type&quot;:&quot;text&quot;}"/>
           <p:cNvSpPr txBox="1"/>
           <p:nvPr/>
         </p:nvSpPr>
@@ -5110,7 +5149,7 @@
       </p:sp>
       <p:sp>
         <p:nvSpPr>
-          <p:cNvPr id="120" name="" descr="{&quot;isTemplate&quot;:true,&quot;type&quot;:&quot;text&quot;}"/>
+          <p:cNvPr id="121" name="" descr="{&quot;isTemplate&quot;:true,&quot;type&quot;:&quot;text&quot;}"/>
           <p:cNvSpPr txBox="1"/>
           <p:nvPr/>
         </p:nvSpPr>
@@ -5147,7 +5186,7 @@
       </p:sp>
       <p:sp>
         <p:nvSpPr>
-          <p:cNvPr id="121" name="" descr="{&quot;isTemplate&quot;:true,&quot;type&quot;:&quot;text&quot;}"/>
+          <p:cNvPr id="122" name="" descr="{&quot;isTemplate&quot;:true,&quot;type&quot;:&quot;text&quot;}"/>
           <p:cNvSpPr txBox="1"/>
           <p:nvPr/>
         </p:nvSpPr>
@@ -5182,7 +5221,7 @@
       </p:sp>
       <p:sp>
         <p:nvSpPr>
-          <p:cNvPr id="122" name="" descr="{&quot;isTemplate&quot;:true,&quot;type&quot;:&quot;text&quot;}"/>
+          <p:cNvPr id="123" name="" descr="{&quot;isTemplate&quot;:true,&quot;type&quot;:&quot;text&quot;}"/>
           <p:cNvSpPr txBox="1"/>
           <p:nvPr/>
         </p:nvSpPr>
@@ -5219,7 +5258,7 @@
       </p:sp>
       <p:sp>
         <p:nvSpPr>
-          <p:cNvPr id="123" name="" descr="{&quot;isTemplate&quot;:true,&quot;type&quot;:&quot;text&quot;}"/>
+          <p:cNvPr id="124" name="" descr="{&quot;isTemplate&quot;:true,&quot;type&quot;:&quot;text&quot;}"/>
           <p:cNvSpPr txBox="1"/>
           <p:nvPr/>
         </p:nvSpPr>
@@ -5254,7 +5293,7 @@
       </p:sp>
       <p:sp>
         <p:nvSpPr>
-          <p:cNvPr id="124" name="" descr="{&quot;isTemplate&quot;:true,&quot;type&quot;:&quot;text&quot;}"/>
+          <p:cNvPr id="125" name="" descr="{&quot;isTemplate&quot;:true,&quot;type&quot;:&quot;text&quot;}"/>
           <p:cNvSpPr txBox="1"/>
           <p:nvPr/>
         </p:nvSpPr>
@@ -5293,7 +5332,7 @@
       </p:sp>
       <p:sp>
         <p:nvSpPr>
-          <p:cNvPr id="125" name="" descr="{&quot;isTemplate&quot;:true,&quot;type&quot;:&quot;text&quot;}"/>
+          <p:cNvPr id="126" name="" descr="{&quot;isTemplate&quot;:true,&quot;type&quot;:&quot;text&quot;}"/>
           <p:cNvSpPr txBox="1"/>
           <p:nvPr/>
         </p:nvSpPr>
@@ -5328,7 +5367,7 @@
       </p:sp>
       <p:sp>
         <p:nvSpPr>
-          <p:cNvPr id="126" name="" descr="{&quot;isTemplate&quot;:true,&quot;type&quot;:&quot;text&quot;}"/>
+          <p:cNvPr id="127" name="" descr="{&quot;isTemplate&quot;:true,&quot;type&quot;:&quot;text&quot;}"/>
           <p:cNvSpPr txBox="1"/>
           <p:nvPr/>
         </p:nvSpPr>
@@ -5367,7 +5406,7 @@
       </p:sp>
       <p:sp>
         <p:nvSpPr>
-          <p:cNvPr id="127" name="" descr="{&quot;isTemplate&quot;:true,&quot;type&quot;:&quot;text&quot;}"/>
+          <p:cNvPr id="128" name="" descr="{&quot;isTemplate&quot;:true,&quot;type&quot;:&quot;text&quot;}"/>
           <p:cNvSpPr txBox="1"/>
           <p:nvPr/>
         </p:nvSpPr>
@@ -5402,7 +5441,7 @@
       </p:sp>
       <p:sp>
         <p:nvSpPr>
-          <p:cNvPr id="128" name="" descr="{&quot;isTemplate&quot;:true,&quot;type&quot;:&quot;text&quot;}"/>
+          <p:cNvPr id="129" name="" descr="{&quot;isTemplate&quot;:true,&quot;type&quot;:&quot;text&quot;}"/>
           <p:cNvSpPr txBox="1"/>
           <p:nvPr/>
         </p:nvSpPr>
@@ -5441,7 +5480,7 @@
       </p:sp>
       <p:sp>
         <p:nvSpPr>
-          <p:cNvPr id="129" name="" descr="{&quot;isTemplate&quot;:true,&quot;type&quot;:&quot;text&quot;}"/>
+          <p:cNvPr id="130" name="" descr="{&quot;isTemplate&quot;:true,&quot;type&quot;:&quot;text&quot;}"/>
           <p:cNvSpPr txBox="1"/>
           <p:nvPr/>
         </p:nvSpPr>
@@ -5476,7 +5515,7 @@
       </p:sp>
       <p:sp>
         <p:nvSpPr>
-          <p:cNvPr id="130" name="" descr="{&quot;isTemplate&quot;:true,&quot;type&quot;:&quot;text&quot;}"/>
+          <p:cNvPr id="131" name="" descr="{&quot;isTemplate&quot;:true,&quot;type&quot;:&quot;text&quot;}"/>
           <p:cNvSpPr txBox="1"/>
           <p:nvPr/>
         </p:nvSpPr>
@@ -5515,7 +5554,7 @@
       </p:sp>
       <p:graphicFrame>
         <p:nvGraphicFramePr>
-          <p:cNvPr id="131" name="131"/>
+          <p:cNvPr id="132" name="131"/>
           <p:cNvGraphicFramePr/>
           <p:nvPr/>
         </p:nvGraphicFramePr>
@@ -5531,7 +5570,7 @@
       </p:graphicFrame>
       <p:sp>
         <p:nvSpPr>
-          <p:cNvPr id="132" name="" descr="{&quot;isTemplate&quot;:true,&quot;type&quot;:&quot;text&quot;}"/>
+          <p:cNvPr id="133" name="" descr="{&quot;isTemplate&quot;:true,&quot;type&quot;:&quot;text&quot;}"/>
           <p:cNvSpPr txBox="1"/>
           <p:nvPr/>
         </p:nvSpPr>
@@ -5568,7 +5607,7 @@
       </p:sp>
       <p:sp>
         <p:nvSpPr>
-          <p:cNvPr id="133" name="" descr="{&quot;isTemplate&quot;:true,&quot;type&quot;:&quot;text&quot;}"/>
+          <p:cNvPr id="134" name="" descr="{&quot;isTemplate&quot;:true,&quot;type&quot;:&quot;text&quot;}"/>
           <p:cNvSpPr txBox="1"/>
           <p:nvPr/>
         </p:nvSpPr>
@@ -5603,7 +5642,7 @@
       </p:sp>
       <p:sp>
         <p:nvSpPr>
-          <p:cNvPr id="134" name=""/>
+          <p:cNvPr id="135" name=""/>
           <p:cNvSpPr/>
           <p:nvPr/>
         </p:nvSpPr>
@@ -5648,7 +5687,7 @@
       </p:sp>
       <p:sp>
         <p:nvSpPr>
-          <p:cNvPr id="135" name="" descr="{&quot;isTemplate&quot;:true,&quot;type&quot;:&quot;text&quot;}"/>
+          <p:cNvPr id="136" name="" descr="{&quot;isTemplate&quot;:true,&quot;type&quot;:&quot;text&quot;}"/>
           <p:cNvSpPr txBox="1"/>
           <p:nvPr/>
         </p:nvSpPr>
@@ -5685,7 +5724,7 @@
       </p:sp>
       <p:sp>
         <p:nvSpPr>
-          <p:cNvPr id="136" name="" descr="{&quot;isTemplate&quot;:true,&quot;type&quot;:&quot;text&quot;}"/>
+          <p:cNvPr id="137" name="" descr="{&quot;isTemplate&quot;:true,&quot;type&quot;:&quot;text&quot;}"/>
           <p:cNvSpPr txBox="1"/>
           <p:nvPr/>
         </p:nvSpPr>
@@ -5730,7 +5769,7 @@
   <p:cSld>
     <p:spTree>
       <p:nvGrpSpPr>
-        <p:cNvPr id="137" name=""/>
+        <p:cNvPr id="138" name=""/>
         <p:cNvGrpSpPr/>
         <p:nvPr/>
       </p:nvGrpSpPr>
@@ -5744,7 +5783,7 @@
       </p:grpSpPr>
       <p:sp>
         <p:nvSpPr>
-          <p:cNvPr id="138" name=""/>
+          <p:cNvPr id="139" name=""/>
           <p:cNvSpPr/>
           <p:nvPr/>
         </p:nvSpPr>
@@ -5771,7 +5810,7 @@
       </p:sp>
       <p:sp>
         <p:nvSpPr>
-          <p:cNvPr id="139" name="" descr="{&quot;isTemplate&quot;:true,&quot;type&quot;:&quot;text&quot;}"/>
+          <p:cNvPr id="140" name="" descr="{&quot;isTemplate&quot;:true,&quot;type&quot;:&quot;text&quot;}"/>
           <p:cNvSpPr txBox="1"/>
           <p:nvPr/>
         </p:nvSpPr>
@@ -5806,7 +5845,7 @@
       </p:sp>
       <p:sp>
         <p:nvSpPr>
-          <p:cNvPr id="140" name="" descr="{&quot;isTemplate&quot;:true,&quot;type&quot;:&quot;text&quot;}"/>
+          <p:cNvPr id="141" name="" descr="{&quot;isTemplate&quot;:true,&quot;type&quot;:&quot;text&quot;}"/>
           <p:cNvSpPr txBox="1"/>
           <p:nvPr/>
         </p:nvSpPr>
@@ -5841,7 +5880,7 @@
       </p:sp>
       <p:sp>
         <p:nvSpPr>
-          <p:cNvPr id="141" name="" descr="{&quot;isTemplate&quot;:true,&quot;type&quot;:&quot;text&quot;}"/>
+          <p:cNvPr id="142" name="" descr="{&quot;isTemplate&quot;:true,&quot;type&quot;:&quot;text&quot;}"/>
           <p:cNvSpPr txBox="1"/>
           <p:nvPr/>
         </p:nvSpPr>
@@ -5878,7 +5917,7 @@
       </p:sp>
       <p:sp>
         <p:nvSpPr>
-          <p:cNvPr id="142" name=""/>
+          <p:cNvPr id="143" name=""/>
           <p:cNvSpPr/>
           <p:nvPr/>
         </p:nvSpPr>
@@ -5916,7 +5955,7 @@
       </p:sp>
       <p:sp>
         <p:nvSpPr>
-          <p:cNvPr id="143" name=""/>
+          <p:cNvPr id="144" name=""/>
           <p:cNvSpPr/>
           <p:nvPr/>
         </p:nvSpPr>
@@ -5961,7 +6000,7 @@
       </p:sp>
       <p:sp>
         <p:nvSpPr>
-          <p:cNvPr id="144" name="" descr="{&quot;isTemplate&quot;:true,&quot;type&quot;:&quot;text&quot;}"/>
+          <p:cNvPr id="145" name="" descr="{&quot;isTemplate&quot;:true,&quot;type&quot;:&quot;text&quot;}"/>
           <p:cNvSpPr txBox="1"/>
           <p:nvPr/>
         </p:nvSpPr>
@@ -5996,7 +6035,7 @@
       </p:sp>
       <p:sp>
         <p:nvSpPr>
-          <p:cNvPr id="145" name="" descr="{&quot;isTemplate&quot;:true,&quot;type&quot;:&quot;text&quot;}"/>
+          <p:cNvPr id="146" name="" descr="{&quot;isTemplate&quot;:true,&quot;type&quot;:&quot;text&quot;}"/>
           <p:cNvSpPr txBox="1"/>
           <p:nvPr/>
         </p:nvSpPr>
@@ -6033,7 +6072,7 @@
       </p:sp>
       <p:sp>
         <p:nvSpPr>
-          <p:cNvPr id="146" name="" descr="{&quot;isTemplate&quot;:true,&quot;type&quot;:&quot;text&quot;}"/>
+          <p:cNvPr id="147" name="" descr="{&quot;isTemplate&quot;:true,&quot;type&quot;:&quot;text&quot;}"/>
           <p:cNvSpPr txBox="1"/>
           <p:nvPr/>
         </p:nvSpPr>
@@ -6068,7 +6107,7 @@
       </p:sp>
       <p:sp>
         <p:nvSpPr>
-          <p:cNvPr id="147" name="" descr="{&quot;isTemplate&quot;:true,&quot;type&quot;:&quot;text&quot;}"/>
+          <p:cNvPr id="148" name="" descr="{&quot;isTemplate&quot;:true,&quot;type&quot;:&quot;text&quot;}"/>
           <p:cNvSpPr txBox="1"/>
           <p:nvPr/>
         </p:nvSpPr>
@@ -6103,7 +6142,7 @@
       </p:sp>
       <p:sp>
         <p:nvSpPr>
-          <p:cNvPr id="148" name="" descr="{&quot;isTemplate&quot;:true,&quot;type&quot;:&quot;text&quot;}"/>
+          <p:cNvPr id="149" name="" descr="{&quot;isTemplate&quot;:true,&quot;type&quot;:&quot;text&quot;}"/>
           <p:cNvSpPr txBox="1"/>
           <p:nvPr/>
         </p:nvSpPr>
@@ -6138,7 +6177,7 @@
       </p:sp>
       <p:sp>
         <p:nvSpPr>
-          <p:cNvPr id="149" name="" descr="{&quot;isTemplate&quot;:true,&quot;type&quot;:&quot;text&quot;}"/>
+          <p:cNvPr id="150" name="" descr="{&quot;isTemplate&quot;:true,&quot;type&quot;:&quot;text&quot;}"/>
           <p:cNvSpPr txBox="1"/>
           <p:nvPr/>
         </p:nvSpPr>
@@ -6173,7 +6212,7 @@
       </p:sp>
       <p:sp>
         <p:nvSpPr>
-          <p:cNvPr id="150" name="" descr="{&quot;isTemplate&quot;:true,&quot;type&quot;:&quot;text&quot;}"/>
+          <p:cNvPr id="151" name="" descr="{&quot;isTemplate&quot;:true,&quot;type&quot;:&quot;text&quot;}"/>
           <p:cNvSpPr txBox="1"/>
           <p:nvPr/>
         </p:nvSpPr>
@@ -6208,7 +6247,7 @@
       </p:sp>
       <p:sp>
         <p:nvSpPr>
-          <p:cNvPr id="151" name="" descr="{&quot;isTemplate&quot;:true,&quot;type&quot;:&quot;text&quot;}"/>
+          <p:cNvPr id="152" name="" descr="{&quot;isTemplate&quot;:true,&quot;type&quot;:&quot;text&quot;}"/>
           <p:cNvSpPr txBox="1"/>
           <p:nvPr/>
         </p:nvSpPr>
@@ -6243,7 +6282,7 @@
       </p:sp>
       <p:sp>
         <p:nvSpPr>
-          <p:cNvPr id="152" name="" descr="{&quot;isTemplate&quot;:true,&quot;type&quot;:&quot;text&quot;}"/>
+          <p:cNvPr id="153" name="" descr="{&quot;isTemplate&quot;:true,&quot;type&quot;:&quot;text&quot;}"/>
           <p:cNvSpPr txBox="1"/>
           <p:nvPr/>
         </p:nvSpPr>
@@ -6278,7 +6317,7 @@
       </p:sp>
       <p:sp>
         <p:nvSpPr>
-          <p:cNvPr id="153" name="" descr="{&quot;isTemplate&quot;:true,&quot;type&quot;:&quot;text&quot;}"/>
+          <p:cNvPr id="154" name="" descr="{&quot;isTemplate&quot;:true,&quot;type&quot;:&quot;text&quot;}"/>
           <p:cNvSpPr txBox="1"/>
           <p:nvPr/>
         </p:nvSpPr>
@@ -6313,7 +6352,7 @@
       </p:sp>
       <p:sp>
         <p:nvSpPr>
-          <p:cNvPr id="154" name="" descr="{&quot;isTemplate&quot;:true,&quot;type&quot;:&quot;text&quot;}"/>
+          <p:cNvPr id="155" name="" descr="{&quot;isTemplate&quot;:true,&quot;type&quot;:&quot;text&quot;}"/>
           <p:cNvSpPr txBox="1"/>
           <p:nvPr/>
         </p:nvSpPr>
@@ -6348,7 +6387,7 @@
       </p:sp>
       <p:sp>
         <p:nvSpPr>
-          <p:cNvPr id="155" name="" descr="{&quot;isTemplate&quot;:true,&quot;type&quot;:&quot;text&quot;}"/>
+          <p:cNvPr id="156" name="" descr="{&quot;isTemplate&quot;:true,&quot;type&quot;:&quot;text&quot;}"/>
           <p:cNvSpPr txBox="1"/>
           <p:nvPr/>
         </p:nvSpPr>
@@ -6383,7 +6422,7 @@
       </p:sp>
       <p:sp>
         <p:nvSpPr>
-          <p:cNvPr id="156" name="" descr="{&quot;isTemplate&quot;:true,&quot;type&quot;:&quot;text&quot;}"/>
+          <p:cNvPr id="157" name="" descr="{&quot;isTemplate&quot;:true,&quot;type&quot;:&quot;text&quot;}"/>
           <p:cNvSpPr txBox="1"/>
           <p:nvPr/>
         </p:nvSpPr>
@@ -6418,7 +6457,7 @@
       </p:sp>
       <p:sp>
         <p:nvSpPr>
-          <p:cNvPr id="157" name="" descr="{&quot;isTemplate&quot;:true,&quot;type&quot;:&quot;text&quot;}"/>
+          <p:cNvPr id="158" name="" descr="{&quot;isTemplate&quot;:true,&quot;type&quot;:&quot;text&quot;}"/>
           <p:cNvSpPr txBox="1"/>
           <p:nvPr/>
         </p:nvSpPr>
@@ -6453,7 +6492,7 @@
       </p:sp>
       <p:sp>
         <p:nvSpPr>
-          <p:cNvPr id="158" name="" descr="{&quot;isTemplate&quot;:true,&quot;type&quot;:&quot;text&quot;}"/>
+          <p:cNvPr id="159" name="" descr="{&quot;isTemplate&quot;:true,&quot;type&quot;:&quot;text&quot;}"/>
           <p:cNvSpPr txBox="1"/>
           <p:nvPr/>
         </p:nvSpPr>
@@ -6488,7 +6527,7 @@
       </p:sp>
       <p:sp>
         <p:nvSpPr>
-          <p:cNvPr id="159" name="" descr="{&quot;isTemplate&quot;:true,&quot;type&quot;:&quot;text&quot;}"/>
+          <p:cNvPr id="160" name="" descr="{&quot;isTemplate&quot;:true,&quot;type&quot;:&quot;text&quot;}"/>
           <p:cNvSpPr txBox="1"/>
           <p:nvPr/>
         </p:nvSpPr>
@@ -6523,7 +6562,7 @@
       </p:sp>
       <p:sp>
         <p:nvSpPr>
-          <p:cNvPr id="160" name="" descr="{&quot;isTemplate&quot;:true,&quot;type&quot;:&quot;text&quot;}"/>
+          <p:cNvPr id="161" name="" descr="{&quot;isTemplate&quot;:true,&quot;type&quot;:&quot;text&quot;}"/>
           <p:cNvSpPr txBox="1"/>
           <p:nvPr/>
         </p:nvSpPr>
@@ -6558,7 +6597,7 @@
       </p:sp>
       <p:sp>
         <p:nvSpPr>
-          <p:cNvPr id="161" name="" descr="{&quot;isTemplate&quot;:true,&quot;type&quot;:&quot;text&quot;}"/>
+          <p:cNvPr id="162" name="" descr="{&quot;isTemplate&quot;:true,&quot;type&quot;:&quot;text&quot;}"/>
           <p:cNvSpPr txBox="1"/>
           <p:nvPr/>
         </p:nvSpPr>
@@ -6593,7 +6632,7 @@
       </p:sp>
       <p:sp>
         <p:nvSpPr>
-          <p:cNvPr id="162" name="" descr="{&quot;isTemplate&quot;:true,&quot;type&quot;:&quot;text&quot;}"/>
+          <p:cNvPr id="163" name="" descr="{&quot;isTemplate&quot;:true,&quot;type&quot;:&quot;text&quot;}"/>
           <p:cNvSpPr txBox="1"/>
           <p:nvPr/>
         </p:nvSpPr>
@@ -6628,7 +6667,7 @@
       </p:sp>
       <p:sp>
         <p:nvSpPr>
-          <p:cNvPr id="163" name="" descr="{&quot;isTemplate&quot;:true,&quot;type&quot;:&quot;text&quot;}"/>
+          <p:cNvPr id="164" name="" descr="{&quot;isTemplate&quot;:true,&quot;type&quot;:&quot;text&quot;}"/>
           <p:cNvSpPr txBox="1"/>
           <p:nvPr/>
         </p:nvSpPr>
@@ -6667,7 +6706,7 @@
       </p:sp>
       <p:sp>
         <p:nvSpPr>
-          <p:cNvPr id="164" name="" descr="{&quot;isTemplate&quot;:true,&quot;type&quot;:&quot;text&quot;}"/>
+          <p:cNvPr id="165" name="" descr="{&quot;isTemplate&quot;:true,&quot;type&quot;:&quot;text&quot;}"/>
           <p:cNvSpPr txBox="1"/>
           <p:nvPr/>
         </p:nvSpPr>
@@ -6702,7 +6741,7 @@
       </p:sp>
       <p:sp>
         <p:nvSpPr>
-          <p:cNvPr id="165" name="" descr="{&quot;isTemplate&quot;:true,&quot;type&quot;:&quot;text&quot;}"/>
+          <p:cNvPr id="166" name="" descr="{&quot;isTemplate&quot;:true,&quot;type&quot;:&quot;text&quot;}"/>
           <p:cNvSpPr txBox="1"/>
           <p:nvPr/>
         </p:nvSpPr>
@@ -6741,7 +6780,7 @@
       </p:sp>
       <p:sp>
         <p:nvSpPr>
-          <p:cNvPr id="166" name="" descr="{&quot;isTemplate&quot;:true,&quot;type&quot;:&quot;text&quot;}"/>
+          <p:cNvPr id="167" name="" descr="{&quot;isTemplate&quot;:true,&quot;type&quot;:&quot;text&quot;}"/>
           <p:cNvSpPr txBox="1"/>
           <p:nvPr/>
         </p:nvSpPr>
@@ -6776,7 +6815,7 @@
       </p:sp>
       <p:sp>
         <p:nvSpPr>
-          <p:cNvPr id="167" name="" descr="{&quot;isTemplate&quot;:true,&quot;type&quot;:&quot;text&quot;}"/>
+          <p:cNvPr id="168" name="" descr="{&quot;isTemplate&quot;:true,&quot;type&quot;:&quot;text&quot;}"/>
           <p:cNvSpPr txBox="1"/>
           <p:nvPr/>
         </p:nvSpPr>
@@ -6815,7 +6854,7 @@
       </p:sp>
       <p:sp>
         <p:nvSpPr>
-          <p:cNvPr id="168" name=""/>
+          <p:cNvPr id="169" name=""/>
           <p:cNvSpPr/>
           <p:nvPr/>
         </p:nvSpPr>
@@ -6844,7 +6883,7 @@
       </p:sp>
       <p:sp>
         <p:nvSpPr>
-          <p:cNvPr id="169" name=""/>
+          <p:cNvPr id="170" name=""/>
           <p:cNvSpPr/>
           <p:nvPr/>
         </p:nvSpPr>
@@ -6887,7 +6926,7 @@
       </p:sp>
       <p:sp>
         <p:nvSpPr>
-          <p:cNvPr id="170" name="" descr="{&quot;isTemplate&quot;:true,&quot;type&quot;:&quot;text&quot;}"/>
+          <p:cNvPr id="171" name="" descr="{&quot;isTemplate&quot;:true,&quot;type&quot;:&quot;text&quot;}"/>
           <p:cNvSpPr txBox="1"/>
           <p:nvPr/>
         </p:nvSpPr>
@@ -6924,7 +6963,7 @@
       </p:sp>
       <p:sp>
         <p:nvSpPr>
-          <p:cNvPr id="171" name=""/>
+          <p:cNvPr id="172" name=""/>
           <p:cNvSpPr/>
           <p:nvPr/>
         </p:nvSpPr>
@@ -6969,7 +7008,7 @@
       </p:sp>
       <p:sp>
         <p:nvSpPr>
-          <p:cNvPr id="172" name="" descr="{&quot;isTemplate&quot;:true,&quot;type&quot;:&quot;text&quot;}"/>
+          <p:cNvPr id="173" name="" descr="{&quot;isTemplate&quot;:true,&quot;type&quot;:&quot;text&quot;}"/>
           <p:cNvSpPr txBox="1"/>
           <p:nvPr/>
         </p:nvSpPr>
@@ -7006,7 +7045,7 @@
       </p:sp>
       <p:sp>
         <p:nvSpPr>
-          <p:cNvPr id="173" name="" descr="{&quot;isTemplate&quot;:true,&quot;type&quot;:&quot;text&quot;}"/>
+          <p:cNvPr id="174" name="" descr="{&quot;isTemplate&quot;:true,&quot;type&quot;:&quot;text&quot;}"/>
           <p:cNvSpPr txBox="1"/>
           <p:nvPr/>
         </p:nvSpPr>
@@ -7051,7 +7090,7 @@
   <p:cSld>
     <p:spTree>
       <p:nvGrpSpPr>
-        <p:cNvPr id="174" name=""/>
+        <p:cNvPr id="175" name=""/>
         <p:cNvGrpSpPr/>
         <p:nvPr/>
       </p:nvGrpSpPr>
@@ -7065,7 +7104,7 @@
       </p:grpSpPr>
       <p:sp>
         <p:nvSpPr>
-          <p:cNvPr id="175" name=""/>
+          <p:cNvPr id="176" name=""/>
           <p:cNvSpPr/>
           <p:nvPr/>
         </p:nvSpPr>
@@ -7092,7 +7131,7 @@
       </p:sp>
       <p:sp>
         <p:nvSpPr>
-          <p:cNvPr id="176" name="" descr="{&quot;isTemplate&quot;:true,&quot;type&quot;:&quot;text&quot;}"/>
+          <p:cNvPr id="177" name="" descr="{&quot;isTemplate&quot;:true,&quot;type&quot;:&quot;text&quot;}"/>
           <p:cNvSpPr txBox="1"/>
           <p:nvPr/>
         </p:nvSpPr>
@@ -7127,7 +7166,7 @@
       </p:sp>
       <p:sp>
         <p:nvSpPr>
-          <p:cNvPr id="177" name="" descr="{&quot;isTemplate&quot;:true,&quot;type&quot;:&quot;text&quot;}"/>
+          <p:cNvPr id="178" name="" descr="{&quot;isTemplate&quot;:true,&quot;type&quot;:&quot;text&quot;}"/>
           <p:cNvSpPr txBox="1"/>
           <p:nvPr/>
         </p:nvSpPr>
@@ -7162,7 +7201,7 @@
       </p:sp>
       <p:sp>
         <p:nvSpPr>
-          <p:cNvPr id="178" name="" descr="{&quot;isTemplate&quot;:true,&quot;type&quot;:&quot;text&quot;}"/>
+          <p:cNvPr id="179" name="" descr="{&quot;isTemplate&quot;:true,&quot;type&quot;:&quot;text&quot;}"/>
           <p:cNvSpPr txBox="1"/>
           <p:nvPr/>
         </p:nvSpPr>
@@ -7199,7 +7238,7 @@
       </p:sp>
       <p:sp>
         <p:nvSpPr>
-          <p:cNvPr id="179" name=""/>
+          <p:cNvPr id="180" name=""/>
           <p:cNvSpPr/>
           <p:nvPr/>
         </p:nvSpPr>
@@ -7237,7 +7276,7 @@
       </p:sp>
       <p:sp>
         <p:nvSpPr>
-          <p:cNvPr id="180" name=""/>
+          <p:cNvPr id="181" name=""/>
           <p:cNvSpPr/>
           <p:nvPr/>
         </p:nvSpPr>
@@ -7282,7 +7321,7 @@
       </p:sp>
       <p:sp>
         <p:nvSpPr>
-          <p:cNvPr id="181" name="" descr="{&quot;isTemplate&quot;:true,&quot;type&quot;:&quot;text&quot;}"/>
+          <p:cNvPr id="182" name="" descr="{&quot;isTemplate&quot;:true,&quot;type&quot;:&quot;text&quot;}"/>
           <p:cNvSpPr txBox="1"/>
           <p:nvPr/>
         </p:nvSpPr>
@@ -7317,7 +7356,7 @@
       </p:sp>
       <p:sp>
         <p:nvSpPr>
-          <p:cNvPr id="182" name="" descr="{&quot;isTemplate&quot;:true,&quot;type&quot;:&quot;text&quot;}"/>
+          <p:cNvPr id="183" name="" descr="{&quot;isTemplate&quot;:true,&quot;type&quot;:&quot;text&quot;}"/>
           <p:cNvSpPr txBox="1"/>
           <p:nvPr/>
         </p:nvSpPr>
@@ -7354,7 +7393,7 @@
       </p:sp>
       <p:sp>
         <p:nvSpPr>
-          <p:cNvPr id="183" name="" descr="{&quot;isTemplate&quot;:true,&quot;type&quot;:&quot;text&quot;}"/>
+          <p:cNvPr id="184" name="" descr="{&quot;isTemplate&quot;:true,&quot;type&quot;:&quot;text&quot;}"/>
           <p:cNvSpPr txBox="1"/>
           <p:nvPr/>
         </p:nvSpPr>
@@ -7389,7 +7428,7 @@
       </p:sp>
       <p:sp>
         <p:nvSpPr>
-          <p:cNvPr id="184" name="" descr="{&quot;isTemplate&quot;:true,&quot;type&quot;:&quot;text&quot;}"/>
+          <p:cNvPr id="185" name="" descr="{&quot;isTemplate&quot;:true,&quot;type&quot;:&quot;text&quot;}"/>
           <p:cNvSpPr txBox="1"/>
           <p:nvPr/>
         </p:nvSpPr>
@@ -7424,7 +7463,7 @@
       </p:sp>
       <p:sp>
         <p:nvSpPr>
-          <p:cNvPr id="185" name="" descr="{&quot;isTemplate&quot;:true,&quot;type&quot;:&quot;text&quot;}"/>
+          <p:cNvPr id="186" name="" descr="{&quot;isTemplate&quot;:true,&quot;type&quot;:&quot;text&quot;}"/>
           <p:cNvSpPr txBox="1"/>
           <p:nvPr/>
         </p:nvSpPr>
@@ -7459,7 +7498,7 @@
       </p:sp>
       <p:sp>
         <p:nvSpPr>
-          <p:cNvPr id="186" name="" descr="{&quot;isTemplate&quot;:true,&quot;type&quot;:&quot;text&quot;}"/>
+          <p:cNvPr id="187" name="" descr="{&quot;isTemplate&quot;:true,&quot;type&quot;:&quot;text&quot;}"/>
           <p:cNvSpPr txBox="1"/>
           <p:nvPr/>
         </p:nvSpPr>
@@ -7494,7 +7533,7 @@
       </p:sp>
       <p:sp>
         <p:nvSpPr>
-          <p:cNvPr id="187" name="" descr="{&quot;isTemplate&quot;:true,&quot;type&quot;:&quot;text&quot;}"/>
+          <p:cNvPr id="188" name="" descr="{&quot;isTemplate&quot;:true,&quot;type&quot;:&quot;text&quot;}"/>
           <p:cNvSpPr txBox="1"/>
           <p:nvPr/>
         </p:nvSpPr>
@@ -7529,7 +7568,7 @@
       </p:sp>
       <p:sp>
         <p:nvSpPr>
-          <p:cNvPr id="188" name="" descr="{&quot;isTemplate&quot;:true,&quot;type&quot;:&quot;text&quot;}"/>
+          <p:cNvPr id="189" name="" descr="{&quot;isTemplate&quot;:true,&quot;type&quot;:&quot;text&quot;}"/>
           <p:cNvSpPr txBox="1"/>
           <p:nvPr/>
         </p:nvSpPr>
@@ -7566,7 +7605,7 @@
       </p:sp>
       <p:sp>
         <p:nvSpPr>
-          <p:cNvPr id="189" name="" descr="{&quot;isTemplate&quot;:true,&quot;type&quot;:&quot;text&quot;}"/>
+          <p:cNvPr id="190" name="" descr="{&quot;isTemplate&quot;:true,&quot;type&quot;:&quot;text&quot;}"/>
           <p:cNvSpPr txBox="1"/>
           <p:nvPr/>
         </p:nvSpPr>
@@ -7601,7 +7640,7 @@
       </p:sp>
       <p:sp>
         <p:nvSpPr>
-          <p:cNvPr id="190" name="" descr="{&quot;isTemplate&quot;:true,&quot;type&quot;:&quot;text&quot;}"/>
+          <p:cNvPr id="191" name="" descr="{&quot;isTemplate&quot;:true,&quot;type&quot;:&quot;text&quot;}"/>
           <p:cNvSpPr txBox="1"/>
           <p:nvPr/>
         </p:nvSpPr>
@@ -7636,7 +7675,7 @@
       </p:sp>
       <p:sp>
         <p:nvSpPr>
-          <p:cNvPr id="191" name="" descr="{&quot;isTemplate&quot;:true,&quot;type&quot;:&quot;text&quot;}"/>
+          <p:cNvPr id="192" name="" descr="{&quot;isTemplate&quot;:true,&quot;type&quot;:&quot;text&quot;}"/>
           <p:cNvSpPr txBox="1"/>
           <p:nvPr/>
         </p:nvSpPr>
@@ -7671,7 +7710,7 @@
       </p:sp>
       <p:sp>
         <p:nvSpPr>
-          <p:cNvPr id="192" name="" descr="{&quot;isTemplate&quot;:true,&quot;type&quot;:&quot;text&quot;}"/>
+          <p:cNvPr id="193" name="" descr="{&quot;isTemplate&quot;:true,&quot;type&quot;:&quot;text&quot;}"/>
           <p:cNvSpPr txBox="1"/>
           <p:nvPr/>
         </p:nvSpPr>
@@ -7706,7 +7745,7 @@
       </p:sp>
       <p:sp>
         <p:nvSpPr>
-          <p:cNvPr id="193" name="" descr="{&quot;isTemplate&quot;:true,&quot;type&quot;:&quot;text&quot;}"/>
+          <p:cNvPr id="194" name="" descr="{&quot;isTemplate&quot;:true,&quot;type&quot;:&quot;text&quot;}"/>
           <p:cNvSpPr txBox="1"/>
           <p:nvPr/>
         </p:nvSpPr>
@@ -7741,7 +7780,7 @@
       </p:sp>
       <p:sp>
         <p:nvSpPr>
-          <p:cNvPr id="194" name="" descr="{&quot;isTemplate&quot;:true,&quot;type&quot;:&quot;text&quot;}"/>
+          <p:cNvPr id="195" name="" descr="{&quot;isTemplate&quot;:true,&quot;type&quot;:&quot;text&quot;}"/>
           <p:cNvSpPr txBox="1"/>
           <p:nvPr/>
         </p:nvSpPr>
@@ -7776,7 +7815,7 @@
       </p:sp>
       <p:sp>
         <p:nvSpPr>
-          <p:cNvPr id="195" name="" descr="{&quot;isTemplate&quot;:true,&quot;type&quot;:&quot;text&quot;}"/>
+          <p:cNvPr id="196" name="" descr="{&quot;isTemplate&quot;:true,&quot;type&quot;:&quot;text&quot;}"/>
           <p:cNvSpPr txBox="1"/>
           <p:nvPr/>
         </p:nvSpPr>
@@ -7811,7 +7850,7 @@
       </p:sp>
       <p:sp>
         <p:nvSpPr>
-          <p:cNvPr id="196" name="" descr="{&quot;isTemplate&quot;:true,&quot;type&quot;:&quot;text&quot;}"/>
+          <p:cNvPr id="197" name="" descr="{&quot;isTemplate&quot;:true,&quot;type&quot;:&quot;text&quot;}"/>
           <p:cNvSpPr txBox="1"/>
           <p:nvPr/>
         </p:nvSpPr>
@@ -7846,7 +7885,7 @@
       </p:sp>
       <p:sp>
         <p:nvSpPr>
-          <p:cNvPr id="197" name="" descr="{&quot;isTemplate&quot;:true,&quot;type&quot;:&quot;text&quot;}"/>
+          <p:cNvPr id="198" name="" descr="{&quot;isTemplate&quot;:true,&quot;type&quot;:&quot;text&quot;}"/>
           <p:cNvSpPr txBox="1"/>
           <p:nvPr/>
         </p:nvSpPr>
@@ -7883,7 +7922,7 @@
       </p:sp>
       <p:sp>
         <p:nvSpPr>
-          <p:cNvPr id="198" name="" descr="{&quot;isTemplate&quot;:true,&quot;type&quot;:&quot;text&quot;}"/>
+          <p:cNvPr id="199" name="" descr="{&quot;isTemplate&quot;:true,&quot;type&quot;:&quot;text&quot;}"/>
           <p:cNvSpPr txBox="1"/>
           <p:nvPr/>
         </p:nvSpPr>
@@ -7918,7 +7957,7 @@
       </p:sp>
       <p:sp>
         <p:nvSpPr>
-          <p:cNvPr id="199" name="" descr="{&quot;isTemplate&quot;:true,&quot;type&quot;:&quot;text&quot;}"/>
+          <p:cNvPr id="200" name="" descr="{&quot;isTemplate&quot;:true,&quot;type&quot;:&quot;text&quot;}"/>
           <p:cNvSpPr txBox="1"/>
           <p:nvPr/>
         </p:nvSpPr>
@@ -7953,7 +7992,7 @@
       </p:sp>
       <p:sp>
         <p:nvSpPr>
-          <p:cNvPr id="200" name="" descr="{&quot;isTemplate&quot;:true,&quot;type&quot;:&quot;text&quot;}"/>
+          <p:cNvPr id="201" name="" descr="{&quot;isTemplate&quot;:true,&quot;type&quot;:&quot;text&quot;}"/>
           <p:cNvSpPr txBox="1"/>
           <p:nvPr/>
         </p:nvSpPr>
@@ -7992,7 +8031,7 @@
       </p:sp>
       <p:sp>
         <p:nvSpPr>
-          <p:cNvPr id="201" name="" descr="{&quot;isTemplate&quot;:true,&quot;type&quot;:&quot;text&quot;}"/>
+          <p:cNvPr id="202" name="" descr="{&quot;isTemplate&quot;:true,&quot;type&quot;:&quot;text&quot;}"/>
           <p:cNvSpPr txBox="1"/>
           <p:nvPr/>
         </p:nvSpPr>
@@ -8027,7 +8066,7 @@
       </p:sp>
       <p:sp>
         <p:nvSpPr>
-          <p:cNvPr id="202" name="" descr="{&quot;isTemplate&quot;:true,&quot;type&quot;:&quot;text&quot;}"/>
+          <p:cNvPr id="203" name="" descr="{&quot;isTemplate&quot;:true,&quot;type&quot;:&quot;text&quot;}"/>
           <p:cNvSpPr txBox="1"/>
           <p:nvPr/>
         </p:nvSpPr>
@@ -8066,7 +8105,7 @@
       </p:sp>
       <p:sp>
         <p:nvSpPr>
-          <p:cNvPr id="203" name="" descr="{&quot;isTemplate&quot;:true,&quot;type&quot;:&quot;text&quot;}"/>
+          <p:cNvPr id="204" name="" descr="{&quot;isTemplate&quot;:true,&quot;type&quot;:&quot;text&quot;}"/>
           <p:cNvSpPr txBox="1"/>
           <p:nvPr/>
         </p:nvSpPr>
@@ -8101,7 +8140,7 @@
       </p:sp>
       <p:sp>
         <p:nvSpPr>
-          <p:cNvPr id="204" name="" descr="{&quot;isTemplate&quot;:true,&quot;type&quot;:&quot;text&quot;}"/>
+          <p:cNvPr id="205" name="" descr="{&quot;isTemplate&quot;:true,&quot;type&quot;:&quot;text&quot;}"/>
           <p:cNvSpPr txBox="1"/>
           <p:nvPr/>
         </p:nvSpPr>
@@ -8140,7 +8179,7 @@
       </p:sp>
       <p:sp>
         <p:nvSpPr>
-          <p:cNvPr id="205" name=""/>
+          <p:cNvPr id="206" name=""/>
           <p:cNvSpPr/>
           <p:nvPr/>
         </p:nvSpPr>
@@ -8169,7 +8208,7 @@
       </p:sp>
       <p:sp>
         <p:nvSpPr>
-          <p:cNvPr id="206" name=""/>
+          <p:cNvPr id="207" name=""/>
           <p:cNvSpPr/>
           <p:nvPr/>
         </p:nvSpPr>
@@ -8212,7 +8251,7 @@
       </p:sp>
       <p:sp>
         <p:nvSpPr>
-          <p:cNvPr id="207" name="" descr="{&quot;isTemplate&quot;:true,&quot;type&quot;:&quot;text&quot;}"/>
+          <p:cNvPr id="208" name="" descr="{&quot;isTemplate&quot;:true,&quot;type&quot;:&quot;text&quot;}"/>
           <p:cNvSpPr txBox="1"/>
           <p:nvPr/>
         </p:nvSpPr>
@@ -8249,7 +8288,7 @@
       </p:sp>
       <p:sp>
         <p:nvSpPr>
-          <p:cNvPr id="208" name=""/>
+          <p:cNvPr id="209" name=""/>
           <p:cNvSpPr/>
           <p:nvPr/>
         </p:nvSpPr>
@@ -8294,7 +8333,7 @@
       </p:sp>
       <p:sp>
         <p:nvSpPr>
-          <p:cNvPr id="209" name="" descr="{&quot;isTemplate&quot;:true,&quot;type&quot;:&quot;text&quot;}"/>
+          <p:cNvPr id="210" name="" descr="{&quot;isTemplate&quot;:true,&quot;type&quot;:&quot;text&quot;}"/>
           <p:cNvSpPr txBox="1"/>
           <p:nvPr/>
         </p:nvSpPr>
@@ -8331,7 +8370,7 @@
       </p:sp>
       <p:sp>
         <p:nvSpPr>
-          <p:cNvPr id="210" name="" descr="{&quot;isTemplate&quot;:true,&quot;type&quot;:&quot;text&quot;}"/>
+          <p:cNvPr id="211" name="" descr="{&quot;isTemplate&quot;:true,&quot;type&quot;:&quot;text&quot;}"/>
           <p:cNvSpPr txBox="1"/>
           <p:nvPr/>
         </p:nvSpPr>
@@ -8376,7 +8415,7 @@
   <p:cSld>
     <p:spTree>
       <p:nvGrpSpPr>
-        <p:cNvPr id="211" name=""/>
+        <p:cNvPr id="212" name=""/>
         <p:cNvGrpSpPr/>
         <p:nvPr/>
       </p:nvGrpSpPr>
@@ -8390,7 +8429,7 @@
       </p:grpSpPr>
       <p:sp>
         <p:nvSpPr>
-          <p:cNvPr id="212" name=""/>
+          <p:cNvPr id="213" name=""/>
           <p:cNvSpPr/>
           <p:nvPr/>
         </p:nvSpPr>
@@ -8417,7 +8456,7 @@
       </p:sp>
       <p:sp>
         <p:nvSpPr>
-          <p:cNvPr id="213" name="" descr="{&quot;isTemplate&quot;:true,&quot;type&quot;:&quot;text&quot;}"/>
+          <p:cNvPr id="214" name="" descr="{&quot;isTemplate&quot;:true,&quot;type&quot;:&quot;text&quot;}"/>
           <p:cNvSpPr txBox="1"/>
           <p:nvPr/>
         </p:nvSpPr>
@@ -8452,7 +8491,7 @@
       </p:sp>
       <p:sp>
         <p:nvSpPr>
-          <p:cNvPr id="214" name="" descr="{&quot;isTemplate&quot;:true,&quot;type&quot;:&quot;text&quot;}"/>
+          <p:cNvPr id="215" name="" descr="{&quot;isTemplate&quot;:true,&quot;type&quot;:&quot;text&quot;}"/>
           <p:cNvSpPr txBox="1"/>
           <p:nvPr/>
         </p:nvSpPr>
@@ -8487,7 +8526,7 @@
       </p:sp>
       <p:sp>
         <p:nvSpPr>
-          <p:cNvPr id="215" name="" descr="{&quot;isTemplate&quot;:true,&quot;type&quot;:&quot;text&quot;}"/>
+          <p:cNvPr id="216" name="" descr="{&quot;isTemplate&quot;:true,&quot;type&quot;:&quot;text&quot;}"/>
           <p:cNvSpPr txBox="1"/>
           <p:nvPr/>
         </p:nvSpPr>
@@ -8524,7 +8563,7 @@
       </p:sp>
       <p:sp>
         <p:nvSpPr>
-          <p:cNvPr id="216" name=""/>
+          <p:cNvPr id="217" name=""/>
           <p:cNvSpPr/>
           <p:nvPr/>
         </p:nvSpPr>
@@ -8562,7 +8601,7 @@
       </p:sp>
       <p:sp>
         <p:nvSpPr>
-          <p:cNvPr id="217" name=""/>
+          <p:cNvPr id="218" name=""/>
           <p:cNvSpPr/>
           <p:nvPr/>
         </p:nvSpPr>
@@ -8607,7 +8646,7 @@
       </p:sp>
       <p:sp>
         <p:nvSpPr>
-          <p:cNvPr id="218" name="" descr="{&quot;isTemplate&quot;:true,&quot;type&quot;:&quot;text&quot;}"/>
+          <p:cNvPr id="219" name="" descr="{&quot;isTemplate&quot;:true,&quot;type&quot;:&quot;text&quot;}"/>
           <p:cNvSpPr txBox="1"/>
           <p:nvPr/>
         </p:nvSpPr>
@@ -8642,7 +8681,7 @@
       </p:sp>
       <p:sp>
         <p:nvSpPr>
-          <p:cNvPr id="219" name="" descr="{&quot;isTemplate&quot;:true,&quot;type&quot;:&quot;text&quot;}"/>
+          <p:cNvPr id="220" name="" descr="{&quot;isTemplate&quot;:true,&quot;type&quot;:&quot;text&quot;}"/>
           <p:cNvSpPr txBox="1"/>
           <p:nvPr/>
         </p:nvSpPr>
@@ -8679,7 +8718,7 @@
       </p:sp>
       <p:sp>
         <p:nvSpPr>
-          <p:cNvPr id="220" name="" descr="{&quot;isTemplate&quot;:true,&quot;type&quot;:&quot;text&quot;}"/>
+          <p:cNvPr id="221" name="" descr="{&quot;isTemplate&quot;:true,&quot;type&quot;:&quot;text&quot;}"/>
           <p:cNvSpPr txBox="1"/>
           <p:nvPr/>
         </p:nvSpPr>
@@ -8716,7 +8755,7 @@
       </p:sp>
       <p:sp>
         <p:nvSpPr>
-          <p:cNvPr id="221" name="" descr="{&quot;isTemplate&quot;:true,&quot;type&quot;:&quot;text&quot;}"/>
+          <p:cNvPr id="222" name="" descr="{&quot;isTemplate&quot;:true,&quot;type&quot;:&quot;text&quot;}"/>
           <p:cNvSpPr txBox="1"/>
           <p:nvPr/>
         </p:nvSpPr>
@@ -8751,7 +8790,7 @@
       </p:sp>
       <p:sp>
         <p:nvSpPr>
-          <p:cNvPr id="222" name="" descr="{&quot;isTemplate&quot;:true,&quot;type&quot;:&quot;text&quot;}"/>
+          <p:cNvPr id="223" name="" descr="{&quot;isTemplate&quot;:true,&quot;type&quot;:&quot;text&quot;}"/>
           <p:cNvSpPr txBox="1"/>
           <p:nvPr/>
         </p:nvSpPr>
@@ -8786,7 +8825,7 @@
       </p:sp>
       <p:sp>
         <p:nvSpPr>
-          <p:cNvPr id="223" name="" descr="{&quot;isTemplate&quot;:true,&quot;type&quot;:&quot;text&quot;}"/>
+          <p:cNvPr id="224" name="" descr="{&quot;isTemplate&quot;:true,&quot;type&quot;:&quot;text&quot;}"/>
           <p:cNvSpPr txBox="1"/>
           <p:nvPr/>
         </p:nvSpPr>
@@ -8821,7 +8860,7 @@
       </p:sp>
       <p:sp>
         <p:nvSpPr>
-          <p:cNvPr id="224" name="" descr="{&quot;isTemplate&quot;:true,&quot;type&quot;:&quot;text&quot;}"/>
+          <p:cNvPr id="225" name="" descr="{&quot;isTemplate&quot;:true,&quot;type&quot;:&quot;text&quot;}"/>
           <p:cNvSpPr txBox="1"/>
           <p:nvPr/>
         </p:nvSpPr>
@@ -8856,7 +8895,7 @@
       </p:sp>
       <p:sp>
         <p:nvSpPr>
-          <p:cNvPr id="225" name="" descr="{&quot;isTemplate&quot;:true,&quot;type&quot;:&quot;text&quot;}"/>
+          <p:cNvPr id="226" name="" descr="{&quot;isTemplate&quot;:true,&quot;type&quot;:&quot;text&quot;}"/>
           <p:cNvSpPr txBox="1"/>
           <p:nvPr/>
         </p:nvSpPr>
@@ -8893,7 +8932,7 @@
       </p:sp>
       <p:sp>
         <p:nvSpPr>
-          <p:cNvPr id="226" name="" descr="{&quot;isTemplate&quot;:true,&quot;type&quot;:&quot;text&quot;}"/>
+          <p:cNvPr id="227" name="" descr="{&quot;isTemplate&quot;:true,&quot;type&quot;:&quot;text&quot;}"/>
           <p:cNvSpPr txBox="1"/>
           <p:nvPr/>
         </p:nvSpPr>
@@ -8928,7 +8967,7 @@
       </p:sp>
       <p:sp>
         <p:nvSpPr>
-          <p:cNvPr id="227" name="" descr="{&quot;isTemplate&quot;:true,&quot;type&quot;:&quot;text&quot;}"/>
+          <p:cNvPr id="228" name="" descr="{&quot;isTemplate&quot;:true,&quot;type&quot;:&quot;text&quot;}"/>
           <p:cNvSpPr txBox="1"/>
           <p:nvPr/>
         </p:nvSpPr>
@@ -8963,7 +9002,7 @@
       </p:sp>
       <p:sp>
         <p:nvSpPr>
-          <p:cNvPr id="228" name="" descr="{&quot;isTemplate&quot;:true,&quot;type&quot;:&quot;text&quot;}"/>
+          <p:cNvPr id="229" name="" descr="{&quot;isTemplate&quot;:true,&quot;type&quot;:&quot;text&quot;}"/>
           <p:cNvSpPr txBox="1"/>
           <p:nvPr/>
         </p:nvSpPr>
@@ -8998,7 +9037,7 @@
       </p:sp>
       <p:sp>
         <p:nvSpPr>
-          <p:cNvPr id="229" name="" descr="{&quot;isTemplate&quot;:true,&quot;type&quot;:&quot;text&quot;}"/>
+          <p:cNvPr id="230" name="" descr="{&quot;isTemplate&quot;:true,&quot;type&quot;:&quot;text&quot;}"/>
           <p:cNvSpPr txBox="1"/>
           <p:nvPr/>
         </p:nvSpPr>
@@ -9033,7 +9072,7 @@
       </p:sp>
       <p:sp>
         <p:nvSpPr>
-          <p:cNvPr id="230" name="" descr="{&quot;isTemplate&quot;:true,&quot;type&quot;:&quot;text&quot;}"/>
+          <p:cNvPr id="231" name="" descr="{&quot;isTemplate&quot;:true,&quot;type&quot;:&quot;text&quot;}"/>
           <p:cNvSpPr txBox="1"/>
           <p:nvPr/>
         </p:nvSpPr>
@@ -9070,7 +9109,7 @@
       </p:sp>
       <p:sp>
         <p:nvSpPr>
-          <p:cNvPr id="231" name="" descr="{&quot;isTemplate&quot;:true,&quot;type&quot;:&quot;text&quot;}"/>
+          <p:cNvPr id="232" name="" descr="{&quot;isTemplate&quot;:true,&quot;type&quot;:&quot;text&quot;}"/>
           <p:cNvSpPr txBox="1"/>
           <p:nvPr/>
         </p:nvSpPr>
@@ -9105,7 +9144,7 @@
       </p:sp>
       <p:sp>
         <p:nvSpPr>
-          <p:cNvPr id="232" name="" descr="{&quot;isTemplate&quot;:true,&quot;type&quot;:&quot;text&quot;}"/>
+          <p:cNvPr id="233" name="" descr="{&quot;isTemplate&quot;:true,&quot;type&quot;:&quot;text&quot;}"/>
           <p:cNvSpPr txBox="1"/>
           <p:nvPr/>
         </p:nvSpPr>
@@ -9140,7 +9179,7 @@
       </p:sp>
       <p:sp>
         <p:nvSpPr>
-          <p:cNvPr id="233" name="" descr="{&quot;isTemplate&quot;:true,&quot;type&quot;:&quot;text&quot;}"/>
+          <p:cNvPr id="234" name="" descr="{&quot;isTemplate&quot;:true,&quot;type&quot;:&quot;text&quot;}"/>
           <p:cNvSpPr txBox="1"/>
           <p:nvPr/>
         </p:nvSpPr>
@@ -9175,7 +9214,7 @@
       </p:sp>
       <p:sp>
         <p:nvSpPr>
-          <p:cNvPr id="234" name="" descr="{&quot;isTemplate&quot;:true,&quot;type&quot;:&quot;text&quot;}"/>
+          <p:cNvPr id="235" name="" descr="{&quot;isTemplate&quot;:true,&quot;type&quot;:&quot;text&quot;}"/>
           <p:cNvSpPr txBox="1"/>
           <p:nvPr/>
         </p:nvSpPr>
@@ -9210,7 +9249,7 @@
       </p:sp>
       <p:sp>
         <p:nvSpPr>
-          <p:cNvPr id="235" name="" descr="{&quot;isTemplate&quot;:true,&quot;type&quot;:&quot;text&quot;}"/>
+          <p:cNvPr id="236" name="" descr="{&quot;isTemplate&quot;:true,&quot;type&quot;:&quot;text&quot;}"/>
           <p:cNvSpPr txBox="1"/>
           <p:nvPr/>
         </p:nvSpPr>
@@ -9245,7 +9284,7 @@
       </p:sp>
       <p:sp>
         <p:nvSpPr>
-          <p:cNvPr id="236" name="" descr="{&quot;isTemplate&quot;:true,&quot;type&quot;:&quot;text&quot;}"/>
+          <p:cNvPr id="237" name="" descr="{&quot;isTemplate&quot;:true,&quot;type&quot;:&quot;text&quot;}"/>
           <p:cNvSpPr txBox="1"/>
           <p:nvPr/>
         </p:nvSpPr>
@@ -9284,7 +9323,7 @@
       </p:sp>
       <p:sp>
         <p:nvSpPr>
-          <p:cNvPr id="237" name="" descr="{&quot;isTemplate&quot;:true,&quot;type&quot;:&quot;text&quot;}"/>
+          <p:cNvPr id="238" name="" descr="{&quot;isTemplate&quot;:true,&quot;type&quot;:&quot;text&quot;}"/>
           <p:cNvSpPr txBox="1"/>
           <p:nvPr/>
         </p:nvSpPr>
@@ -9319,7 +9358,7 @@
       </p:sp>
       <p:sp>
         <p:nvSpPr>
-          <p:cNvPr id="238" name="" descr="{&quot;isTemplate&quot;:true,&quot;type&quot;:&quot;text&quot;}"/>
+          <p:cNvPr id="239" name="" descr="{&quot;isTemplate&quot;:true,&quot;type&quot;:&quot;text&quot;}"/>
           <p:cNvSpPr txBox="1"/>
           <p:nvPr/>
         </p:nvSpPr>
@@ -9358,7 +9397,7 @@
       </p:sp>
       <p:sp>
         <p:nvSpPr>
-          <p:cNvPr id="239" name="" descr="{&quot;isTemplate&quot;:true,&quot;type&quot;:&quot;text&quot;}"/>
+          <p:cNvPr id="240" name="" descr="{&quot;isTemplate&quot;:true,&quot;type&quot;:&quot;text&quot;}"/>
           <p:cNvSpPr txBox="1"/>
           <p:nvPr/>
         </p:nvSpPr>
@@ -9393,7 +9432,7 @@
       </p:sp>
       <p:sp>
         <p:nvSpPr>
-          <p:cNvPr id="240" name="" descr="{&quot;isTemplate&quot;:true,&quot;type&quot;:&quot;text&quot;}"/>
+          <p:cNvPr id="241" name="" descr="{&quot;isTemplate&quot;:true,&quot;type&quot;:&quot;text&quot;}"/>
           <p:cNvSpPr txBox="1"/>
           <p:nvPr/>
         </p:nvSpPr>
@@ -9432,7 +9471,7 @@
       </p:sp>
       <p:sp>
         <p:nvSpPr>
-          <p:cNvPr id="241" name=""/>
+          <p:cNvPr id="242" name=""/>
           <p:cNvSpPr/>
           <p:nvPr/>
         </p:nvSpPr>
@@ -9461,7 +9500,7 @@
       </p:sp>
       <p:sp>
         <p:nvSpPr>
-          <p:cNvPr id="242" name=""/>
+          <p:cNvPr id="243" name=""/>
           <p:cNvSpPr/>
           <p:nvPr/>
         </p:nvSpPr>
@@ -9504,7 +9543,7 @@
       </p:sp>
       <p:sp>
         <p:nvSpPr>
-          <p:cNvPr id="243" name="" descr="{&quot;isTemplate&quot;:true,&quot;type&quot;:&quot;text&quot;}"/>
+          <p:cNvPr id="244" name="" descr="{&quot;isTemplate&quot;:true,&quot;type&quot;:&quot;text&quot;}"/>
           <p:cNvSpPr txBox="1"/>
           <p:nvPr/>
         </p:nvSpPr>
@@ -9541,7 +9580,7 @@
       </p:sp>
       <p:sp>
         <p:nvSpPr>
-          <p:cNvPr id="244" name=""/>
+          <p:cNvPr id="245" name=""/>
           <p:cNvSpPr/>
           <p:nvPr/>
         </p:nvSpPr>
@@ -9586,7 +9625,7 @@
       </p:sp>
       <p:sp>
         <p:nvSpPr>
-          <p:cNvPr id="245" name="" descr="{&quot;isTemplate&quot;:true,&quot;type&quot;:&quot;text&quot;}"/>
+          <p:cNvPr id="246" name="" descr="{&quot;isTemplate&quot;:true,&quot;type&quot;:&quot;text&quot;}"/>
           <p:cNvSpPr txBox="1"/>
           <p:nvPr/>
         </p:nvSpPr>
@@ -9623,7 +9662,7 @@
       </p:sp>
       <p:sp>
         <p:nvSpPr>
-          <p:cNvPr id="246" name="" descr="{&quot;isTemplate&quot;:true,&quot;type&quot;:&quot;text&quot;}"/>
+          <p:cNvPr id="247" name="" descr="{&quot;isTemplate&quot;:true,&quot;type&quot;:&quot;text&quot;}"/>
           <p:cNvSpPr txBox="1"/>
           <p:nvPr/>
         </p:nvSpPr>
@@ -9668,7 +9707,7 @@
   <p:cSld>
     <p:spTree>
       <p:nvGrpSpPr>
-        <p:cNvPr id="247" name=""/>
+        <p:cNvPr id="248" name=""/>
         <p:cNvGrpSpPr/>
         <p:nvPr/>
       </p:nvGrpSpPr>
@@ -9682,7 +9721,7 @@
       </p:grpSpPr>
       <p:sp>
         <p:nvSpPr>
-          <p:cNvPr id="248" name=""/>
+          <p:cNvPr id="249" name=""/>
           <p:cNvSpPr/>
           <p:nvPr/>
         </p:nvSpPr>
@@ -9709,7 +9748,7 @@
       </p:sp>
       <p:sp>
         <p:nvSpPr>
-          <p:cNvPr id="249" name="" descr="{&quot;isTemplate&quot;:true,&quot;type&quot;:&quot;text&quot;}"/>
+          <p:cNvPr id="250" name="" descr="{&quot;isTemplate&quot;:true,&quot;type&quot;:&quot;text&quot;}"/>
           <p:cNvSpPr txBox="1"/>
           <p:nvPr/>
         </p:nvSpPr>
@@ -9744,7 +9783,7 @@
       </p:sp>
       <p:sp>
         <p:nvSpPr>
-          <p:cNvPr id="250" name="" descr="{&quot;isTemplate&quot;:true,&quot;type&quot;:&quot;text&quot;}"/>
+          <p:cNvPr id="251" name="" descr="{&quot;isTemplate&quot;:true,&quot;type&quot;:&quot;text&quot;}"/>
           <p:cNvSpPr txBox="1"/>
           <p:nvPr/>
         </p:nvSpPr>
@@ -9779,7 +9818,7 @@
       </p:sp>
       <p:sp>
         <p:nvSpPr>
-          <p:cNvPr id="251" name="" descr="{&quot;isTemplate&quot;:true,&quot;type&quot;:&quot;text&quot;}"/>
+          <p:cNvPr id="252" name="" descr="{&quot;isTemplate&quot;:true,&quot;type&quot;:&quot;text&quot;}"/>
           <p:cNvSpPr txBox="1"/>
           <p:nvPr/>
         </p:nvSpPr>
@@ -9816,7 +9855,7 @@
       </p:sp>
       <p:sp>
         <p:nvSpPr>
-          <p:cNvPr id="252" name=""/>
+          <p:cNvPr id="253" name=""/>
           <p:cNvSpPr/>
           <p:nvPr/>
         </p:nvSpPr>
@@ -9847,7 +9886,7 @@
       </p:sp>
       <p:pic>
         <p:nvPicPr>
-          <p:cNvPr id="253" name=""/>
+          <p:cNvPr id="254" name=""/>
           <p:cNvPicPr>
             <a:picLocks noChangeAspect="1"/>
           </p:cNvPicPr>
@@ -9882,7 +9921,7 @@
       </p:pic>
       <p:sp>
         <p:nvSpPr>
-          <p:cNvPr id="254" name="" descr="{&quot;isTemplate&quot;:true,&quot;type&quot;:&quot;text&quot;}"/>
+          <p:cNvPr id="255" name="" descr="{&quot;isTemplate&quot;:true,&quot;type&quot;:&quot;text&quot;}"/>
           <p:cNvSpPr txBox="1"/>
           <p:nvPr/>
         </p:nvSpPr>
@@ -9919,7 +9958,7 @@
       </p:sp>
       <p:sp>
         <p:nvSpPr>
-          <p:cNvPr id="255" name="" descr="{&quot;isTemplate&quot;:true,&quot;type&quot;:&quot;text&quot;}"/>
+          <p:cNvPr id="256" name="" descr="{&quot;isTemplate&quot;:true,&quot;type&quot;:&quot;text&quot;}"/>
           <p:cNvSpPr txBox="1"/>
           <p:nvPr/>
         </p:nvSpPr>
@@ -9956,7 +9995,7 @@
       </p:sp>
       <p:sp>
         <p:nvSpPr>
-          <p:cNvPr id="256" name="" descr="{&quot;isTemplate&quot;:true,&quot;type&quot;:&quot;text&quot;}"/>
+          <p:cNvPr id="257" name="" descr="{&quot;isTemplate&quot;:true,&quot;type&quot;:&quot;text&quot;}"/>
           <p:cNvSpPr txBox="1"/>
           <p:nvPr/>
         </p:nvSpPr>
@@ -9993,7 +10032,7 @@
       </p:sp>
       <p:sp>
         <p:nvSpPr>
-          <p:cNvPr id="257" name="" descr="{&quot;isTemplate&quot;:true,&quot;type&quot;:&quot;text&quot;}"/>
+          <p:cNvPr id="258" name="" descr="{&quot;isTemplate&quot;:true,&quot;type&quot;:&quot;text&quot;}"/>
           <p:cNvSpPr txBox="1"/>
           <p:nvPr/>
         </p:nvSpPr>
@@ -10032,7 +10071,7 @@
       </p:sp>
       <p:sp>
         <p:nvSpPr>
-          <p:cNvPr id="258" name=""/>
+          <p:cNvPr id="259" name=""/>
           <p:cNvSpPr/>
           <p:nvPr/>
         </p:nvSpPr>
@@ -10077,7 +10116,7 @@
       </p:sp>
       <p:sp>
         <p:nvSpPr>
-          <p:cNvPr id="259" name="" descr="{&quot;isTemplate&quot;:true,&quot;type&quot;:&quot;text&quot;}"/>
+          <p:cNvPr id="260" name="" descr="{&quot;isTemplate&quot;:true,&quot;type&quot;:&quot;text&quot;}"/>
           <p:cNvSpPr txBox="1"/>
           <p:nvPr/>
         </p:nvSpPr>
@@ -10114,7 +10153,7 @@
       </p:sp>
       <p:sp>
         <p:nvSpPr>
-          <p:cNvPr id="260" name="" descr="{&quot;isTemplate&quot;:true,&quot;type&quot;:&quot;text&quot;}"/>
+          <p:cNvPr id="261" name="" descr="{&quot;isTemplate&quot;:true,&quot;type&quot;:&quot;text&quot;}"/>
           <p:cNvSpPr txBox="1"/>
           <p:nvPr/>
         </p:nvSpPr>
@@ -10149,7 +10188,7 @@
       </p:sp>
       <p:sp>
         <p:nvSpPr>
-          <p:cNvPr id="261" name=""/>
+          <p:cNvPr id="262" name=""/>
           <p:cNvSpPr/>
           <p:nvPr/>
         </p:nvSpPr>
@@ -10194,7 +10233,7 @@
       </p:sp>
       <p:sp>
         <p:nvSpPr>
-          <p:cNvPr id="262" name="" descr="{&quot;isTemplate&quot;:true,&quot;type&quot;:&quot;text&quot;}"/>
+          <p:cNvPr id="263" name="" descr="{&quot;isTemplate&quot;:true,&quot;type&quot;:&quot;text&quot;}"/>
           <p:cNvSpPr txBox="1"/>
           <p:nvPr/>
         </p:nvSpPr>
@@ -10231,7 +10270,7 @@
       </p:sp>
       <p:sp>
         <p:nvSpPr>
-          <p:cNvPr id="263" name="" descr="{&quot;isTemplate&quot;:true,&quot;type&quot;:&quot;text&quot;}"/>
+          <p:cNvPr id="264" name="" descr="{&quot;isTemplate&quot;:true,&quot;type&quot;:&quot;text&quot;}"/>
           <p:cNvSpPr txBox="1"/>
           <p:nvPr/>
         </p:nvSpPr>
@@ -10266,7 +10305,7 @@
       </p:sp>
       <p:sp>
         <p:nvSpPr>
-          <p:cNvPr id="264" name=""/>
+          <p:cNvPr id="265" name=""/>
           <p:cNvSpPr/>
           <p:nvPr/>
         </p:nvSpPr>
@@ -10311,7 +10350,7 @@
       </p:sp>
       <p:sp>
         <p:nvSpPr>
-          <p:cNvPr id="265" name="" descr="{&quot;isTemplate&quot;:true,&quot;type&quot;:&quot;text&quot;}"/>
+          <p:cNvPr id="266" name="" descr="{&quot;isTemplate&quot;:true,&quot;type&quot;:&quot;text&quot;}"/>
           <p:cNvSpPr txBox="1"/>
           <p:nvPr/>
         </p:nvSpPr>
@@ -10348,7 +10387,7 @@
       </p:sp>
       <p:sp>
         <p:nvSpPr>
-          <p:cNvPr id="266" name="" descr="{&quot;isTemplate&quot;:true,&quot;type&quot;:&quot;text&quot;}"/>
+          <p:cNvPr id="267" name="" descr="{&quot;isTemplate&quot;:true,&quot;type&quot;:&quot;text&quot;}"/>
           <p:cNvSpPr txBox="1"/>
           <p:nvPr/>
         </p:nvSpPr>
@@ -10383,7 +10422,7 @@
       </p:sp>
       <p:sp>
         <p:nvSpPr>
-          <p:cNvPr id="267" name="" descr="{&quot;isTemplate&quot;:true,&quot;type&quot;:&quot;text&quot;}"/>
+          <p:cNvPr id="268" name="" descr="{&quot;isTemplate&quot;:true,&quot;type&quot;:&quot;text&quot;}"/>
           <p:cNvSpPr txBox="1"/>
           <p:nvPr/>
         </p:nvSpPr>
@@ -10420,7 +10459,7 @@
       </p:sp>
       <p:sp>
         <p:nvSpPr>
-          <p:cNvPr id="268" name="" descr="{&quot;isTemplate&quot;:true,&quot;type&quot;:&quot;text&quot;}"/>
+          <p:cNvPr id="269" name="" descr="{&quot;isTemplate&quot;:true,&quot;type&quot;:&quot;text&quot;}"/>
           <p:cNvSpPr txBox="1"/>
           <p:nvPr/>
         </p:nvSpPr>
@@ -10455,7 +10494,7 @@
       </p:sp>
       <p:sp>
         <p:nvSpPr>
-          <p:cNvPr id="269" name=""/>
+          <p:cNvPr id="270" name=""/>
           <p:cNvSpPr/>
           <p:nvPr/>
         </p:nvSpPr>
@@ -10500,7 +10539,7 @@
       </p:sp>
       <p:sp>
         <p:nvSpPr>
-          <p:cNvPr id="270" name="" descr="{&quot;isTemplate&quot;:true,&quot;type&quot;:&quot;text&quot;}"/>
+          <p:cNvPr id="271" name="" descr="{&quot;isTemplate&quot;:true,&quot;type&quot;:&quot;text&quot;}"/>
           <p:cNvSpPr txBox="1"/>
           <p:nvPr/>
         </p:nvSpPr>
@@ -10537,7 +10576,7 @@
       </p:sp>
       <p:sp>
         <p:nvSpPr>
-          <p:cNvPr id="271" name="" descr="{&quot;isTemplate&quot;:true,&quot;type&quot;:&quot;text&quot;}"/>
+          <p:cNvPr id="272" name="" descr="{&quot;isTemplate&quot;:true,&quot;type&quot;:&quot;text&quot;}"/>
           <p:cNvSpPr txBox="1"/>
           <p:nvPr/>
         </p:nvSpPr>
@@ -10582,7 +10621,7 @@
   <p:cSld>
     <p:spTree>
       <p:nvGrpSpPr>
-        <p:cNvPr id="272" name=""/>
+        <p:cNvPr id="273" name=""/>
         <p:cNvGrpSpPr/>
         <p:nvPr/>
       </p:nvGrpSpPr>
@@ -10596,7 +10635,7 @@
       </p:grpSpPr>
       <p:sp>
         <p:nvSpPr>
-          <p:cNvPr id="273" name=""/>
+          <p:cNvPr id="274" name=""/>
           <p:cNvSpPr/>
           <p:nvPr/>
         </p:nvSpPr>
@@ -10623,7 +10662,7 @@
       </p:sp>
       <p:sp>
         <p:nvSpPr>
-          <p:cNvPr id="274" name="" descr="{&quot;isTemplate&quot;:true,&quot;type&quot;:&quot;text&quot;}"/>
+          <p:cNvPr id="275" name="" descr="{&quot;isTemplate&quot;:true,&quot;type&quot;:&quot;text&quot;}"/>
           <p:cNvSpPr txBox="1"/>
           <p:nvPr/>
         </p:nvSpPr>
@@ -10658,7 +10697,7 @@
       </p:sp>
       <p:sp>
         <p:nvSpPr>
-          <p:cNvPr id="275" name="" descr="{&quot;isTemplate&quot;:true,&quot;type&quot;:&quot;text&quot;}"/>
+          <p:cNvPr id="276" name="" descr="{&quot;isTemplate&quot;:true,&quot;type&quot;:&quot;text&quot;}"/>
           <p:cNvSpPr txBox="1"/>
           <p:nvPr/>
         </p:nvSpPr>
@@ -10693,7 +10732,7 @@
       </p:sp>
       <p:sp>
         <p:nvSpPr>
-          <p:cNvPr id="276" name="" descr="{&quot;isTemplate&quot;:true,&quot;type&quot;:&quot;text&quot;}"/>
+          <p:cNvPr id="277" name="" descr="{&quot;isTemplate&quot;:true,&quot;type&quot;:&quot;text&quot;}"/>
           <p:cNvSpPr txBox="1"/>
           <p:nvPr/>
         </p:nvSpPr>
@@ -10730,7 +10769,7 @@
       </p:sp>
       <p:sp>
         <p:nvSpPr>
-          <p:cNvPr id="277" name=""/>
+          <p:cNvPr id="278" name=""/>
           <p:cNvSpPr/>
           <p:nvPr/>
         </p:nvSpPr>
@@ -10761,7 +10800,7 @@
       </p:sp>
       <p:pic>
         <p:nvPicPr>
-          <p:cNvPr id="278" name=""/>
+          <p:cNvPr id="279" name=""/>
           <p:cNvPicPr>
             <a:picLocks noChangeAspect="1"/>
           </p:cNvPicPr>
@@ -10796,7 +10835,7 @@
       </p:pic>
       <p:sp>
         <p:nvSpPr>
-          <p:cNvPr id="279" name="" descr="{&quot;isTemplate&quot;:true,&quot;type&quot;:&quot;text&quot;}"/>
+          <p:cNvPr id="280" name="" descr="{&quot;isTemplate&quot;:true,&quot;type&quot;:&quot;text&quot;}"/>
           <p:cNvSpPr txBox="1"/>
           <p:nvPr/>
         </p:nvSpPr>
@@ -10835,7 +10874,7 @@
       </p:sp>
       <p:sp>
         <p:nvSpPr>
-          <p:cNvPr id="280" name="" descr="{&quot;isTemplate&quot;:true,&quot;type&quot;:&quot;text&quot;}"/>
+          <p:cNvPr id="281" name="" descr="{&quot;isTemplate&quot;:true,&quot;type&quot;:&quot;text&quot;}"/>
           <p:cNvSpPr txBox="1"/>
           <p:nvPr/>
         </p:nvSpPr>
@@ -10872,7 +10911,7 @@
       </p:sp>
       <p:sp>
         <p:nvSpPr>
-          <p:cNvPr id="281" name="" descr="{&quot;isTemplate&quot;:true,&quot;type&quot;:&quot;text&quot;}"/>
+          <p:cNvPr id="282" name="" descr="{&quot;isTemplate&quot;:true,&quot;type&quot;:&quot;text&quot;}"/>
           <p:cNvSpPr txBox="1"/>
           <p:nvPr/>
         </p:nvSpPr>
@@ -10907,7 +10946,7 @@
       </p:sp>
       <p:sp>
         <p:nvSpPr>
-          <p:cNvPr id="282" name="" descr="{&quot;isTemplate&quot;:true,&quot;type&quot;:&quot;text&quot;}"/>
+          <p:cNvPr id="283" name="" descr="{&quot;isTemplate&quot;:true,&quot;type&quot;:&quot;text&quot;}"/>
           <p:cNvSpPr txBox="1"/>
           <p:nvPr/>
         </p:nvSpPr>
@@ -10942,7 +10981,7 @@
       </p:sp>
       <p:sp>
         <p:nvSpPr>
-          <p:cNvPr id="283" name="" descr="{&quot;isTemplate&quot;:true,&quot;type&quot;:&quot;text&quot;}"/>
+          <p:cNvPr id="284" name="" descr="{&quot;isTemplate&quot;:true,&quot;type&quot;:&quot;text&quot;}"/>
           <p:cNvSpPr txBox="1"/>
           <p:nvPr/>
         </p:nvSpPr>
@@ -10981,7 +11020,7 @@
       </p:sp>
       <p:sp>
         <p:nvSpPr>
-          <p:cNvPr id="284" name="" descr="{&quot;isTemplate&quot;:true,&quot;type&quot;:&quot;text&quot;}"/>
+          <p:cNvPr id="285" name="" descr="{&quot;isTemplate&quot;:true,&quot;type&quot;:&quot;text&quot;}"/>
           <p:cNvSpPr txBox="1"/>
           <p:nvPr/>
         </p:nvSpPr>
@@ -11018,7 +11057,7 @@
       </p:sp>
       <p:sp>
         <p:nvSpPr>
-          <p:cNvPr id="285" name=""/>
+          <p:cNvPr id="286" name=""/>
           <p:cNvSpPr/>
           <p:nvPr/>
         </p:nvSpPr>
@@ -11063,7 +11102,7 @@
       </p:sp>
       <p:sp>
         <p:nvSpPr>
-          <p:cNvPr id="286" name="" descr="{&quot;isTemplate&quot;:true,&quot;type&quot;:&quot;text&quot;}"/>
+          <p:cNvPr id="287" name="" descr="{&quot;isTemplate&quot;:true,&quot;type&quot;:&quot;text&quot;}"/>
           <p:cNvSpPr txBox="1"/>
           <p:nvPr/>
         </p:nvSpPr>
@@ -11098,7 +11137,7 @@
       </p:sp>
       <p:sp>
         <p:nvSpPr>
-          <p:cNvPr id="287" name="" descr="{&quot;isTemplate&quot;:true,&quot;type&quot;:&quot;text&quot;}"/>
+          <p:cNvPr id="288" name="" descr="{&quot;isTemplate&quot;:true,&quot;type&quot;:&quot;text&quot;}"/>
           <p:cNvSpPr txBox="1"/>
           <p:nvPr/>
         </p:nvSpPr>
@@ -11135,7 +11174,7 @@
       </p:sp>
       <p:sp>
         <p:nvSpPr>
-          <p:cNvPr id="288" name=""/>
+          <p:cNvPr id="289" name=""/>
           <p:cNvSpPr/>
           <p:nvPr/>
         </p:nvSpPr>
@@ -11180,7 +11219,7 @@
       </p:sp>
       <p:sp>
         <p:nvSpPr>
-          <p:cNvPr id="289" name="" descr="{&quot;isTemplate&quot;:true,&quot;type&quot;:&quot;text&quot;}"/>
+          <p:cNvPr id="290" name="" descr="{&quot;isTemplate&quot;:true,&quot;type&quot;:&quot;text&quot;}"/>
           <p:cNvSpPr txBox="1"/>
           <p:nvPr/>
         </p:nvSpPr>
@@ -11215,7 +11254,7 @@
       </p:sp>
       <p:sp>
         <p:nvSpPr>
-          <p:cNvPr id="290" name="" descr="{&quot;isTemplate&quot;:true,&quot;type&quot;:&quot;text&quot;}"/>
+          <p:cNvPr id="291" name="" descr="{&quot;isTemplate&quot;:true,&quot;type&quot;:&quot;text&quot;}"/>
           <p:cNvSpPr txBox="1"/>
           <p:nvPr/>
         </p:nvSpPr>
@@ -11252,7 +11291,7 @@
       </p:sp>
       <p:sp>
         <p:nvSpPr>
-          <p:cNvPr id="291" name="" descr="{&quot;isTemplate&quot;:true,&quot;type&quot;:&quot;text&quot;}"/>
+          <p:cNvPr id="292" name="" descr="{&quot;isTemplate&quot;:true,&quot;type&quot;:&quot;text&quot;}"/>
           <p:cNvSpPr txBox="1"/>
           <p:nvPr/>
         </p:nvSpPr>
@@ -11287,7 +11326,7 @@
       </p:sp>
       <p:sp>
         <p:nvSpPr>
-          <p:cNvPr id="292" name="" descr="{&quot;isTemplate&quot;:true,&quot;type&quot;:&quot;text&quot;}"/>
+          <p:cNvPr id="293" name="" descr="{&quot;isTemplate&quot;:true,&quot;type&quot;:&quot;text&quot;}"/>
           <p:cNvSpPr txBox="1"/>
           <p:nvPr/>
         </p:nvSpPr>
@@ -11322,7 +11361,7 @@
       </p:sp>
       <p:sp>
         <p:nvSpPr>
-          <p:cNvPr id="293" name="" descr="{&quot;isTemplate&quot;:true,&quot;type&quot;:&quot;text&quot;}"/>
+          <p:cNvPr id="294" name="" descr="{&quot;isTemplate&quot;:true,&quot;type&quot;:&quot;text&quot;}"/>
           <p:cNvSpPr txBox="1"/>
           <p:nvPr/>
         </p:nvSpPr>
@@ -11361,7 +11400,7 @@
       </p:sp>
       <p:sp>
         <p:nvSpPr>
-          <p:cNvPr id="294" name=""/>
+          <p:cNvPr id="295" name=""/>
           <p:cNvSpPr/>
           <p:nvPr/>
         </p:nvSpPr>
@@ -11406,7 +11445,7 @@
       </p:sp>
       <p:sp>
         <p:nvSpPr>
-          <p:cNvPr id="295" name="" descr="{&quot;isTemplate&quot;:true,&quot;type&quot;:&quot;text&quot;}"/>
+          <p:cNvPr id="296" name="" descr="{&quot;isTemplate&quot;:true,&quot;type&quot;:&quot;text&quot;}"/>
           <p:cNvSpPr txBox="1"/>
           <p:nvPr/>
         </p:nvSpPr>
@@ -11443,7 +11482,7 @@
       </p:sp>
       <p:sp>
         <p:nvSpPr>
-          <p:cNvPr id="296" name="" descr="{&quot;isTemplate&quot;:true,&quot;type&quot;:&quot;text&quot;}"/>
+          <p:cNvPr id="297" name="" descr="{&quot;isTemplate&quot;:true,&quot;type&quot;:&quot;text&quot;}"/>
           <p:cNvSpPr txBox="1"/>
           <p:nvPr/>
         </p:nvSpPr>
@@ -11488,7 +11527,7 @@
   <p:cSld>
     <p:spTree>
       <p:nvGrpSpPr>
-        <p:cNvPr id="297" name=""/>
+        <p:cNvPr id="298" name=""/>
         <p:cNvGrpSpPr/>
         <p:nvPr/>
       </p:nvGrpSpPr>
@@ -11502,7 +11541,7 @@
       </p:grpSpPr>
       <p:sp>
         <p:nvSpPr>
-          <p:cNvPr id="298" name=""/>
+          <p:cNvPr id="299" name=""/>
           <p:cNvSpPr/>
           <p:nvPr/>
         </p:nvSpPr>
@@ -11529,7 +11568,7 @@
       </p:sp>
       <p:sp>
         <p:nvSpPr>
-          <p:cNvPr id="299" name="" descr="{&quot;isTemplate&quot;:true,&quot;type&quot;:&quot;text&quot;}"/>
+          <p:cNvPr id="300" name="" descr="{&quot;isTemplate&quot;:true,&quot;type&quot;:&quot;text&quot;}"/>
           <p:cNvSpPr txBox="1"/>
           <p:nvPr/>
         </p:nvSpPr>
@@ -11564,7 +11603,7 @@
       </p:sp>
       <p:sp>
         <p:nvSpPr>
-          <p:cNvPr id="300" name="" descr="{&quot;isTemplate&quot;:true,&quot;type&quot;:&quot;text&quot;}"/>
+          <p:cNvPr id="301" name="" descr="{&quot;isTemplate&quot;:true,&quot;type&quot;:&quot;text&quot;}"/>
           <p:cNvSpPr txBox="1"/>
           <p:nvPr/>
         </p:nvSpPr>
@@ -11599,7 +11638,7 @@
       </p:sp>
       <p:sp>
         <p:nvSpPr>
-          <p:cNvPr id="301" name="" descr="{&quot;isTemplate&quot;:true,&quot;type&quot;:&quot;text&quot;}"/>
+          <p:cNvPr id="302" name="" descr="{&quot;isTemplate&quot;:true,&quot;type&quot;:&quot;text&quot;}"/>
           <p:cNvSpPr txBox="1"/>
           <p:nvPr/>
         </p:nvSpPr>
@@ -11636,7 +11675,7 @@
       </p:sp>
       <p:sp>
         <p:nvSpPr>
-          <p:cNvPr id="302" name="" descr="{&quot;isTemplate&quot;:true,&quot;type&quot;:&quot;text&quot;}"/>
+          <p:cNvPr id="303" name="" descr="{&quot;isTemplate&quot;:true,&quot;type&quot;:&quot;text&quot;}"/>
           <p:cNvSpPr txBox="1"/>
           <p:nvPr/>
         </p:nvSpPr>
@@ -11675,7 +11714,7 @@
       </p:sp>
       <p:sp>
         <p:nvSpPr>
-          <p:cNvPr id="303" name=""/>
+          <p:cNvPr id="304" name=""/>
           <p:cNvSpPr/>
           <p:nvPr/>
         </p:nvSpPr>
@@ -11711,7 +11750,7 @@
       </p:sp>
       <p:sp>
         <p:nvSpPr>
-          <p:cNvPr id="304" name="" descr="{&quot;isTemplate&quot;:true,&quot;type&quot;:&quot;text&quot;}"/>
+          <p:cNvPr id="305" name="" descr="{&quot;isTemplate&quot;:true,&quot;type&quot;:&quot;text&quot;}"/>
           <p:cNvSpPr txBox="1"/>
           <p:nvPr/>
         </p:nvSpPr>
@@ -11748,7 +11787,7 @@
       </p:sp>
       <p:sp>
         <p:nvSpPr>
-          <p:cNvPr id="305" name="" descr="{&quot;isTemplate&quot;:true,&quot;type&quot;:&quot;text&quot;}"/>
+          <p:cNvPr id="306" name="" descr="{&quot;isTemplate&quot;:true,&quot;type&quot;:&quot;text&quot;}"/>
           <p:cNvSpPr txBox="1"/>
           <p:nvPr/>
         </p:nvSpPr>
@@ -11783,7 +11822,7 @@
       </p:sp>
       <p:sp>
         <p:nvSpPr>
-          <p:cNvPr id="306" name="" descr="{&quot;isTemplate&quot;:true,&quot;type&quot;:&quot;text&quot;}"/>
+          <p:cNvPr id="307" name="" descr="{&quot;isTemplate&quot;:true,&quot;type&quot;:&quot;text&quot;}"/>
           <p:cNvSpPr txBox="1"/>
           <p:nvPr/>
         </p:nvSpPr>
@@ -11820,7 +11859,7 @@
       </p:sp>
       <p:sp>
         <p:nvSpPr>
-          <p:cNvPr id="307" name="" descr="{&quot;isTemplate&quot;:true,&quot;type&quot;:&quot;text&quot;}"/>
+          <p:cNvPr id="308" name="" descr="{&quot;isTemplate&quot;:true,&quot;type&quot;:&quot;text&quot;}"/>
           <p:cNvSpPr txBox="1"/>
           <p:nvPr/>
         </p:nvSpPr>
@@ -11855,7 +11894,7 @@
       </p:sp>
       <p:sp>
         <p:nvSpPr>
-          <p:cNvPr id="308" name="" descr="{&quot;isTemplate&quot;:true,&quot;type&quot;:&quot;text&quot;}"/>
+          <p:cNvPr id="309" name="" descr="{&quot;isTemplate&quot;:true,&quot;type&quot;:&quot;text&quot;}"/>
           <p:cNvSpPr txBox="1"/>
           <p:nvPr/>
         </p:nvSpPr>
@@ -11890,7 +11929,7 @@
       </p:sp>
       <p:sp>
         <p:nvSpPr>
-          <p:cNvPr id="309" name="" descr="{&quot;isTemplate&quot;:true,&quot;type&quot;:&quot;text&quot;}"/>
+          <p:cNvPr id="310" name="" descr="{&quot;isTemplate&quot;:true,&quot;type&quot;:&quot;text&quot;}"/>
           <p:cNvSpPr txBox="1"/>
           <p:nvPr/>
         </p:nvSpPr>
@@ -11927,7 +11966,7 @@
       </p:sp>
       <p:sp>
         <p:nvSpPr>
-          <p:cNvPr id="310" name="" descr="{&quot;isTemplate&quot;:true,&quot;type&quot;:&quot;text&quot;}"/>
+          <p:cNvPr id="311" name="" descr="{&quot;isTemplate&quot;:true,&quot;type&quot;:&quot;text&quot;}"/>
           <p:cNvSpPr txBox="1"/>
           <p:nvPr/>
         </p:nvSpPr>
@@ -11962,7 +12001,7 @@
       </p:sp>
       <p:sp>
         <p:nvSpPr>
-          <p:cNvPr id="311" name="" descr="{&quot;isTemplate&quot;:true,&quot;type&quot;:&quot;text&quot;}"/>
+          <p:cNvPr id="312" name="" descr="{&quot;isTemplate&quot;:true,&quot;type&quot;:&quot;text&quot;}"/>
           <p:cNvSpPr txBox="1"/>
           <p:nvPr/>
         </p:nvSpPr>
@@ -11999,7 +12038,7 @@
       </p:sp>
       <p:sp>
         <p:nvSpPr>
-          <p:cNvPr id="312" name="" descr="{&quot;isTemplate&quot;:true,&quot;type&quot;:&quot;text&quot;}"/>
+          <p:cNvPr id="313" name="" descr="{&quot;isTemplate&quot;:true,&quot;type&quot;:&quot;text&quot;}"/>
           <p:cNvSpPr txBox="1"/>
           <p:nvPr/>
         </p:nvSpPr>
@@ -12034,7 +12073,7 @@
       </p:sp>
       <p:sp>
         <p:nvSpPr>
-          <p:cNvPr id="313" name="" descr="{&quot;isTemplate&quot;:true,&quot;type&quot;:&quot;text&quot;}"/>
+          <p:cNvPr id="314" name="" descr="{&quot;isTemplate&quot;:true,&quot;type&quot;:&quot;text&quot;}"/>
           <p:cNvSpPr txBox="1"/>
           <p:nvPr/>
         </p:nvSpPr>
@@ -12071,7 +12110,7 @@
       </p:sp>
       <p:sp>
         <p:nvSpPr>
-          <p:cNvPr id="314" name=""/>
+          <p:cNvPr id="315" name=""/>
           <p:cNvSpPr/>
           <p:nvPr/>
         </p:nvSpPr>
@@ -12102,7 +12141,7 @@
       </p:sp>
       <p:pic>
         <p:nvPicPr>
-          <p:cNvPr id="315" name=""/>
+          <p:cNvPr id="316" name=""/>
           <p:cNvPicPr>
             <a:picLocks noChangeAspect="1"/>
           </p:cNvPicPr>
@@ -12130,7 +12169,7 @@
       </p:pic>
       <p:sp>
         <p:nvSpPr>
-          <p:cNvPr id="316" name="" descr="{&quot;isTemplate&quot;:true,&quot;type&quot;:&quot;text&quot;}"/>
+          <p:cNvPr id="317" name="" descr="{&quot;isTemplate&quot;:true,&quot;type&quot;:&quot;text&quot;}"/>
           <p:cNvSpPr txBox="1"/>
           <p:nvPr/>
         </p:nvSpPr>
@@ -12169,7 +12208,7 @@
       </p:sp>
       <p:sp>
         <p:nvSpPr>
-          <p:cNvPr id="317" name=""/>
+          <p:cNvPr id="318" name=""/>
           <p:cNvSpPr/>
           <p:nvPr/>
         </p:nvSpPr>
@@ -12214,7 +12253,7 @@
       </p:sp>
       <p:sp>
         <p:nvSpPr>
-          <p:cNvPr id="318" name="" descr="{&quot;isTemplate&quot;:true,&quot;type&quot;:&quot;text&quot;}"/>
+          <p:cNvPr id="319" name="" descr="{&quot;isTemplate&quot;:true,&quot;type&quot;:&quot;text&quot;}"/>
           <p:cNvSpPr txBox="1"/>
           <p:nvPr/>
         </p:nvSpPr>
@@ -12251,7 +12290,7 @@
       </p:sp>
       <p:sp>
         <p:nvSpPr>
-          <p:cNvPr id="319" name="" descr="{&quot;isTemplate&quot;:true,&quot;type&quot;:&quot;text&quot;}"/>
+          <p:cNvPr id="320" name="" descr="{&quot;isTemplate&quot;:true,&quot;type&quot;:&quot;text&quot;}"/>
           <p:cNvSpPr txBox="1"/>
           <p:nvPr/>
         </p:nvSpPr>

</xml_diff>